<commit_message>
Plot the 2s10s distribution, and cut the deck references
</commit_message>
<xml_diff>
--- a/JGB_2s10s_Steepener.pptx
+++ b/JGB_2s10s_Steepener.pptx
@@ -1816,6 +1816,365 @@
 </file>
 
 <file path=ppt/charts/chart2.xml><?xml version="1.0" encoding="utf-8"?>
+<c:chartSpace xmlns:c="http://schemas.openxmlformats.org/drawingml/2006/chart" xmlns:a="http://schemas.openxmlformats.org/drawingml/2006/main" xmlns:r="http://schemas.openxmlformats.org/officeDocument/2006/relationships">
+  <c:date1904 val="0"/>
+  <c:chart>
+    <c:autoTitleDeleted val="1"/>
+    <c:plotArea>
+      <c:barChart>
+        <c:barDir val="col"/>
+        <c:grouping val="clustered"/>
+        <c:ser>
+          <c:idx val="0"/>
+          <c:order val="0"/>
+          <c:tx>
+            <c:strRef>
+              <c:f>Sheet1!$B$1</c:f>
+              <c:strCache>
+                <c:ptCount val="1"/>
+                <c:pt idx="0">
+                  <c:v>s</c:v>
+                </c:pt>
+              </c:strCache>
+            </c:strRef>
+          </c:tx>
+          <c:spPr>
+            <a:ln>
+              <a:noFill/>
+            </a:ln>
+          </c:spPr>
+          <c:dPt>
+            <c:idx val="0"/>
+            <c:spPr>
+              <a:solidFill>
+                <a:srgbClr val="D7D8D6"/>
+              </a:solidFill>
+            </c:spPr>
+          </c:dPt>
+          <c:dPt>
+            <c:idx val="1"/>
+            <c:spPr>
+              <a:solidFill>
+                <a:srgbClr val="D7D8D6"/>
+              </a:solidFill>
+            </c:spPr>
+          </c:dPt>
+          <c:dPt>
+            <c:idx val="2"/>
+            <c:spPr>
+              <a:solidFill>
+                <a:srgbClr val="D7D8D6"/>
+              </a:solidFill>
+            </c:spPr>
+          </c:dPt>
+          <c:dPt>
+            <c:idx val="3"/>
+            <c:spPr>
+              <a:solidFill>
+                <a:srgbClr val="D7D8D6"/>
+              </a:solidFill>
+            </c:spPr>
+          </c:dPt>
+          <c:dPt>
+            <c:idx val="4"/>
+            <c:spPr>
+              <a:solidFill>
+                <a:srgbClr val="D7D8D6"/>
+              </a:solidFill>
+            </c:spPr>
+          </c:dPt>
+          <c:dPt>
+            <c:idx val="5"/>
+            <c:spPr>
+              <a:solidFill>
+                <a:srgbClr val="D7D8D6"/>
+              </a:solidFill>
+            </c:spPr>
+          </c:dPt>
+          <c:dPt>
+            <c:idx val="6"/>
+            <c:spPr>
+              <a:solidFill>
+                <a:srgbClr val="D7D8D6"/>
+              </a:solidFill>
+            </c:spPr>
+          </c:dPt>
+          <c:dPt>
+            <c:idx val="7"/>
+            <c:spPr>
+              <a:solidFill>
+                <a:srgbClr val="D7D8D6"/>
+              </a:solidFill>
+            </c:spPr>
+          </c:dPt>
+          <c:dPt>
+            <c:idx val="8"/>
+            <c:spPr>
+              <a:solidFill>
+                <a:srgbClr val="D7D8D6"/>
+              </a:solidFill>
+            </c:spPr>
+          </c:dPt>
+          <c:dPt>
+            <c:idx val="9"/>
+            <c:spPr>
+              <a:solidFill>
+                <a:srgbClr val="D7D8D6"/>
+              </a:solidFill>
+            </c:spPr>
+          </c:dPt>
+          <c:dPt>
+            <c:idx val="10"/>
+            <c:spPr>
+              <a:solidFill>
+                <a:srgbClr val="D7D8D6"/>
+              </a:solidFill>
+            </c:spPr>
+          </c:dPt>
+          <c:dPt>
+            <c:idx val="11"/>
+            <c:spPr>
+              <a:solidFill>
+                <a:srgbClr val="D7D8D6"/>
+              </a:solidFill>
+            </c:spPr>
+          </c:dPt>
+          <c:dPt>
+            <c:idx val="12"/>
+            <c:spPr>
+              <a:solidFill>
+                <a:srgbClr val="44546A"/>
+              </a:solidFill>
+            </c:spPr>
+          </c:dPt>
+          <c:dPt>
+            <c:idx val="13"/>
+            <c:spPr>
+              <a:solidFill>
+                <a:srgbClr val="DB0011"/>
+              </a:solidFill>
+            </c:spPr>
+          </c:dPt>
+          <c:dPt>
+            <c:idx val="14"/>
+            <c:spPr>
+              <a:solidFill>
+                <a:srgbClr val="DB0011"/>
+              </a:solidFill>
+            </c:spPr>
+          </c:dPt>
+          <c:dPt>
+            <c:idx val="15"/>
+            <c:spPr>
+              <a:solidFill>
+                <a:srgbClr val="DB0011"/>
+              </a:solidFill>
+            </c:spPr>
+          </c:dPt>
+          <c:dPt>
+            <c:idx val="16"/>
+            <c:spPr>
+              <a:solidFill>
+                <a:srgbClr val="DB0011"/>
+              </a:solidFill>
+            </c:spPr>
+          </c:dPt>
+          <c:cat>
+            <c:strRef>
+              <c:f>Sheet1!$A$2:$A$18</c:f>
+              <c:strCache>
+                <c:ptCount val="17"/>
+                <c:pt idx="0">
+                  <c:v>0</c:v>
+                </c:pt>
+                <c:pt idx="1">
+                  <c:v/>
+                </c:pt>
+                <c:pt idx="2">
+                  <c:v>20</c:v>
+                </c:pt>
+                <c:pt idx="3">
+                  <c:v/>
+                </c:pt>
+                <c:pt idx="4">
+                  <c:v>40</c:v>
+                </c:pt>
+                <c:pt idx="5">
+                  <c:v/>
+                </c:pt>
+                <c:pt idx="6">
+                  <c:v>60</c:v>
+                </c:pt>
+                <c:pt idx="7">
+                  <c:v/>
+                </c:pt>
+                <c:pt idx="8">
+                  <c:v>80</c:v>
+                </c:pt>
+                <c:pt idx="9">
+                  <c:v/>
+                </c:pt>
+                <c:pt idx="10">
+                  <c:v>100</c:v>
+                </c:pt>
+                <c:pt idx="11">
+                  <c:v/>
+                </c:pt>
+                <c:pt idx="12">
+                  <c:v>120</c:v>
+                </c:pt>
+                <c:pt idx="13">
+                  <c:v/>
+                </c:pt>
+                <c:pt idx="14">
+                  <c:v>140</c:v>
+                </c:pt>
+                <c:pt idx="15">
+                  <c:v/>
+                </c:pt>
+                <c:pt idx="16">
+                  <c:v>160</c:v>
+                </c:pt>
+              </c:strCache>
+            </c:strRef>
+          </c:cat>
+          <c:val>
+            <c:numRef>
+              <c:f>Sheet1!$B$2:$B$18</c:f>
+              <c:numCache>
+                <c:formatCode>General</c:formatCode>
+                <c:ptCount val="17"/>
+                <c:pt idx="0">
+                  <c:v>2.1</c:v>
+                </c:pt>
+                <c:pt idx="1">
+                  <c:v>12.9</c:v>
+                </c:pt>
+                <c:pt idx="2">
+                  <c:v>9.2</c:v>
+                </c:pt>
+                <c:pt idx="3">
+                  <c:v>5.2</c:v>
+                </c:pt>
+                <c:pt idx="4">
+                  <c:v>4.9</c:v>
+                </c:pt>
+                <c:pt idx="5">
+                  <c:v>7.4</c:v>
+                </c:pt>
+                <c:pt idx="6">
+                  <c:v>5.9</c:v>
+                </c:pt>
+                <c:pt idx="7">
+                  <c:v>8.0</c:v>
+                </c:pt>
+                <c:pt idx="8">
+                  <c:v>9.0</c:v>
+                </c:pt>
+                <c:pt idx="9">
+                  <c:v>5.7</c:v>
+                </c:pt>
+                <c:pt idx="10">
+                  <c:v>6.1</c:v>
+                </c:pt>
+                <c:pt idx="11">
+                  <c:v>6.8</c:v>
+                </c:pt>
+                <c:pt idx="12">
+                  <c:v>10.2</c:v>
+                </c:pt>
+                <c:pt idx="13">
+                  <c:v>5.0</c:v>
+                </c:pt>
+                <c:pt idx="14">
+                  <c:v>0.9</c:v>
+                </c:pt>
+                <c:pt idx="15">
+                  <c:v>0.1</c:v>
+                </c:pt>
+                <c:pt idx="16">
+                  <c:v>0.5</c:v>
+                </c:pt>
+              </c:numCache>
+            </c:numRef>
+          </c:val>
+        </c:ser>
+        <c:gapWidth val="18"/>
+        <c:axId val="-2068027336"/>
+        <c:axId val="-2113994440"/>
+      </c:barChart>
+      <c:catAx>
+        <c:axId val="-2068027336"/>
+        <c:scaling>
+          <c:orientation val="minMax"/>
+        </c:scaling>
+        <c:delete val="0"/>
+        <c:axPos val="b"/>
+        <c:majorTickMark val="none"/>
+        <c:minorTickMark val="none"/>
+        <c:tickLblPos val="nextTo"/>
+        <c:spPr>
+          <a:ln w="9525">
+            <a:solidFill>
+              <a:srgbClr val="000000"/>
+            </a:solidFill>
+          </a:ln>
+        </c:spPr>
+        <c:txPr>
+          <a:bodyPr/>
+          <a:lstStyle/>
+          <a:p>
+            <a:pPr>
+              <a:defRPr sz="700">
+                <a:solidFill>
+                  <a:srgbClr val="000000"/>
+                </a:solidFill>
+                <a:latin typeface="Arial"/>
+              </a:defRPr>
+            </a:pPr>
+          </a:p>
+        </c:txPr>
+        <c:crossAx val="-2113994440"/>
+        <c:crosses val="autoZero"/>
+        <c:auto val="1"/>
+        <c:lblAlgn val="ctr"/>
+        <c:lblOffset val="100"/>
+        <c:noMultiLvlLbl val="0"/>
+      </c:catAx>
+      <c:valAx>
+        <c:axId val="-2113994440"/>
+        <c:scaling>
+          <c:max val="14.0"/>
+          <c:min val="0.0"/>
+        </c:scaling>
+        <c:delete/>
+        <c:axPos val="l"/>
+        <c:majorTickMark val="out"/>
+        <c:minorTickMark val="none"/>
+        <c:tickLblPos val="nextTo"/>
+        <c:crossAx val="-2068027336"/>
+        <c:crosses val="autoZero"/>
+      </c:valAx>
+    </c:plotArea>
+    <c:dispBlanksAs val="gap"/>
+  </c:chart>
+  <c:txPr>
+    <a:bodyPr/>
+    <a:lstStyle/>
+    <a:p>
+      <a:pPr>
+        <a:defRPr sz="1800"/>
+      </a:pPr>
+      <a:endParaRPr lang="en-US"/>
+    </a:p>
+  </c:txPr>
+  <c:externalData r:id="rId1">
+    <c:autoUpdate val="0"/>
+  </c:externalData>
+</c:chartSpace>
+</file>
+
+<file path=ppt/charts/chart3.xml><?xml version="1.0" encoding="utf-8"?>
 <c:chartSpace xmlns:c="http://schemas.openxmlformats.org/drawingml/2006/chart" xmlns:a="http://schemas.openxmlformats.org/drawingml/2006/main" xmlns:r="http://schemas.openxmlformats.org/officeDocument/2006/relationships">
   <c:date1904 val="0"/>
   <c:chart>
@@ -5095,48 +5454,6 @@
       </p:sp>
       <p:sp>
         <p:nvSpPr>
-          <p:cNvPr id="3" name="TextBox 2"/>
-          <p:cNvSpPr txBox="1"/>
-          <p:nvPr/>
-        </p:nvSpPr>
-        <p:spPr>
-          <a:xfrm>
-            <a:off x="8412480" y="347472"/>
-            <a:ext cx="3310128" cy="219456"/>
-          </a:xfrm>
-          <a:prstGeom prst="rect">
-            <a:avLst/>
-          </a:prstGeom>
-          <a:noFill/>
-        </p:spPr>
-        <p:txBody>
-          <a:bodyPr wrap="none" lIns="0" rIns="0" tIns="0" bIns="0" anchor="t">
-            <a:spAutoFit/>
-          </a:bodyPr>
-          <a:lstStyle/>
-          <a:p>
-            <a:pPr algn="r">
-              <a:lnSpc>
-                <a:spcPct val="100000"/>
-              </a:lnSpc>
-              <a:spcAft>
-                <a:spcPts val="0"/>
-              </a:spcAft>
-            </a:pPr>
-            <a:r>
-              <a:rPr sz="950" b="0" i="1">
-                <a:solidFill>
-                  <a:srgbClr val="767576"/>
-                </a:solidFill>
-                <a:latin typeface="Arial"/>
-              </a:rPr>
-              <a:t>Trade 2 of 3 · rates · 30% of the risk budget</a:t>
-            </a:r>
-          </a:p>
-        </p:txBody>
-      </p:sp>
-      <p:sp>
-        <p:nvSpPr>
           <p:cNvPr id="4" name="TextBox 3"/>
           <p:cNvSpPr txBox="1"/>
           <p:nvPr/>
@@ -5862,7 +6179,7 @@
                 </a:solidFill>
                 <a:latin typeface="Arial"/>
               </a:rPr>
-              <a:t>Exhibit 5. 2s10s has 35bp of room. 2s30s has 12bp, and the round trip takes a third of it</a:t>
+              <a:t>Exhibit 5. The curve has been steeper than this in 7% of the last 26 years</a:t>
             </a:r>
           </a:p>
         </p:txBody>
@@ -5904,287 +6221,39 @@
                 </a:solidFill>
                 <a:latin typeface="Arial"/>
               </a:rPr>
-              <a:t>Slope vs its own range since 2000, bp</a:t>
-            </a:r>
-          </a:p>
-        </p:txBody>
-      </p:sp>
-      <p:cxnSp>
-        <p:nvCxnSpPr>
-          <p:cNvPr id="23" name="Connector 22"/>
-          <p:cNvCxnSpPr/>
+              <a:t>JGB 2s10s, weekly closes since 2000, % of weeks per 10bp bin</a:t>
+            </a:r>
+          </a:p>
+        </p:txBody>
+      </p:sp>
+      <p:graphicFrame>
+        <p:nvGraphicFramePr>
+          <p:cNvPr id="23" name="Chart 22"/>
+          <p:cNvGraphicFramePr>
+            <a:graphicFrameLocks noGrp="1"/>
+          </p:cNvGraphicFramePr>
           <p:nvPr/>
-        </p:nvCxnSpPr>
+        </p:nvGraphicFramePr>
+        <p:xfrm>
+          <a:off x="4078224" y="1700784"/>
+          <a:ext cx="4169664" cy="1572768"/>
+        </p:xfrm>
+        <a:graphic>
+          <a:graphicData uri="http://schemas.openxmlformats.org/drawingml/2006/chart">
+            <c:chart xmlns:c="http://schemas.openxmlformats.org/drawingml/2006/chart" r:id="rId3"/>
+          </a:graphicData>
+        </a:graphic>
+      </p:graphicFrame>
+      <p:sp>
+        <p:nvSpPr>
+          <p:cNvPr id="24" name="TextBox 23"/>
+          <p:cNvSpPr txBox="1"/>
+          <p:nvPr/>
+        </p:nvSpPr>
         <p:spPr>
           <a:xfrm>
-            <a:off x="5093207" y="1755648"/>
-            <a:ext cx="0" cy="1316736"/>
-          </a:xfrm>
-          <a:prstGeom prst="line">
-            <a:avLst/>
-          </a:prstGeom>
-          <a:ln w="6350">
-            <a:solidFill>
-              <a:srgbClr val="D0CECE"/>
-            </a:solidFill>
-          </a:ln>
-        </p:spPr>
-        <p:style>
-          <a:lnRef idx="2">
-            <a:schemeClr val="accent1"/>
-          </a:lnRef>
-          <a:fillRef idx="0">
-            <a:schemeClr val="accent1"/>
-          </a:fillRef>
-          <a:effectRef idx="1">
-            <a:schemeClr val="accent1"/>
-          </a:effectRef>
-          <a:fontRef idx="minor">
-            <a:schemeClr val="tx1"/>
-          </a:fontRef>
-        </p:style>
-      </p:cxnSp>
-      <p:cxnSp>
-        <p:nvCxnSpPr>
-          <p:cNvPr id="24" name="Connector 23"/>
-          <p:cNvCxnSpPr/>
-          <p:nvPr/>
-        </p:nvCxnSpPr>
-        <p:spPr>
-          <a:xfrm>
-            <a:off x="5806440" y="1755648"/>
-            <a:ext cx="0" cy="1316736"/>
-          </a:xfrm>
-          <a:prstGeom prst="line">
-            <a:avLst/>
-          </a:prstGeom>
-          <a:ln w="6350">
-            <a:solidFill>
-              <a:srgbClr val="D0CECE"/>
-            </a:solidFill>
-          </a:ln>
-        </p:spPr>
-        <p:style>
-          <a:lnRef idx="2">
-            <a:schemeClr val="accent1"/>
-          </a:lnRef>
-          <a:fillRef idx="0">
-            <a:schemeClr val="accent1"/>
-          </a:fillRef>
-          <a:effectRef idx="1">
-            <a:schemeClr val="accent1"/>
-          </a:effectRef>
-          <a:fontRef idx="minor">
-            <a:schemeClr val="tx1"/>
-          </a:fontRef>
-        </p:style>
-      </p:cxnSp>
-      <p:cxnSp>
-        <p:nvCxnSpPr>
-          <p:cNvPr id="25" name="Connector 24"/>
-          <p:cNvCxnSpPr/>
-          <p:nvPr/>
-        </p:nvCxnSpPr>
-        <p:spPr>
-          <a:xfrm>
-            <a:off x="6519672" y="1755648"/>
-            <a:ext cx="0" cy="1316736"/>
-          </a:xfrm>
-          <a:prstGeom prst="line">
-            <a:avLst/>
-          </a:prstGeom>
-          <a:ln w="6350">
-            <a:solidFill>
-              <a:srgbClr val="D0CECE"/>
-            </a:solidFill>
-          </a:ln>
-        </p:spPr>
-        <p:style>
-          <a:lnRef idx="2">
-            <a:schemeClr val="accent1"/>
-          </a:lnRef>
-          <a:fillRef idx="0">
-            <a:schemeClr val="accent1"/>
-          </a:fillRef>
-          <a:effectRef idx="1">
-            <a:schemeClr val="accent1"/>
-          </a:effectRef>
-          <a:fontRef idx="minor">
-            <a:schemeClr val="tx1"/>
-          </a:fontRef>
-        </p:style>
-      </p:cxnSp>
-      <p:cxnSp>
-        <p:nvCxnSpPr>
-          <p:cNvPr id="26" name="Connector 25"/>
-          <p:cNvCxnSpPr/>
-          <p:nvPr/>
-        </p:nvCxnSpPr>
-        <p:spPr>
-          <a:xfrm>
-            <a:off x="7232904" y="1755648"/>
-            <a:ext cx="0" cy="1316736"/>
-          </a:xfrm>
-          <a:prstGeom prst="line">
-            <a:avLst/>
-          </a:prstGeom>
-          <a:ln w="6350">
-            <a:solidFill>
-              <a:srgbClr val="D0CECE"/>
-            </a:solidFill>
-          </a:ln>
-        </p:spPr>
-        <p:style>
-          <a:lnRef idx="2">
-            <a:schemeClr val="accent1"/>
-          </a:lnRef>
-          <a:fillRef idx="0">
-            <a:schemeClr val="accent1"/>
-          </a:fillRef>
-          <a:effectRef idx="1">
-            <a:schemeClr val="accent1"/>
-          </a:effectRef>
-          <a:fontRef idx="minor">
-            <a:schemeClr val="tx1"/>
-          </a:fontRef>
-        </p:style>
-      </p:cxnSp>
-      <p:sp>
-        <p:nvSpPr>
-          <p:cNvPr id="27" name="Rectangle 26"/>
-          <p:cNvSpPr/>
-          <p:nvPr/>
-        </p:nvSpPr>
-        <p:spPr>
-          <a:xfrm>
-            <a:off x="5118567" y="1897380"/>
-            <a:ext cx="1281440" cy="155448"/>
-          </a:xfrm>
-          <a:prstGeom prst="rect">
-            <a:avLst/>
-          </a:prstGeom>
-          <a:solidFill>
-            <a:srgbClr val="D7D8D6"/>
-          </a:solidFill>
-          <a:ln>
-            <a:noFill/>
-          </a:ln>
-          <a:effectLst/>
-        </p:spPr>
-        <p:style>
-          <a:lnRef idx="1">
-            <a:schemeClr val="accent1"/>
-          </a:lnRef>
-          <a:fillRef idx="3">
-            <a:schemeClr val="accent1"/>
-          </a:fillRef>
-          <a:effectRef idx="2">
-            <a:schemeClr val="accent1"/>
-          </a:effectRef>
-          <a:fontRef idx="minor">
-            <a:schemeClr val="lt1"/>
-          </a:fontRef>
-        </p:style>
-        <p:txBody>
-          <a:bodyPr rtlCol="0" anchor="ctr"/>
-          <a:lstStyle/>
-          <a:p/>
-        </p:txBody>
-      </p:sp>
-      <p:sp>
-        <p:nvSpPr>
-          <p:cNvPr id="28" name="Rectangle 27"/>
-          <p:cNvSpPr/>
-          <p:nvPr/>
-        </p:nvSpPr>
-        <p:spPr>
-          <a:xfrm>
-            <a:off x="5649772" y="1860804"/>
-            <a:ext cx="20116" cy="228600"/>
-          </a:xfrm>
-          <a:prstGeom prst="rect">
-            <a:avLst/>
-          </a:prstGeom>
-          <a:solidFill>
-            <a:srgbClr val="44546A"/>
-          </a:solidFill>
-          <a:ln>
-            <a:noFill/>
-          </a:ln>
-          <a:effectLst/>
-        </p:spPr>
-        <p:style>
-          <a:lnRef idx="1">
-            <a:schemeClr val="accent1"/>
-          </a:lnRef>
-          <a:fillRef idx="3">
-            <a:schemeClr val="accent1"/>
-          </a:fillRef>
-          <a:effectRef idx="2">
-            <a:schemeClr val="accent1"/>
-          </a:effectRef>
-          <a:fontRef idx="minor">
-            <a:schemeClr val="lt1"/>
-          </a:fontRef>
-        </p:style>
-        <p:txBody>
-          <a:bodyPr rtlCol="0" anchor="ctr"/>
-          <a:lstStyle/>
-          <a:p/>
-        </p:txBody>
-      </p:sp>
-      <p:sp>
-        <p:nvSpPr>
-          <p:cNvPr id="29" name="Rectangle 28"/>
-          <p:cNvSpPr/>
-          <p:nvPr/>
-        </p:nvSpPr>
-        <p:spPr>
-          <a:xfrm>
-            <a:off x="6093073" y="1833372"/>
-            <a:ext cx="51206" cy="283464"/>
-          </a:xfrm>
-          <a:prstGeom prst="rect">
-            <a:avLst/>
-          </a:prstGeom>
-          <a:solidFill>
-            <a:srgbClr val="DB0011"/>
-          </a:solidFill>
-          <a:ln>
-            <a:noFill/>
-          </a:ln>
-          <a:effectLst/>
-        </p:spPr>
-        <p:style>
-          <a:lnRef idx="1">
-            <a:schemeClr val="accent1"/>
-          </a:lnRef>
-          <a:fillRef idx="3">
-            <a:schemeClr val="accent1"/>
-          </a:fillRef>
-          <a:effectRef idx="2">
-            <a:schemeClr val="accent1"/>
-          </a:effectRef>
-          <a:fontRef idx="minor">
-            <a:schemeClr val="lt1"/>
-          </a:fontRef>
-        </p:style>
-        <p:txBody>
-          <a:bodyPr rtlCol="0" anchor="ctr"/>
-          <a:lstStyle/>
-          <a:p/>
-        </p:txBody>
-      </p:sp>
-      <p:sp>
-        <p:nvSpPr>
-          <p:cNvPr id="30" name="TextBox 29"/>
-          <p:cNvSpPr txBox="1"/>
-          <p:nvPr/>
-        </p:nvSpPr>
-        <p:spPr>
-          <a:xfrm>
-            <a:off x="4133087" y="1869948"/>
-            <a:ext cx="868680" cy="210312"/>
+            <a:off x="4133087" y="3310128"/>
+            <a:ext cx="4059936" cy="384048"/>
           </a:xfrm>
           <a:prstGeom prst="rect">
             <a:avLst/>
@@ -6192,951 +6261,34 @@
           <a:noFill/>
         </p:spPr>
         <p:txBody>
-          <a:bodyPr wrap="none" lIns="0" rIns="0" tIns="0" bIns="0" anchor="t">
+          <a:bodyPr wrap="square" lIns="0" rIns="0" tIns="0" bIns="0" anchor="t">
             <a:spAutoFit/>
           </a:bodyPr>
           <a:lstStyle/>
           <a:p>
-            <a:pPr algn="l">
+            <a:pPr algn="ctr">
               <a:lnSpc>
-                <a:spcPct val="100000"/>
+                <a:spcPct val="114000"/>
               </a:lnSpc>
               <a:spcAft>
                 <a:spcPts val="0"/>
               </a:spcAft>
             </a:pPr>
             <a:r>
-              <a:rPr sz="1000" b="1" i="0">
-                <a:solidFill>
-                  <a:srgbClr val="000000"/>
-                </a:solidFill>
-                <a:latin typeface="Arial"/>
-              </a:rPr>
-              <a:t>JGB 2s10s</a:t>
-            </a:r>
-          </a:p>
-        </p:txBody>
-      </p:sp>
-      <p:sp>
-        <p:nvSpPr>
-          <p:cNvPr id="31" name="TextBox 30"/>
-          <p:cNvSpPr txBox="1"/>
-          <p:nvPr/>
-        </p:nvSpPr>
-        <p:spPr>
-          <a:xfrm>
-            <a:off x="7232904" y="1869948"/>
-            <a:ext cx="923544" cy="210312"/>
-          </a:xfrm>
-          <a:prstGeom prst="rect">
-            <a:avLst/>
-          </a:prstGeom>
-          <a:noFill/>
-        </p:spPr>
-        <p:txBody>
-          <a:bodyPr wrap="none" lIns="0" rIns="0" tIns="0" bIns="0" anchor="t">
-            <a:spAutoFit/>
-          </a:bodyPr>
-          <a:lstStyle/>
-          <a:p>
-            <a:pPr algn="r">
-              <a:lnSpc>
-                <a:spcPct val="100000"/>
-              </a:lnSpc>
-              <a:spcAft>
-                <a:spcPts val="0"/>
-              </a:spcAft>
-            </a:pPr>
-            <a:r>
-              <a:rPr sz="1000" b="1" i="0">
-                <a:solidFill>
-                  <a:srgbClr val="DB0011"/>
-                </a:solidFill>
-                <a:latin typeface="Arial"/>
-              </a:rPr>
-              <a:t>129bp · 93rd</a:t>
-            </a:r>
-          </a:p>
-        </p:txBody>
-      </p:sp>
-      <p:sp>
-        <p:nvSpPr>
-          <p:cNvPr id="32" name="Rectangle 31"/>
-          <p:cNvSpPr/>
-          <p:nvPr/>
-        </p:nvSpPr>
-        <p:spPr>
-          <a:xfrm>
-            <a:off x="5345216" y="2336292"/>
-            <a:ext cx="966825" cy="155448"/>
-          </a:xfrm>
-          <a:prstGeom prst="rect">
-            <a:avLst/>
-          </a:prstGeom>
-          <a:solidFill>
-            <a:srgbClr val="D7D8D6"/>
-          </a:solidFill>
-          <a:ln>
-            <a:noFill/>
-          </a:ln>
-          <a:effectLst/>
-        </p:spPr>
-        <p:style>
-          <a:lnRef idx="1">
-            <a:schemeClr val="accent1"/>
-          </a:lnRef>
-          <a:fillRef idx="3">
-            <a:schemeClr val="accent1"/>
-          </a:fillRef>
-          <a:effectRef idx="2">
-            <a:schemeClr val="accent1"/>
-          </a:effectRef>
-          <a:fontRef idx="minor">
-            <a:schemeClr val="lt1"/>
-          </a:fontRef>
-        </p:style>
-        <p:txBody>
-          <a:bodyPr rtlCol="0" anchor="ctr"/>
-          <a:lstStyle/>
-          <a:p/>
-        </p:txBody>
-      </p:sp>
-      <p:sp>
-        <p:nvSpPr>
-          <p:cNvPr id="33" name="Rectangle 32"/>
-          <p:cNvSpPr/>
-          <p:nvPr/>
-        </p:nvSpPr>
-        <p:spPr>
-          <a:xfrm>
-            <a:off x="5767059" y="2299716"/>
-            <a:ext cx="20116" cy="228600"/>
-          </a:xfrm>
-          <a:prstGeom prst="rect">
-            <a:avLst/>
-          </a:prstGeom>
-          <a:solidFill>
-            <a:srgbClr val="44546A"/>
-          </a:solidFill>
-          <a:ln>
-            <a:noFill/>
-          </a:ln>
-          <a:effectLst/>
-        </p:spPr>
-        <p:style>
-          <a:lnRef idx="1">
-            <a:schemeClr val="accent1"/>
-          </a:lnRef>
-          <a:fillRef idx="3">
-            <a:schemeClr val="accent1"/>
-          </a:fillRef>
-          <a:effectRef idx="2">
-            <a:schemeClr val="accent1"/>
-          </a:effectRef>
-          <a:fontRef idx="minor">
-            <a:schemeClr val="lt1"/>
-          </a:fontRef>
-        </p:style>
-        <p:txBody>
-          <a:bodyPr rtlCol="0" anchor="ctr"/>
-          <a:lstStyle/>
-          <a:p/>
-        </p:txBody>
-      </p:sp>
-      <p:sp>
-        <p:nvSpPr>
-          <p:cNvPr id="34" name="Rectangle 33"/>
-          <p:cNvSpPr/>
-          <p:nvPr/>
-        </p:nvSpPr>
-        <p:spPr>
-          <a:xfrm>
-            <a:off x="6003523" y="2272284"/>
-            <a:ext cx="51206" cy="283464"/>
-          </a:xfrm>
-          <a:prstGeom prst="rect">
-            <a:avLst/>
-          </a:prstGeom>
-          <a:solidFill>
-            <a:srgbClr val="DB0011"/>
-          </a:solidFill>
-          <a:ln>
-            <a:noFill/>
-          </a:ln>
-          <a:effectLst/>
-        </p:spPr>
-        <p:style>
-          <a:lnRef idx="1">
-            <a:schemeClr val="accent1"/>
-          </a:lnRef>
-          <a:fillRef idx="3">
-            <a:schemeClr val="accent1"/>
-          </a:fillRef>
-          <a:effectRef idx="2">
-            <a:schemeClr val="accent1"/>
-          </a:effectRef>
-          <a:fontRef idx="minor">
-            <a:schemeClr val="lt1"/>
-          </a:fontRef>
-        </p:style>
-        <p:txBody>
-          <a:bodyPr rtlCol="0" anchor="ctr"/>
-          <a:lstStyle/>
-          <a:p/>
-        </p:txBody>
-      </p:sp>
-      <p:sp>
-        <p:nvSpPr>
-          <p:cNvPr id="35" name="TextBox 34"/>
-          <p:cNvSpPr txBox="1"/>
-          <p:nvPr/>
-        </p:nvSpPr>
-        <p:spPr>
-          <a:xfrm>
-            <a:off x="4133087" y="2308860"/>
-            <a:ext cx="868680" cy="210312"/>
-          </a:xfrm>
-          <a:prstGeom prst="rect">
-            <a:avLst/>
-          </a:prstGeom>
-          <a:noFill/>
-        </p:spPr>
-        <p:txBody>
-          <a:bodyPr wrap="none" lIns="0" rIns="0" tIns="0" bIns="0" anchor="t">
-            <a:spAutoFit/>
-          </a:bodyPr>
-          <a:lstStyle/>
-          <a:p>
-            <a:pPr algn="l">
-              <a:lnSpc>
-                <a:spcPct val="100000"/>
-              </a:lnSpc>
-              <a:spcAft>
-                <a:spcPts val="0"/>
-              </a:spcAft>
-            </a:pPr>
-            <a:r>
-              <a:rPr sz="1000" b="1" i="0">
-                <a:solidFill>
-                  <a:srgbClr val="000000"/>
-                </a:solidFill>
-                <a:latin typeface="Arial"/>
-              </a:rPr>
-              <a:t>JGB 10s30s</a:t>
-            </a:r>
-          </a:p>
-        </p:txBody>
-      </p:sp>
-      <p:sp>
-        <p:nvSpPr>
-          <p:cNvPr id="36" name="TextBox 35"/>
-          <p:cNvSpPr txBox="1"/>
-          <p:nvPr/>
-        </p:nvSpPr>
-        <p:spPr>
-          <a:xfrm>
-            <a:off x="7232904" y="2308860"/>
-            <a:ext cx="923544" cy="210312"/>
-          </a:xfrm>
-          <a:prstGeom prst="rect">
-            <a:avLst/>
-          </a:prstGeom>
-          <a:noFill/>
-        </p:spPr>
-        <p:txBody>
-          <a:bodyPr wrap="none" lIns="0" rIns="0" tIns="0" bIns="0" anchor="t">
-            <a:spAutoFit/>
-          </a:bodyPr>
-          <a:lstStyle/>
-          <a:p>
-            <a:pPr algn="r">
-              <a:lnSpc>
-                <a:spcPct val="100000"/>
-              </a:lnSpc>
-              <a:spcAft>
-                <a:spcPts val="0"/>
-              </a:spcAft>
-            </a:pPr>
-            <a:r>
-              <a:rPr sz="1000" b="1" i="0">
-                <a:solidFill>
-                  <a:srgbClr val="DB0011"/>
-                </a:solidFill>
-                <a:latin typeface="Arial"/>
-              </a:rPr>
-              <a:t>118bp · 94th</a:t>
-            </a:r>
-          </a:p>
-        </p:txBody>
-      </p:sp>
-      <p:sp>
-        <p:nvSpPr>
-          <p:cNvPr id="37" name="Rectangle 36"/>
-          <p:cNvSpPr/>
-          <p:nvPr/>
-        </p:nvSpPr>
-        <p:spPr>
-          <a:xfrm>
-            <a:off x="5427634" y="2775204"/>
-            <a:ext cx="1724436" cy="155448"/>
-          </a:xfrm>
-          <a:prstGeom prst="rect">
-            <a:avLst/>
-          </a:prstGeom>
-          <a:solidFill>
-            <a:srgbClr val="D7D8D6"/>
-          </a:solidFill>
-          <a:ln>
-            <a:noFill/>
-          </a:ln>
-          <a:effectLst/>
-        </p:spPr>
-        <p:style>
-          <a:lnRef idx="1">
-            <a:schemeClr val="accent1"/>
-          </a:lnRef>
-          <a:fillRef idx="3">
-            <a:schemeClr val="accent1"/>
-          </a:fillRef>
-          <a:effectRef idx="2">
-            <a:schemeClr val="accent1"/>
-          </a:effectRef>
-          <a:fontRef idx="minor">
-            <a:schemeClr val="lt1"/>
-          </a:fontRef>
-        </p:style>
-        <p:txBody>
-          <a:bodyPr rtlCol="0" anchor="ctr"/>
-          <a:lstStyle/>
-          <a:p/>
-        </p:txBody>
-      </p:sp>
-      <p:sp>
-        <p:nvSpPr>
-          <p:cNvPr id="38" name="Rectangle 37"/>
-          <p:cNvSpPr/>
-          <p:nvPr/>
-        </p:nvSpPr>
-        <p:spPr>
-          <a:xfrm>
-            <a:off x="6333683" y="2738628"/>
-            <a:ext cx="20116" cy="228600"/>
-          </a:xfrm>
-          <a:prstGeom prst="rect">
-            <a:avLst/>
-          </a:prstGeom>
-          <a:solidFill>
-            <a:srgbClr val="44546A"/>
-          </a:solidFill>
-          <a:ln>
-            <a:noFill/>
-          </a:ln>
-          <a:effectLst/>
-        </p:spPr>
-        <p:style>
-          <a:lnRef idx="1">
-            <a:schemeClr val="accent1"/>
-          </a:lnRef>
-          <a:fillRef idx="3">
-            <a:schemeClr val="accent1"/>
-          </a:fillRef>
-          <a:effectRef idx="2">
-            <a:schemeClr val="accent1"/>
-          </a:effectRef>
-          <a:fontRef idx="minor">
-            <a:schemeClr val="lt1"/>
-          </a:fontRef>
-        </p:style>
-        <p:txBody>
-          <a:bodyPr rtlCol="0" anchor="ctr"/>
-          <a:lstStyle/>
-          <a:p/>
-        </p:txBody>
-      </p:sp>
-      <p:sp>
-        <p:nvSpPr>
-          <p:cNvPr id="39" name="Rectangle 38"/>
-          <p:cNvSpPr/>
-          <p:nvPr/>
-        </p:nvSpPr>
-        <p:spPr>
-          <a:xfrm>
-            <a:off x="7028992" y="2711196"/>
-            <a:ext cx="51206" cy="283464"/>
-          </a:xfrm>
-          <a:prstGeom prst="rect">
-            <a:avLst/>
-          </a:prstGeom>
-          <a:solidFill>
-            <a:srgbClr val="DB0011"/>
-          </a:solidFill>
-          <a:ln>
-            <a:noFill/>
-          </a:ln>
-          <a:effectLst/>
-        </p:spPr>
-        <p:style>
-          <a:lnRef idx="1">
-            <a:schemeClr val="accent1"/>
-          </a:lnRef>
-          <a:fillRef idx="3">
-            <a:schemeClr val="accent1"/>
-          </a:fillRef>
-          <a:effectRef idx="2">
-            <a:schemeClr val="accent1"/>
-          </a:effectRef>
-          <a:fontRef idx="minor">
-            <a:schemeClr val="lt1"/>
-          </a:fontRef>
-        </p:style>
-        <p:txBody>
-          <a:bodyPr rtlCol="0" anchor="ctr"/>
-          <a:lstStyle/>
-          <a:p/>
-        </p:txBody>
-      </p:sp>
-      <p:sp>
-        <p:nvSpPr>
-          <p:cNvPr id="40" name="TextBox 39"/>
-          <p:cNvSpPr txBox="1"/>
-          <p:nvPr/>
-        </p:nvSpPr>
-        <p:spPr>
-          <a:xfrm>
-            <a:off x="4133087" y="2747772"/>
-            <a:ext cx="868680" cy="210312"/>
-          </a:xfrm>
-          <a:prstGeom prst="rect">
-            <a:avLst/>
-          </a:prstGeom>
-          <a:noFill/>
-        </p:spPr>
-        <p:txBody>
-          <a:bodyPr wrap="none" lIns="0" rIns="0" tIns="0" bIns="0" anchor="t">
-            <a:spAutoFit/>
-          </a:bodyPr>
-          <a:lstStyle/>
-          <a:p>
-            <a:pPr algn="l">
-              <a:lnSpc>
-                <a:spcPct val="100000"/>
-              </a:lnSpc>
-              <a:spcAft>
-                <a:spcPts val="0"/>
-              </a:spcAft>
-            </a:pPr>
-            <a:r>
-              <a:rPr sz="1000" b="1" i="0">
-                <a:solidFill>
-                  <a:srgbClr val="000000"/>
-                </a:solidFill>
-                <a:latin typeface="Arial"/>
-              </a:rPr>
-              <a:t>JGB 2s30s</a:t>
-            </a:r>
-          </a:p>
-        </p:txBody>
-      </p:sp>
-      <p:sp>
-        <p:nvSpPr>
-          <p:cNvPr id="41" name="TextBox 40"/>
-          <p:cNvSpPr txBox="1"/>
-          <p:nvPr/>
-        </p:nvSpPr>
-        <p:spPr>
-          <a:xfrm>
-            <a:off x="7232904" y="2747772"/>
-            <a:ext cx="923544" cy="210312"/>
-          </a:xfrm>
-          <a:prstGeom prst="rect">
-            <a:avLst/>
-          </a:prstGeom>
-          <a:noFill/>
-        </p:spPr>
-        <p:txBody>
-          <a:bodyPr wrap="none" lIns="0" rIns="0" tIns="0" bIns="0" anchor="t">
-            <a:spAutoFit/>
-          </a:bodyPr>
-          <a:lstStyle/>
-          <a:p>
-            <a:pPr algn="r">
-              <a:lnSpc>
-                <a:spcPct val="100000"/>
-              </a:lnSpc>
-              <a:spcAft>
-                <a:spcPts val="0"/>
-              </a:spcAft>
-            </a:pPr>
-            <a:r>
-              <a:rPr sz="1000" b="1" i="0">
-                <a:solidFill>
-                  <a:srgbClr val="DB0011"/>
-                </a:solidFill>
-                <a:latin typeface="Arial"/>
-              </a:rPr>
-              <a:t>248bp · 99th</a:t>
-            </a:r>
-          </a:p>
-        </p:txBody>
-      </p:sp>
-      <p:cxnSp>
-        <p:nvCxnSpPr>
-          <p:cNvPr id="42" name="Connector 41"/>
-          <p:cNvCxnSpPr/>
-          <p:nvPr/>
-        </p:nvCxnSpPr>
-        <p:spPr>
-          <a:xfrm>
-            <a:off x="5093207" y="3072384"/>
-            <a:ext cx="2139697" cy="0"/>
-          </a:xfrm>
-          <a:prstGeom prst="line">
-            <a:avLst/>
-          </a:prstGeom>
-          <a:ln w="9525">
-            <a:solidFill>
-              <a:srgbClr val="000000"/>
-            </a:solidFill>
-          </a:ln>
-        </p:spPr>
-        <p:style>
-          <a:lnRef idx="2">
-            <a:schemeClr val="accent1"/>
-          </a:lnRef>
-          <a:fillRef idx="0">
-            <a:schemeClr val="accent1"/>
-          </a:fillRef>
-          <a:effectRef idx="1">
-            <a:schemeClr val="accent1"/>
-          </a:effectRef>
-          <a:fontRef idx="minor">
-            <a:schemeClr val="tx1"/>
-          </a:fontRef>
-        </p:style>
-      </p:cxnSp>
-      <p:sp>
-        <p:nvSpPr>
-          <p:cNvPr id="43" name="TextBox 42"/>
-          <p:cNvSpPr txBox="1"/>
-          <p:nvPr/>
-        </p:nvSpPr>
-        <p:spPr>
-          <a:xfrm>
-            <a:off x="4773168" y="3108960"/>
-            <a:ext cx="640080" cy="182880"/>
-          </a:xfrm>
-          <a:prstGeom prst="rect">
-            <a:avLst/>
-          </a:prstGeom>
-          <a:noFill/>
-        </p:spPr>
-        <p:txBody>
-          <a:bodyPr wrap="none" lIns="0" rIns="0" tIns="0" bIns="0" anchor="t">
-            <a:spAutoFit/>
-          </a:bodyPr>
-          <a:lstStyle/>
-          <a:p>
-            <a:pPr algn="ctr">
-              <a:lnSpc>
-                <a:spcPct val="100000"/>
-              </a:lnSpc>
-              <a:spcAft>
-                <a:spcPts val="0"/>
-              </a:spcAft>
-            </a:pPr>
-            <a:r>
-              <a:rPr sz="850" b="0" i="0">
+              <a:rPr sz="700" b="0" i="0">
                 <a:solidFill>
                   <a:srgbClr val="767576"/>
                 </a:solidFill>
                 <a:latin typeface="Arial"/>
               </a:rPr>
-              <a:t>0</a:t>
-            </a:r>
-          </a:p>
-        </p:txBody>
-      </p:sp>
-      <p:sp>
-        <p:nvSpPr>
-          <p:cNvPr id="44" name="TextBox 43"/>
-          <p:cNvSpPr txBox="1"/>
-          <p:nvPr/>
-        </p:nvSpPr>
-        <p:spPr>
-          <a:xfrm>
-            <a:off x="5486400" y="3108960"/>
-            <a:ext cx="640080" cy="182880"/>
-          </a:xfrm>
-          <a:prstGeom prst="rect">
-            <a:avLst/>
-          </a:prstGeom>
-          <a:noFill/>
-        </p:spPr>
-        <p:txBody>
-          <a:bodyPr wrap="none" lIns="0" rIns="0" tIns="0" bIns="0" anchor="t">
-            <a:spAutoFit/>
-          </a:bodyPr>
-          <a:lstStyle/>
-          <a:p>
-            <a:pPr algn="ctr">
-              <a:lnSpc>
-                <a:spcPct val="100000"/>
-              </a:lnSpc>
-              <a:spcAft>
-                <a:spcPts val="0"/>
-              </a:spcAft>
-            </a:pPr>
-            <a:r>
-              <a:rPr sz="850" b="0" i="0">
-                <a:solidFill>
-                  <a:srgbClr val="767576"/>
-                </a:solidFill>
-                <a:latin typeface="Arial"/>
-              </a:rPr>
-              <a:t>+90</a:t>
-            </a:r>
-          </a:p>
-        </p:txBody>
-      </p:sp>
-      <p:sp>
-        <p:nvSpPr>
-          <p:cNvPr id="45" name="TextBox 44"/>
-          <p:cNvSpPr txBox="1"/>
-          <p:nvPr/>
-        </p:nvSpPr>
-        <p:spPr>
-          <a:xfrm>
-            <a:off x="6199632" y="3108960"/>
-            <a:ext cx="640080" cy="182880"/>
-          </a:xfrm>
-          <a:prstGeom prst="rect">
-            <a:avLst/>
-          </a:prstGeom>
-          <a:noFill/>
-        </p:spPr>
-        <p:txBody>
-          <a:bodyPr wrap="none" lIns="0" rIns="0" tIns="0" bIns="0" anchor="t">
-            <a:spAutoFit/>
-          </a:bodyPr>
-          <a:lstStyle/>
-          <a:p>
-            <a:pPr algn="ctr">
-              <a:lnSpc>
-                <a:spcPct val="100000"/>
-              </a:lnSpc>
-              <a:spcAft>
-                <a:spcPts val="0"/>
-              </a:spcAft>
-            </a:pPr>
-            <a:r>
-              <a:rPr sz="850" b="0" i="0">
-                <a:solidFill>
-                  <a:srgbClr val="767576"/>
-                </a:solidFill>
-                <a:latin typeface="Arial"/>
-              </a:rPr>
-              <a:t>+180</a:t>
-            </a:r>
-          </a:p>
-        </p:txBody>
-      </p:sp>
-      <p:sp>
-        <p:nvSpPr>
-          <p:cNvPr id="46" name="TextBox 45"/>
-          <p:cNvSpPr txBox="1"/>
-          <p:nvPr/>
-        </p:nvSpPr>
-        <p:spPr>
-          <a:xfrm>
-            <a:off x="6912864" y="3108960"/>
-            <a:ext cx="640080" cy="182880"/>
-          </a:xfrm>
-          <a:prstGeom prst="rect">
-            <a:avLst/>
-          </a:prstGeom>
-          <a:noFill/>
-        </p:spPr>
-        <p:txBody>
-          <a:bodyPr wrap="none" lIns="0" rIns="0" tIns="0" bIns="0" anchor="t">
-            <a:spAutoFit/>
-          </a:bodyPr>
-          <a:lstStyle/>
-          <a:p>
-            <a:pPr algn="ctr">
-              <a:lnSpc>
-                <a:spcPct val="100000"/>
-              </a:lnSpc>
-              <a:spcAft>
-                <a:spcPts val="0"/>
-              </a:spcAft>
-            </a:pPr>
-            <a:r>
-              <a:rPr sz="850" b="0" i="0">
-                <a:solidFill>
-                  <a:srgbClr val="767576"/>
-                </a:solidFill>
-                <a:latin typeface="Arial"/>
-              </a:rPr>
-              <a:t>+270</a:t>
-            </a:r>
-          </a:p>
-        </p:txBody>
-      </p:sp>
-      <p:sp>
-        <p:nvSpPr>
-          <p:cNvPr id="47" name="Rectangle 46"/>
-          <p:cNvSpPr/>
-          <p:nvPr/>
-        </p:nvSpPr>
-        <p:spPr>
-          <a:xfrm>
-            <a:off x="4133087" y="3310128"/>
-            <a:ext cx="51206" cy="128016"/>
-          </a:xfrm>
-          <a:prstGeom prst="rect">
-            <a:avLst/>
-          </a:prstGeom>
-          <a:solidFill>
-            <a:srgbClr val="DB0011"/>
-          </a:solidFill>
-          <a:ln>
-            <a:noFill/>
-          </a:ln>
-          <a:effectLst/>
-        </p:spPr>
-        <p:style>
-          <a:lnRef idx="1">
-            <a:schemeClr val="accent1"/>
-          </a:lnRef>
-          <a:fillRef idx="3">
-            <a:schemeClr val="accent1"/>
-          </a:fillRef>
-          <a:effectRef idx="2">
-            <a:schemeClr val="accent1"/>
-          </a:effectRef>
-          <a:fontRef idx="minor">
-            <a:schemeClr val="lt1"/>
-          </a:fontRef>
-        </p:style>
-        <p:txBody>
-          <a:bodyPr rtlCol="0" anchor="ctr"/>
-          <a:lstStyle/>
-          <a:p/>
-        </p:txBody>
-      </p:sp>
-      <p:sp>
-        <p:nvSpPr>
-          <p:cNvPr id="48" name="TextBox 47"/>
-          <p:cNvSpPr txBox="1"/>
-          <p:nvPr/>
-        </p:nvSpPr>
-        <p:spPr>
-          <a:xfrm>
-            <a:off x="4248302" y="3291840"/>
-            <a:ext cx="1174089" cy="182880"/>
-          </a:xfrm>
-          <a:prstGeom prst="rect">
-            <a:avLst/>
-          </a:prstGeom>
-          <a:noFill/>
-        </p:spPr>
-        <p:txBody>
-          <a:bodyPr wrap="none" lIns="0" rIns="0" tIns="0" bIns="0" anchor="t">
-            <a:spAutoFit/>
-          </a:bodyPr>
-          <a:lstStyle/>
-          <a:p>
-            <a:pPr algn="l">
-              <a:lnSpc>
-                <a:spcPct val="100000"/>
-              </a:lnSpc>
-              <a:spcAft>
-                <a:spcPts val="0"/>
-              </a:spcAft>
-            </a:pPr>
-            <a:r>
-              <a:rPr sz="850" b="0" i="0">
-                <a:solidFill>
-                  <a:srgbClr val="767576"/>
-                </a:solidFill>
-                <a:latin typeface="Arial"/>
-              </a:rPr>
-              <a:t>Today</a:t>
-            </a:r>
-          </a:p>
-        </p:txBody>
-      </p:sp>
-      <p:sp>
-        <p:nvSpPr>
-          <p:cNvPr id="49" name="Rectangle 48"/>
-          <p:cNvSpPr/>
-          <p:nvPr/>
-        </p:nvSpPr>
-        <p:spPr>
-          <a:xfrm>
-            <a:off x="5486400" y="3310128"/>
-            <a:ext cx="20116" cy="128016"/>
-          </a:xfrm>
-          <a:prstGeom prst="rect">
-            <a:avLst/>
-          </a:prstGeom>
-          <a:solidFill>
-            <a:srgbClr val="44546A"/>
-          </a:solidFill>
-          <a:ln>
-            <a:noFill/>
-          </a:ln>
-          <a:effectLst/>
-        </p:spPr>
-        <p:style>
-          <a:lnRef idx="1">
-            <a:schemeClr val="accent1"/>
-          </a:lnRef>
-          <a:fillRef idx="3">
-            <a:schemeClr val="accent1"/>
-          </a:fillRef>
-          <a:effectRef idx="2">
-            <a:schemeClr val="accent1"/>
-          </a:effectRef>
-          <a:fontRef idx="minor">
-            <a:schemeClr val="lt1"/>
-          </a:fontRef>
-        </p:style>
-        <p:txBody>
-          <a:bodyPr rtlCol="0" anchor="ctr"/>
-          <a:lstStyle/>
-          <a:p/>
-        </p:txBody>
-      </p:sp>
-      <p:sp>
-        <p:nvSpPr>
-          <p:cNvPr id="50" name="TextBox 49"/>
-          <p:cNvSpPr txBox="1"/>
-          <p:nvPr/>
-        </p:nvSpPr>
-        <p:spPr>
-          <a:xfrm>
-            <a:off x="5570524" y="3291840"/>
-            <a:ext cx="1205179" cy="182880"/>
-          </a:xfrm>
-          <a:prstGeom prst="rect">
-            <a:avLst/>
-          </a:prstGeom>
-          <a:noFill/>
-        </p:spPr>
-        <p:txBody>
-          <a:bodyPr wrap="none" lIns="0" rIns="0" tIns="0" bIns="0" anchor="t">
-            <a:spAutoFit/>
-          </a:bodyPr>
-          <a:lstStyle/>
-          <a:p>
-            <a:pPr algn="l">
-              <a:lnSpc>
-                <a:spcPct val="100000"/>
-              </a:lnSpc>
-              <a:spcAft>
-                <a:spcPts val="0"/>
-              </a:spcAft>
-            </a:pPr>
-            <a:r>
-              <a:rPr sz="850" b="0" i="0">
-                <a:solidFill>
-                  <a:srgbClr val="767576"/>
-                </a:solidFill>
-                <a:latin typeface="Arial"/>
-              </a:rPr>
-              <a:t>Mean</a:t>
-            </a:r>
-          </a:p>
-        </p:txBody>
-      </p:sp>
-      <p:sp>
-        <p:nvSpPr>
-          <p:cNvPr id="51" name="Rectangle 50"/>
-          <p:cNvSpPr/>
-          <p:nvPr/>
-        </p:nvSpPr>
-        <p:spPr>
-          <a:xfrm>
-            <a:off x="6839712" y="3328416"/>
-            <a:ext cx="201168" cy="91440"/>
-          </a:xfrm>
-          <a:prstGeom prst="rect">
-            <a:avLst/>
-          </a:prstGeom>
-          <a:solidFill>
-            <a:srgbClr val="D7D8D6"/>
-          </a:solidFill>
-          <a:ln>
-            <a:noFill/>
-          </a:ln>
-          <a:effectLst/>
-        </p:spPr>
-        <p:style>
-          <a:lnRef idx="1">
-            <a:schemeClr val="accent1"/>
-          </a:lnRef>
-          <a:fillRef idx="3">
-            <a:schemeClr val="accent1"/>
-          </a:fillRef>
-          <a:effectRef idx="2">
-            <a:schemeClr val="accent1"/>
-          </a:effectRef>
-          <a:fontRef idx="minor">
-            <a:schemeClr val="lt1"/>
-          </a:fontRef>
-        </p:style>
-        <p:txBody>
-          <a:bodyPr rtlCol="0" anchor="ctr"/>
-          <a:lstStyle/>
-          <a:p/>
-        </p:txBody>
-      </p:sp>
-      <p:sp>
-        <p:nvSpPr>
-          <p:cNvPr id="52" name="TextBox 51"/>
-          <p:cNvSpPr txBox="1"/>
-          <p:nvPr/>
-        </p:nvSpPr>
-        <p:spPr>
-          <a:xfrm>
-            <a:off x="7104888" y="3291840"/>
-            <a:ext cx="1024128" cy="182880"/>
-          </a:xfrm>
-          <a:prstGeom prst="rect">
-            <a:avLst/>
-          </a:prstGeom>
-          <a:noFill/>
-        </p:spPr>
-        <p:txBody>
-          <a:bodyPr wrap="none" lIns="0" rIns="0" tIns="0" bIns="0" anchor="t">
-            <a:spAutoFit/>
-          </a:bodyPr>
-          <a:lstStyle/>
-          <a:p>
-            <a:pPr algn="l">
-              <a:lnSpc>
-                <a:spcPct val="100000"/>
-              </a:lnSpc>
-              <a:spcAft>
-                <a:spcPts val="0"/>
-              </a:spcAft>
-            </a:pPr>
-            <a:r>
-              <a:rPr sz="850" b="0" i="0">
-                <a:solidFill>
-                  <a:srgbClr val="767576"/>
-                </a:solidFill>
-                <a:latin typeface="Arial"/>
-              </a:rPr>
-              <a:t>Since 2000</a:t>
-            </a:r>
-          </a:p>
-        </p:txBody>
-      </p:sp>
-      <p:sp>
-        <p:nvSpPr>
-          <p:cNvPr id="53" name="TextBox 52"/>
+              <a:t>Navy is the bin we are in, red every bin above it. 6.8% of the 1,387 weeks closed steeper than today. The 160bp target and the 164.9bp high are both in the last bin.</a:t>
+            </a:r>
+          </a:p>
+        </p:txBody>
+      </p:sp>
+      <p:sp>
+        <p:nvSpPr>
+          <p:cNvPr id="25" name="TextBox 24"/>
           <p:cNvSpPr txBox="1"/>
           <p:nvPr/>
         </p:nvSpPr>
@@ -7178,7 +6330,7 @@
       </p:sp>
       <p:sp>
         <p:nvSpPr>
-          <p:cNvPr id="54" name="TextBox 53"/>
+          <p:cNvPr id="26" name="TextBox 25"/>
           <p:cNvSpPr txBox="1"/>
           <p:nvPr/>
         </p:nvSpPr>
@@ -7220,7 +6372,7 @@
       </p:sp>
       <p:cxnSp>
         <p:nvCxnSpPr>
-          <p:cNvPr id="55" name="Connector 54"/>
+          <p:cNvPr id="27" name="Connector 26"/>
           <p:cNvCxnSpPr/>
           <p:nvPr/>
         </p:nvCxnSpPr>
@@ -7255,7 +6407,7 @@
       </p:cxnSp>
       <p:sp>
         <p:nvSpPr>
-          <p:cNvPr id="56" name="TextBox 55"/>
+          <p:cNvPr id="28" name="TextBox 27"/>
           <p:cNvSpPr txBox="1"/>
           <p:nvPr/>
         </p:nvSpPr>
@@ -7297,7 +6449,7 @@
       </p:sp>
       <p:sp>
         <p:nvSpPr>
-          <p:cNvPr id="57" name="TextBox 56"/>
+          <p:cNvPr id="29" name="TextBox 28"/>
           <p:cNvSpPr txBox="1"/>
           <p:nvPr/>
         </p:nvSpPr>
@@ -7339,7 +6491,7 @@
       </p:sp>
       <p:sp>
         <p:nvSpPr>
-          <p:cNvPr id="58" name="TextBox 57"/>
+          <p:cNvPr id="30" name="TextBox 29"/>
           <p:cNvSpPr txBox="1"/>
           <p:nvPr/>
         </p:nvSpPr>
@@ -7381,7 +6533,7 @@
       </p:sp>
       <p:cxnSp>
         <p:nvCxnSpPr>
-          <p:cNvPr id="59" name="Connector 58"/>
+          <p:cNvPr id="31" name="Connector 30"/>
           <p:cNvCxnSpPr/>
           <p:nvPr/>
         </p:nvCxnSpPr>
@@ -7416,7 +6568,7 @@
       </p:cxnSp>
       <p:sp>
         <p:nvSpPr>
-          <p:cNvPr id="60" name="TextBox 59"/>
+          <p:cNvPr id="32" name="TextBox 31"/>
           <p:cNvSpPr txBox="1"/>
           <p:nvPr/>
         </p:nvSpPr>
@@ -7458,7 +6610,7 @@
       </p:sp>
       <p:sp>
         <p:nvSpPr>
-          <p:cNvPr id="61" name="TextBox 60"/>
+          <p:cNvPr id="33" name="TextBox 32"/>
           <p:cNvSpPr txBox="1"/>
           <p:nvPr/>
         </p:nvSpPr>
@@ -7500,7 +6652,7 @@
       </p:sp>
       <p:sp>
         <p:nvSpPr>
-          <p:cNvPr id="62" name="TextBox 61"/>
+          <p:cNvPr id="34" name="TextBox 33"/>
           <p:cNvSpPr txBox="1"/>
           <p:nvPr/>
         </p:nvSpPr>
@@ -7542,7 +6694,7 @@
       </p:sp>
       <p:cxnSp>
         <p:nvCxnSpPr>
-          <p:cNvPr id="63" name="Connector 62"/>
+          <p:cNvPr id="35" name="Connector 34"/>
           <p:cNvCxnSpPr/>
           <p:nvPr/>
         </p:nvCxnSpPr>
@@ -7577,7 +6729,7 @@
       </p:cxnSp>
       <p:sp>
         <p:nvSpPr>
-          <p:cNvPr id="64" name="TextBox 63"/>
+          <p:cNvPr id="36" name="TextBox 35"/>
           <p:cNvSpPr txBox="1"/>
           <p:nvPr/>
         </p:nvSpPr>
@@ -7619,7 +6771,7 @@
       </p:sp>
       <p:sp>
         <p:nvSpPr>
-          <p:cNvPr id="65" name="TextBox 64"/>
+          <p:cNvPr id="37" name="TextBox 36"/>
           <p:cNvSpPr txBox="1"/>
           <p:nvPr/>
         </p:nvSpPr>
@@ -7661,7 +6813,7 @@
       </p:sp>
       <p:sp>
         <p:nvSpPr>
-          <p:cNvPr id="66" name="TextBox 65"/>
+          <p:cNvPr id="38" name="TextBox 37"/>
           <p:cNvSpPr txBox="1"/>
           <p:nvPr/>
         </p:nvSpPr>
@@ -7703,7 +6855,7 @@
       </p:sp>
       <p:cxnSp>
         <p:nvCxnSpPr>
-          <p:cNvPr id="67" name="Connector 66"/>
+          <p:cNvPr id="39" name="Connector 38"/>
           <p:cNvCxnSpPr/>
           <p:nvPr/>
         </p:nvCxnSpPr>
@@ -7738,7 +6890,7 @@
       </p:cxnSp>
       <p:sp>
         <p:nvSpPr>
-          <p:cNvPr id="68" name="TextBox 67"/>
+          <p:cNvPr id="40" name="TextBox 39"/>
           <p:cNvSpPr txBox="1"/>
           <p:nvPr/>
         </p:nvSpPr>
@@ -7780,7 +6932,7 @@
       </p:sp>
       <p:sp>
         <p:nvSpPr>
-          <p:cNvPr id="69" name="TextBox 68"/>
+          <p:cNvPr id="41" name="TextBox 40"/>
           <p:cNvSpPr txBox="1"/>
           <p:nvPr/>
         </p:nvSpPr>
@@ -7822,7 +6974,7 @@
       </p:sp>
       <p:sp>
         <p:nvSpPr>
-          <p:cNvPr id="70" name="TextBox 69"/>
+          <p:cNvPr id="42" name="TextBox 41"/>
           <p:cNvSpPr txBox="1"/>
           <p:nvPr/>
         </p:nvSpPr>
@@ -7864,7 +7016,7 @@
       </p:sp>
       <p:sp>
         <p:nvSpPr>
-          <p:cNvPr id="71" name="TextBox 70"/>
+          <p:cNvPr id="43" name="TextBox 42"/>
           <p:cNvSpPr txBox="1"/>
           <p:nvPr/>
         </p:nvSpPr>
@@ -7906,7 +7058,7 @@
       </p:sp>
       <p:sp>
         <p:nvSpPr>
-          <p:cNvPr id="72" name="TextBox 71"/>
+          <p:cNvPr id="44" name="TextBox 43"/>
           <p:cNvSpPr txBox="1"/>
           <p:nvPr/>
         </p:nvSpPr>
@@ -7948,7 +7100,7 @@
       </p:sp>
       <p:sp>
         <p:nvSpPr>
-          <p:cNvPr id="73" name="TextBox 72"/>
+          <p:cNvPr id="45" name="TextBox 44"/>
           <p:cNvSpPr txBox="1"/>
           <p:nvPr/>
         </p:nvSpPr>
@@ -7990,7 +7142,7 @@
       </p:sp>
       <p:graphicFrame>
         <p:nvGraphicFramePr>
-          <p:cNvPr id="74" name="Chart 73"/>
+          <p:cNvPr id="46" name="Chart 45"/>
           <p:cNvGraphicFramePr>
             <a:graphicFrameLocks noGrp="1"/>
           </p:cNvGraphicFramePr>
@@ -8002,13 +7154,13 @@
         </p:xfrm>
         <a:graphic>
           <a:graphicData uri="http://schemas.openxmlformats.org/drawingml/2006/chart">
-            <c:chart xmlns:c="http://schemas.openxmlformats.org/drawingml/2006/chart" r:id="rId3"/>
+            <c:chart xmlns:c="http://schemas.openxmlformats.org/drawingml/2006/chart" r:id="rId4"/>
           </a:graphicData>
         </a:graphic>
       </p:graphicFrame>
       <p:sp>
         <p:nvSpPr>
-          <p:cNvPr id="75" name="TextBox 74"/>
+          <p:cNvPr id="47" name="TextBox 46"/>
           <p:cNvSpPr txBox="1"/>
           <p:nvPr/>
         </p:nvSpPr>
@@ -8050,7 +7202,7 @@
       </p:sp>
       <p:sp>
         <p:nvSpPr>
-          <p:cNvPr id="76" name="TextBox 75"/>
+          <p:cNvPr id="48" name="TextBox 47"/>
           <p:cNvSpPr txBox="1"/>
           <p:nvPr/>
         </p:nvSpPr>
@@ -8092,7 +7244,7 @@
       </p:sp>
       <p:sp>
         <p:nvSpPr>
-          <p:cNvPr id="77" name="TextBox 76"/>
+          <p:cNvPr id="49" name="TextBox 48"/>
           <p:cNvSpPr txBox="1"/>
           <p:nvPr/>
         </p:nvSpPr>
@@ -8134,7 +7286,7 @@
       </p:sp>
       <p:sp>
         <p:nvSpPr>
-          <p:cNvPr id="78" name="TextBox 77"/>
+          <p:cNvPr id="50" name="TextBox 49"/>
           <p:cNvSpPr txBox="1"/>
           <p:nvPr/>
         </p:nvSpPr>
@@ -8176,7 +7328,7 @@
       </p:sp>
       <p:sp>
         <p:nvSpPr>
-          <p:cNvPr id="79" name="TextBox 78"/>
+          <p:cNvPr id="51" name="TextBox 50"/>
           <p:cNvSpPr txBox="1"/>
           <p:nvPr/>
         </p:nvSpPr>
@@ -8218,7 +7370,7 @@
       </p:sp>
       <p:graphicFrame>
         <p:nvGraphicFramePr>
-          <p:cNvPr id="80" name="Table 79"/>
+          <p:cNvPr id="52" name="Table 51"/>
           <p:cNvGraphicFramePr>
             <a:graphicFrameLocks noGrp="1"/>
           </p:cNvGraphicFramePr>
@@ -8720,7 +7872,7 @@
       </p:graphicFrame>
       <p:sp>
         <p:nvSpPr>
-          <p:cNvPr id="81" name="TextBox 80"/>
+          <p:cNvPr id="53" name="TextBox 52"/>
           <p:cNvSpPr txBox="1"/>
           <p:nvPr/>
         </p:nvSpPr>
@@ -8762,7 +7914,7 @@
       </p:sp>
       <p:sp>
         <p:nvSpPr>
-          <p:cNvPr id="82" name="TextBox 81"/>
+          <p:cNvPr id="54" name="TextBox 53"/>
           <p:cNvSpPr txBox="1"/>
           <p:nvPr/>
         </p:nvSpPr>
@@ -8797,7 +7949,7 @@
                 </a:solidFill>
                 <a:latin typeface="Arial"/>
               </a:rPr>
-              <a:t>MoF JGB curve at 31-Jul-26, weekly since 2000, n = 1,387. Slide 3's panel is a different window: month-end to May-26, five years, so its levels and percentiles will not tie to these. Cashflow-level pricing on the annual JPY OIS schedule. Our path is a scenario: 2y +10bp, 10y +40bp.</a:t>
+              <a:t>MoF JGB curve at 31-Jul-26, weekly since 2000, n = 1,387. Cashflow-level pricing on the annual JPY OIS schedule. Our path is a scenario: 2y +10bp, 10y +40bp.</a:t>
             </a:r>
           </a:p>
         </p:txBody>

</xml_diff>

<commit_message>
Draw the room to the high, and set 2s10s against 2s30s
</commit_message>
<xml_diff>
--- a/JGB_2s10s_Steepener.pptx
+++ b/JGB_2s10s_Steepener.pptx
@@ -1816,365 +1816,6 @@
 </file>
 
 <file path=ppt/charts/chart2.xml><?xml version="1.0" encoding="utf-8"?>
-<c:chartSpace xmlns:c="http://schemas.openxmlformats.org/drawingml/2006/chart" xmlns:a="http://schemas.openxmlformats.org/drawingml/2006/main" xmlns:r="http://schemas.openxmlformats.org/officeDocument/2006/relationships">
-  <c:date1904 val="0"/>
-  <c:chart>
-    <c:autoTitleDeleted val="1"/>
-    <c:plotArea>
-      <c:barChart>
-        <c:barDir val="col"/>
-        <c:grouping val="clustered"/>
-        <c:ser>
-          <c:idx val="0"/>
-          <c:order val="0"/>
-          <c:tx>
-            <c:strRef>
-              <c:f>Sheet1!$B$1</c:f>
-              <c:strCache>
-                <c:ptCount val="1"/>
-                <c:pt idx="0">
-                  <c:v>s</c:v>
-                </c:pt>
-              </c:strCache>
-            </c:strRef>
-          </c:tx>
-          <c:spPr>
-            <a:ln>
-              <a:noFill/>
-            </a:ln>
-          </c:spPr>
-          <c:dPt>
-            <c:idx val="0"/>
-            <c:spPr>
-              <a:solidFill>
-                <a:srgbClr val="D7D8D6"/>
-              </a:solidFill>
-            </c:spPr>
-          </c:dPt>
-          <c:dPt>
-            <c:idx val="1"/>
-            <c:spPr>
-              <a:solidFill>
-                <a:srgbClr val="D7D8D6"/>
-              </a:solidFill>
-            </c:spPr>
-          </c:dPt>
-          <c:dPt>
-            <c:idx val="2"/>
-            <c:spPr>
-              <a:solidFill>
-                <a:srgbClr val="D7D8D6"/>
-              </a:solidFill>
-            </c:spPr>
-          </c:dPt>
-          <c:dPt>
-            <c:idx val="3"/>
-            <c:spPr>
-              <a:solidFill>
-                <a:srgbClr val="D7D8D6"/>
-              </a:solidFill>
-            </c:spPr>
-          </c:dPt>
-          <c:dPt>
-            <c:idx val="4"/>
-            <c:spPr>
-              <a:solidFill>
-                <a:srgbClr val="D7D8D6"/>
-              </a:solidFill>
-            </c:spPr>
-          </c:dPt>
-          <c:dPt>
-            <c:idx val="5"/>
-            <c:spPr>
-              <a:solidFill>
-                <a:srgbClr val="D7D8D6"/>
-              </a:solidFill>
-            </c:spPr>
-          </c:dPt>
-          <c:dPt>
-            <c:idx val="6"/>
-            <c:spPr>
-              <a:solidFill>
-                <a:srgbClr val="D7D8D6"/>
-              </a:solidFill>
-            </c:spPr>
-          </c:dPt>
-          <c:dPt>
-            <c:idx val="7"/>
-            <c:spPr>
-              <a:solidFill>
-                <a:srgbClr val="D7D8D6"/>
-              </a:solidFill>
-            </c:spPr>
-          </c:dPt>
-          <c:dPt>
-            <c:idx val="8"/>
-            <c:spPr>
-              <a:solidFill>
-                <a:srgbClr val="D7D8D6"/>
-              </a:solidFill>
-            </c:spPr>
-          </c:dPt>
-          <c:dPt>
-            <c:idx val="9"/>
-            <c:spPr>
-              <a:solidFill>
-                <a:srgbClr val="D7D8D6"/>
-              </a:solidFill>
-            </c:spPr>
-          </c:dPt>
-          <c:dPt>
-            <c:idx val="10"/>
-            <c:spPr>
-              <a:solidFill>
-                <a:srgbClr val="D7D8D6"/>
-              </a:solidFill>
-            </c:spPr>
-          </c:dPt>
-          <c:dPt>
-            <c:idx val="11"/>
-            <c:spPr>
-              <a:solidFill>
-                <a:srgbClr val="D7D8D6"/>
-              </a:solidFill>
-            </c:spPr>
-          </c:dPt>
-          <c:dPt>
-            <c:idx val="12"/>
-            <c:spPr>
-              <a:solidFill>
-                <a:srgbClr val="44546A"/>
-              </a:solidFill>
-            </c:spPr>
-          </c:dPt>
-          <c:dPt>
-            <c:idx val="13"/>
-            <c:spPr>
-              <a:solidFill>
-                <a:srgbClr val="DB0011"/>
-              </a:solidFill>
-            </c:spPr>
-          </c:dPt>
-          <c:dPt>
-            <c:idx val="14"/>
-            <c:spPr>
-              <a:solidFill>
-                <a:srgbClr val="DB0011"/>
-              </a:solidFill>
-            </c:spPr>
-          </c:dPt>
-          <c:dPt>
-            <c:idx val="15"/>
-            <c:spPr>
-              <a:solidFill>
-                <a:srgbClr val="DB0011"/>
-              </a:solidFill>
-            </c:spPr>
-          </c:dPt>
-          <c:dPt>
-            <c:idx val="16"/>
-            <c:spPr>
-              <a:solidFill>
-                <a:srgbClr val="DB0011"/>
-              </a:solidFill>
-            </c:spPr>
-          </c:dPt>
-          <c:cat>
-            <c:strRef>
-              <c:f>Sheet1!$A$2:$A$18</c:f>
-              <c:strCache>
-                <c:ptCount val="17"/>
-                <c:pt idx="0">
-                  <c:v>0</c:v>
-                </c:pt>
-                <c:pt idx="1">
-                  <c:v/>
-                </c:pt>
-                <c:pt idx="2">
-                  <c:v>20</c:v>
-                </c:pt>
-                <c:pt idx="3">
-                  <c:v/>
-                </c:pt>
-                <c:pt idx="4">
-                  <c:v>40</c:v>
-                </c:pt>
-                <c:pt idx="5">
-                  <c:v/>
-                </c:pt>
-                <c:pt idx="6">
-                  <c:v>60</c:v>
-                </c:pt>
-                <c:pt idx="7">
-                  <c:v/>
-                </c:pt>
-                <c:pt idx="8">
-                  <c:v>80</c:v>
-                </c:pt>
-                <c:pt idx="9">
-                  <c:v/>
-                </c:pt>
-                <c:pt idx="10">
-                  <c:v>100</c:v>
-                </c:pt>
-                <c:pt idx="11">
-                  <c:v/>
-                </c:pt>
-                <c:pt idx="12">
-                  <c:v>120</c:v>
-                </c:pt>
-                <c:pt idx="13">
-                  <c:v/>
-                </c:pt>
-                <c:pt idx="14">
-                  <c:v>140</c:v>
-                </c:pt>
-                <c:pt idx="15">
-                  <c:v/>
-                </c:pt>
-                <c:pt idx="16">
-                  <c:v>160</c:v>
-                </c:pt>
-              </c:strCache>
-            </c:strRef>
-          </c:cat>
-          <c:val>
-            <c:numRef>
-              <c:f>Sheet1!$B$2:$B$18</c:f>
-              <c:numCache>
-                <c:formatCode>General</c:formatCode>
-                <c:ptCount val="17"/>
-                <c:pt idx="0">
-                  <c:v>2.1</c:v>
-                </c:pt>
-                <c:pt idx="1">
-                  <c:v>12.9</c:v>
-                </c:pt>
-                <c:pt idx="2">
-                  <c:v>9.2</c:v>
-                </c:pt>
-                <c:pt idx="3">
-                  <c:v>5.2</c:v>
-                </c:pt>
-                <c:pt idx="4">
-                  <c:v>4.9</c:v>
-                </c:pt>
-                <c:pt idx="5">
-                  <c:v>7.4</c:v>
-                </c:pt>
-                <c:pt idx="6">
-                  <c:v>5.9</c:v>
-                </c:pt>
-                <c:pt idx="7">
-                  <c:v>8.0</c:v>
-                </c:pt>
-                <c:pt idx="8">
-                  <c:v>9.0</c:v>
-                </c:pt>
-                <c:pt idx="9">
-                  <c:v>5.7</c:v>
-                </c:pt>
-                <c:pt idx="10">
-                  <c:v>6.1</c:v>
-                </c:pt>
-                <c:pt idx="11">
-                  <c:v>6.8</c:v>
-                </c:pt>
-                <c:pt idx="12">
-                  <c:v>10.2</c:v>
-                </c:pt>
-                <c:pt idx="13">
-                  <c:v>5.0</c:v>
-                </c:pt>
-                <c:pt idx="14">
-                  <c:v>0.9</c:v>
-                </c:pt>
-                <c:pt idx="15">
-                  <c:v>0.1</c:v>
-                </c:pt>
-                <c:pt idx="16">
-                  <c:v>0.5</c:v>
-                </c:pt>
-              </c:numCache>
-            </c:numRef>
-          </c:val>
-        </c:ser>
-        <c:gapWidth val="18"/>
-        <c:axId val="-2068027336"/>
-        <c:axId val="-2113994440"/>
-      </c:barChart>
-      <c:catAx>
-        <c:axId val="-2068027336"/>
-        <c:scaling>
-          <c:orientation val="minMax"/>
-        </c:scaling>
-        <c:delete val="0"/>
-        <c:axPos val="b"/>
-        <c:majorTickMark val="none"/>
-        <c:minorTickMark val="none"/>
-        <c:tickLblPos val="nextTo"/>
-        <c:spPr>
-          <a:ln w="9525">
-            <a:solidFill>
-              <a:srgbClr val="000000"/>
-            </a:solidFill>
-          </a:ln>
-        </c:spPr>
-        <c:txPr>
-          <a:bodyPr/>
-          <a:lstStyle/>
-          <a:p>
-            <a:pPr>
-              <a:defRPr sz="700">
-                <a:solidFill>
-                  <a:srgbClr val="000000"/>
-                </a:solidFill>
-                <a:latin typeface="Arial"/>
-              </a:defRPr>
-            </a:pPr>
-          </a:p>
-        </c:txPr>
-        <c:crossAx val="-2113994440"/>
-        <c:crosses val="autoZero"/>
-        <c:auto val="1"/>
-        <c:lblAlgn val="ctr"/>
-        <c:lblOffset val="100"/>
-        <c:noMultiLvlLbl val="0"/>
-      </c:catAx>
-      <c:valAx>
-        <c:axId val="-2113994440"/>
-        <c:scaling>
-          <c:max val="14.0"/>
-          <c:min val="0.0"/>
-        </c:scaling>
-        <c:delete/>
-        <c:axPos val="l"/>
-        <c:majorTickMark val="out"/>
-        <c:minorTickMark val="none"/>
-        <c:tickLblPos val="nextTo"/>
-        <c:crossAx val="-2068027336"/>
-        <c:crosses val="autoZero"/>
-      </c:valAx>
-    </c:plotArea>
-    <c:dispBlanksAs val="gap"/>
-  </c:chart>
-  <c:txPr>
-    <a:bodyPr/>
-    <a:lstStyle/>
-    <a:p>
-      <a:pPr>
-        <a:defRPr sz="1800"/>
-      </a:pPr>
-      <a:endParaRPr lang="en-US"/>
-    </a:p>
-  </c:txPr>
-  <c:externalData r:id="rId1">
-    <c:autoUpdate val="0"/>
-  </c:externalData>
-</c:chartSpace>
-</file>
-
-<file path=ppt/charts/chart3.xml><?xml version="1.0" encoding="utf-8"?>
 <c:chartSpace xmlns:c="http://schemas.openxmlformats.org/drawingml/2006/chart" xmlns:a="http://schemas.openxmlformats.org/drawingml/2006/main" xmlns:r="http://schemas.openxmlformats.org/officeDocument/2006/relationships">
   <c:date1904 val="0"/>
   <c:chart>
@@ -6179,7 +5820,7 @@
                 </a:solidFill>
                 <a:latin typeface="Arial"/>
               </a:rPr>
-              <a:t>Exhibit 5. The curve has been steeper than this in 7% of the last 26 years</a:t>
+              <a:t>Exhibit 5. 2s10s has 35bp of room to its high. 2s30s has 12bp, and the round trip takes a third of it</a:t>
             </a:r>
           </a:p>
         </p:txBody>
@@ -6221,172 +5862,28 @@
                 </a:solidFill>
                 <a:latin typeface="Arial"/>
               </a:rPr>
-              <a:t>JGB 2s10s, weekly closes since 2000, % of weeks per 10bp bin</a:t>
-            </a:r>
-          </a:p>
-        </p:txBody>
-      </p:sp>
-      <p:graphicFrame>
-        <p:nvGraphicFramePr>
-          <p:cNvPr id="23" name="Chart 22"/>
-          <p:cNvGraphicFramePr>
-            <a:graphicFrameLocks noGrp="1"/>
-          </p:cNvGraphicFramePr>
-          <p:nvPr/>
-        </p:nvGraphicFramePr>
-        <p:xfrm>
-          <a:off x="4078224" y="1700784"/>
-          <a:ext cx="4169664" cy="1572768"/>
-        </p:xfrm>
-        <a:graphic>
-          <a:graphicData uri="http://schemas.openxmlformats.org/drawingml/2006/chart">
-            <c:chart xmlns:c="http://schemas.openxmlformats.org/drawingml/2006/chart" r:id="rId3"/>
-          </a:graphicData>
-        </a:graphic>
-      </p:graphicFrame>
-      <p:sp>
-        <p:nvSpPr>
-          <p:cNvPr id="24" name="TextBox 23"/>
-          <p:cNvSpPr txBox="1"/>
-          <p:nvPr/>
-        </p:nvSpPr>
-        <p:spPr>
-          <a:xfrm>
-            <a:off x="4133087" y="3310128"/>
-            <a:ext cx="4059936" cy="384048"/>
-          </a:xfrm>
-          <a:prstGeom prst="rect">
-            <a:avLst/>
-          </a:prstGeom>
-          <a:noFill/>
-        </p:spPr>
-        <p:txBody>
-          <a:bodyPr wrap="square" lIns="0" rIns="0" tIns="0" bIns="0" anchor="t">
-            <a:spAutoFit/>
-          </a:bodyPr>
-          <a:lstStyle/>
-          <a:p>
-            <a:pPr algn="ctr">
-              <a:lnSpc>
-                <a:spcPct val="114000"/>
-              </a:lnSpc>
-              <a:spcAft>
-                <a:spcPts val="0"/>
-              </a:spcAft>
-            </a:pPr>
-            <a:r>
-              <a:rPr sz="700" b="0" i="0">
-                <a:solidFill>
-                  <a:srgbClr val="767576"/>
-                </a:solidFill>
-                <a:latin typeface="Arial"/>
-              </a:rPr>
-              <a:t>Navy is the bin we are in, red every bin above it. 6.8% of the 1,387 weeks closed steeper than today. The 160bp target and the 164.9bp high are both in the last bin.</a:t>
-            </a:r>
-          </a:p>
-        </p:txBody>
-      </p:sp>
-      <p:sp>
-        <p:nvSpPr>
-          <p:cNvPr id="25" name="TextBox 24"/>
-          <p:cNvSpPr txBox="1"/>
-          <p:nvPr/>
-        </p:nvSpPr>
-        <p:spPr>
-          <a:xfrm>
-            <a:off x="6236207" y="3584448"/>
-            <a:ext cx="914400" cy="164592"/>
-          </a:xfrm>
-          <a:prstGeom prst="rect">
-            <a:avLst/>
-          </a:prstGeom>
-          <a:noFill/>
-        </p:spPr>
-        <p:txBody>
-          <a:bodyPr wrap="none" lIns="0" rIns="0" tIns="0" bIns="0" anchor="t">
-            <a:spAutoFit/>
-          </a:bodyPr>
-          <a:lstStyle/>
-          <a:p>
-            <a:pPr algn="r">
-              <a:lnSpc>
-                <a:spcPct val="100000"/>
-              </a:lnSpc>
-              <a:spcAft>
-                <a:spcPts val="0"/>
-              </a:spcAft>
-            </a:pPr>
-            <a:r>
-              <a:rPr sz="850" b="1" i="0">
-                <a:solidFill>
-                  <a:srgbClr val="DB0011"/>
-                </a:solidFill>
-                <a:latin typeface="Arial"/>
-              </a:rPr>
-              <a:t>2s10s</a:t>
-            </a:r>
-          </a:p>
-        </p:txBody>
-      </p:sp>
-      <p:sp>
-        <p:nvSpPr>
-          <p:cNvPr id="26" name="TextBox 25"/>
-          <p:cNvSpPr txBox="1"/>
-          <p:nvPr/>
-        </p:nvSpPr>
-        <p:spPr>
-          <a:xfrm>
-            <a:off x="7150607" y="3584448"/>
-            <a:ext cx="914400" cy="164592"/>
-          </a:xfrm>
-          <a:prstGeom prst="rect">
-            <a:avLst/>
-          </a:prstGeom>
-          <a:noFill/>
-        </p:spPr>
-        <p:txBody>
-          <a:bodyPr wrap="none" lIns="0" rIns="0" tIns="0" bIns="0" anchor="t">
-            <a:spAutoFit/>
-          </a:bodyPr>
-          <a:lstStyle/>
-          <a:p>
-            <a:pPr algn="r">
-              <a:lnSpc>
-                <a:spcPct val="100000"/>
-              </a:lnSpc>
-              <a:spcAft>
-                <a:spcPts val="0"/>
-              </a:spcAft>
-            </a:pPr>
-            <a:r>
-              <a:rPr sz="850" b="1" i="0">
-                <a:solidFill>
-                  <a:srgbClr val="767576"/>
-                </a:solidFill>
-                <a:latin typeface="Arial"/>
-              </a:rPr>
-              <a:t>2s30s</a:t>
+              <a:t>Slope vs its own range since 2000, bp</a:t>
             </a:r>
           </a:p>
         </p:txBody>
       </p:sp>
       <p:cxnSp>
         <p:nvCxnSpPr>
-          <p:cNvPr id="27" name="Connector 26"/>
+          <p:cNvPr id="23" name="Connector 22"/>
           <p:cNvCxnSpPr/>
           <p:nvPr/>
         </p:nvCxnSpPr>
         <p:spPr>
           <a:xfrm>
-            <a:off x="4133087" y="3767328"/>
-            <a:ext cx="3931921" cy="0"/>
+            <a:off x="5102352" y="1737360"/>
+            <a:ext cx="0" cy="1207008"/>
           </a:xfrm>
           <a:prstGeom prst="line">
             <a:avLst/>
           </a:prstGeom>
-          <a:ln w="9525">
+          <a:ln w="6350">
             <a:solidFill>
-              <a:srgbClr val="000000"/>
+              <a:srgbClr val="D0CECE"/>
             </a:solidFill>
           </a:ln>
         </p:spPr>
@@ -6405,142 +5902,16 @@
           </a:fontRef>
         </p:style>
       </p:cxnSp>
-      <p:sp>
-        <p:nvSpPr>
-          <p:cNvPr id="28" name="TextBox 27"/>
-          <p:cNvSpPr txBox="1"/>
-          <p:nvPr/>
-        </p:nvSpPr>
-        <p:spPr>
-          <a:xfrm>
-            <a:off x="4133087" y="3822191"/>
-            <a:ext cx="2029967" cy="164592"/>
-          </a:xfrm>
-          <a:prstGeom prst="rect">
-            <a:avLst/>
-          </a:prstGeom>
-          <a:noFill/>
-        </p:spPr>
-        <p:txBody>
-          <a:bodyPr wrap="none" lIns="0" rIns="0" tIns="0" bIns="0" anchor="t">
-            <a:spAutoFit/>
-          </a:bodyPr>
-          <a:lstStyle/>
-          <a:p>
-            <a:pPr algn="l">
-              <a:lnSpc>
-                <a:spcPct val="100000"/>
-              </a:lnSpc>
-              <a:spcAft>
-                <a:spcPts val="0"/>
-              </a:spcAft>
-            </a:pPr>
-            <a:r>
-              <a:rPr sz="800" b="0" i="0">
-                <a:solidFill>
-                  <a:srgbClr val="000000"/>
-                </a:solidFill>
-                <a:latin typeface="Arial"/>
-              </a:rPr>
-              <a:t>Headroom to the high since 2000</a:t>
-            </a:r>
-          </a:p>
-        </p:txBody>
-      </p:sp>
-      <p:sp>
-        <p:nvSpPr>
-          <p:cNvPr id="29" name="TextBox 28"/>
-          <p:cNvSpPr txBox="1"/>
-          <p:nvPr/>
-        </p:nvSpPr>
-        <p:spPr>
-          <a:xfrm>
-            <a:off x="6236207" y="3822191"/>
-            <a:ext cx="914400" cy="164592"/>
-          </a:xfrm>
-          <a:prstGeom prst="rect">
-            <a:avLst/>
-          </a:prstGeom>
-          <a:noFill/>
-        </p:spPr>
-        <p:txBody>
-          <a:bodyPr wrap="none" lIns="0" rIns="0" tIns="0" bIns="0" anchor="t">
-            <a:spAutoFit/>
-          </a:bodyPr>
-          <a:lstStyle/>
-          <a:p>
-            <a:pPr algn="r">
-              <a:lnSpc>
-                <a:spcPct val="100000"/>
-              </a:lnSpc>
-              <a:spcAft>
-                <a:spcPts val="0"/>
-              </a:spcAft>
-            </a:pPr>
-            <a:r>
-              <a:rPr sz="850" b="1" i="0">
-                <a:solidFill>
-                  <a:srgbClr val="DB0011"/>
-                </a:solidFill>
-                <a:latin typeface="Arial"/>
-              </a:rPr>
-              <a:t>+35.5bp</a:t>
-            </a:r>
-          </a:p>
-        </p:txBody>
-      </p:sp>
-      <p:sp>
-        <p:nvSpPr>
-          <p:cNvPr id="30" name="TextBox 29"/>
-          <p:cNvSpPr txBox="1"/>
-          <p:nvPr/>
-        </p:nvSpPr>
-        <p:spPr>
-          <a:xfrm>
-            <a:off x="7150607" y="3822191"/>
-            <a:ext cx="914400" cy="164592"/>
-          </a:xfrm>
-          <a:prstGeom prst="rect">
-            <a:avLst/>
-          </a:prstGeom>
-          <a:noFill/>
-        </p:spPr>
-        <p:txBody>
-          <a:bodyPr wrap="none" lIns="0" rIns="0" tIns="0" bIns="0" anchor="t">
-            <a:spAutoFit/>
-          </a:bodyPr>
-          <a:lstStyle/>
-          <a:p>
-            <a:pPr algn="r">
-              <a:lnSpc>
-                <a:spcPct val="100000"/>
-              </a:lnSpc>
-              <a:spcAft>
-                <a:spcPts val="0"/>
-              </a:spcAft>
-            </a:pPr>
-            <a:r>
-              <a:rPr sz="850" b="0" i="0">
-                <a:solidFill>
-                  <a:srgbClr val="767576"/>
-                </a:solidFill>
-                <a:latin typeface="Arial"/>
-              </a:rPr>
-              <a:t>+12.3bp</a:t>
-            </a:r>
-          </a:p>
-        </p:txBody>
-      </p:sp>
       <p:cxnSp>
         <p:nvCxnSpPr>
-          <p:cNvPr id="31" name="Connector 30"/>
+          <p:cNvPr id="24" name="Connector 23"/>
           <p:cNvCxnSpPr/>
           <p:nvPr/>
         </p:nvCxnSpPr>
         <p:spPr>
           <a:xfrm>
-            <a:off x="4133087" y="3968496"/>
-            <a:ext cx="3931921" cy="0"/>
+            <a:off x="5791200" y="1737360"/>
+            <a:ext cx="0" cy="1207008"/>
           </a:xfrm>
           <a:prstGeom prst="line">
             <a:avLst/>
@@ -6566,142 +5937,16 @@
           </a:fontRef>
         </p:style>
       </p:cxnSp>
-      <p:sp>
-        <p:nvSpPr>
-          <p:cNvPr id="32" name="TextBox 31"/>
-          <p:cNvSpPr txBox="1"/>
-          <p:nvPr/>
-        </p:nvSpPr>
-        <p:spPr>
-          <a:xfrm>
-            <a:off x="4133087" y="4005072"/>
-            <a:ext cx="2029967" cy="164592"/>
-          </a:xfrm>
-          <a:prstGeom prst="rect">
-            <a:avLst/>
-          </a:prstGeom>
-          <a:noFill/>
-        </p:spPr>
-        <p:txBody>
-          <a:bodyPr wrap="none" lIns="0" rIns="0" tIns="0" bIns="0" anchor="t">
-            <a:spAutoFit/>
-          </a:bodyPr>
-          <a:lstStyle/>
-          <a:p>
-            <a:pPr algn="l">
-              <a:lnSpc>
-                <a:spcPct val="100000"/>
-              </a:lnSpc>
-              <a:spcAft>
-                <a:spcPts val="0"/>
-              </a:spcAft>
-            </a:pPr>
-            <a:r>
-              <a:rPr sz="800" b="0" i="0">
-                <a:solidFill>
-                  <a:srgbClr val="000000"/>
-                </a:solidFill>
-                <a:latin typeface="Arial"/>
-              </a:rPr>
-              <a:t>Round trip, share of headroom</a:t>
-            </a:r>
-          </a:p>
-        </p:txBody>
-      </p:sp>
-      <p:sp>
-        <p:nvSpPr>
-          <p:cNvPr id="33" name="TextBox 32"/>
-          <p:cNvSpPr txBox="1"/>
-          <p:nvPr/>
-        </p:nvSpPr>
-        <p:spPr>
-          <a:xfrm>
-            <a:off x="6236207" y="4005072"/>
-            <a:ext cx="914400" cy="164592"/>
-          </a:xfrm>
-          <a:prstGeom prst="rect">
-            <a:avLst/>
-          </a:prstGeom>
-          <a:noFill/>
-        </p:spPr>
-        <p:txBody>
-          <a:bodyPr wrap="none" lIns="0" rIns="0" tIns="0" bIns="0" anchor="t">
-            <a:spAutoFit/>
-          </a:bodyPr>
-          <a:lstStyle/>
-          <a:p>
-            <a:pPr algn="r">
-              <a:lnSpc>
-                <a:spcPct val="100000"/>
-              </a:lnSpc>
-              <a:spcAft>
-                <a:spcPts val="0"/>
-              </a:spcAft>
-            </a:pPr>
-            <a:r>
-              <a:rPr sz="850" b="1" i="0">
-                <a:solidFill>
-                  <a:srgbClr val="DB0011"/>
-                </a:solidFill>
-                <a:latin typeface="Arial"/>
-              </a:rPr>
-              <a:t>11%</a:t>
-            </a:r>
-          </a:p>
-        </p:txBody>
-      </p:sp>
-      <p:sp>
-        <p:nvSpPr>
-          <p:cNvPr id="34" name="TextBox 33"/>
-          <p:cNvSpPr txBox="1"/>
-          <p:nvPr/>
-        </p:nvSpPr>
-        <p:spPr>
-          <a:xfrm>
-            <a:off x="7150607" y="4005072"/>
-            <a:ext cx="914400" cy="164592"/>
-          </a:xfrm>
-          <a:prstGeom prst="rect">
-            <a:avLst/>
-          </a:prstGeom>
-          <a:noFill/>
-        </p:spPr>
-        <p:txBody>
-          <a:bodyPr wrap="none" lIns="0" rIns="0" tIns="0" bIns="0" anchor="t">
-            <a:spAutoFit/>
-          </a:bodyPr>
-          <a:lstStyle/>
-          <a:p>
-            <a:pPr algn="r">
-              <a:lnSpc>
-                <a:spcPct val="100000"/>
-              </a:lnSpc>
-              <a:spcAft>
-                <a:spcPts val="0"/>
-              </a:spcAft>
-            </a:pPr>
-            <a:r>
-              <a:rPr sz="850" b="0" i="0">
-                <a:solidFill>
-                  <a:srgbClr val="767576"/>
-                </a:solidFill>
-                <a:latin typeface="Arial"/>
-              </a:rPr>
-              <a:t>33%</a:t>
-            </a:r>
-          </a:p>
-        </p:txBody>
-      </p:sp>
       <p:cxnSp>
         <p:nvCxnSpPr>
-          <p:cNvPr id="35" name="Connector 34"/>
+          <p:cNvPr id="25" name="Connector 24"/>
           <p:cNvCxnSpPr/>
           <p:nvPr/>
         </p:nvCxnSpPr>
         <p:spPr>
           <a:xfrm>
-            <a:off x="4133087" y="4151376"/>
-            <a:ext cx="3931921" cy="0"/>
+            <a:off x="6480048" y="1737360"/>
+            <a:ext cx="0" cy="1207008"/>
           </a:xfrm>
           <a:prstGeom prst="line">
             <a:avLst/>
@@ -6727,142 +5972,16 @@
           </a:fontRef>
         </p:style>
       </p:cxnSp>
-      <p:sp>
-        <p:nvSpPr>
-          <p:cNvPr id="36" name="TextBox 35"/>
-          <p:cNvSpPr txBox="1"/>
-          <p:nvPr/>
-        </p:nvSpPr>
-        <p:spPr>
-          <a:xfrm>
-            <a:off x="4133087" y="4187952"/>
-            <a:ext cx="2029967" cy="164592"/>
-          </a:xfrm>
-          <a:prstGeom prst="rect">
-            <a:avLst/>
-          </a:prstGeom>
-          <a:noFill/>
-        </p:spPr>
-        <p:txBody>
-          <a:bodyPr wrap="none" lIns="0" rIns="0" tIns="0" bIns="0" anchor="t">
-            <a:spAutoFit/>
-          </a:bodyPr>
-          <a:lstStyle/>
-          <a:p>
-            <a:pPr algn="l">
-              <a:lnSpc>
-                <a:spcPct val="100000"/>
-              </a:lnSpc>
-              <a:spcAft>
-                <a:spcPts val="0"/>
-              </a:spcAft>
-            </a:pPr>
-            <a:r>
-              <a:rPr sz="800" b="0" i="0">
-                <a:solidFill>
-                  <a:srgbClr val="000000"/>
-                </a:solidFill>
-                <a:latin typeface="Arial"/>
-              </a:rPr>
-              <a:t>Risk : reward, net of costs</a:t>
-            </a:r>
-          </a:p>
-        </p:txBody>
-      </p:sp>
-      <p:sp>
-        <p:nvSpPr>
-          <p:cNvPr id="37" name="TextBox 36"/>
-          <p:cNvSpPr txBox="1"/>
-          <p:nvPr/>
-        </p:nvSpPr>
-        <p:spPr>
-          <a:xfrm>
-            <a:off x="6236207" y="4187952"/>
-            <a:ext cx="914400" cy="164592"/>
-          </a:xfrm>
-          <a:prstGeom prst="rect">
-            <a:avLst/>
-          </a:prstGeom>
-          <a:noFill/>
-        </p:spPr>
-        <p:txBody>
-          <a:bodyPr wrap="none" lIns="0" rIns="0" tIns="0" bIns="0" anchor="t">
-            <a:spAutoFit/>
-          </a:bodyPr>
-          <a:lstStyle/>
-          <a:p>
-            <a:pPr algn="r">
-              <a:lnSpc>
-                <a:spcPct val="100000"/>
-              </a:lnSpc>
-              <a:spcAft>
-                <a:spcPts val="0"/>
-              </a:spcAft>
-            </a:pPr>
-            <a:r>
-              <a:rPr sz="850" b="1" i="0">
-                <a:solidFill>
-                  <a:srgbClr val="DB0011"/>
-                </a:solidFill>
-                <a:latin typeface="Arial"/>
-              </a:rPr>
-              <a:t>2.1 : 1</a:t>
-            </a:r>
-          </a:p>
-        </p:txBody>
-      </p:sp>
-      <p:sp>
-        <p:nvSpPr>
-          <p:cNvPr id="38" name="TextBox 37"/>
-          <p:cNvSpPr txBox="1"/>
-          <p:nvPr/>
-        </p:nvSpPr>
-        <p:spPr>
-          <a:xfrm>
-            <a:off x="7150607" y="4187952"/>
-            <a:ext cx="914400" cy="164592"/>
-          </a:xfrm>
-          <a:prstGeom prst="rect">
-            <a:avLst/>
-          </a:prstGeom>
-          <a:noFill/>
-        </p:spPr>
-        <p:txBody>
-          <a:bodyPr wrap="none" lIns="0" rIns="0" tIns="0" bIns="0" anchor="t">
-            <a:spAutoFit/>
-          </a:bodyPr>
-          <a:lstStyle/>
-          <a:p>
-            <a:pPr algn="r">
-              <a:lnSpc>
-                <a:spcPct val="100000"/>
-              </a:lnSpc>
-              <a:spcAft>
-                <a:spcPts val="0"/>
-              </a:spcAft>
-            </a:pPr>
-            <a:r>
-              <a:rPr sz="850" b="0" i="0">
-                <a:solidFill>
-                  <a:srgbClr val="767576"/>
-                </a:solidFill>
-                <a:latin typeface="Arial"/>
-              </a:rPr>
-              <a:t>1.1 : 1</a:t>
-            </a:r>
-          </a:p>
-        </p:txBody>
-      </p:sp>
       <p:cxnSp>
         <p:nvCxnSpPr>
-          <p:cNvPr id="39" name="Connector 38"/>
+          <p:cNvPr id="26" name="Connector 25"/>
           <p:cNvCxnSpPr/>
           <p:nvPr/>
         </p:nvCxnSpPr>
         <p:spPr>
           <a:xfrm>
-            <a:off x="4133087" y="4334256"/>
-            <a:ext cx="3931921" cy="0"/>
+            <a:off x="7168896" y="1737360"/>
+            <a:ext cx="0" cy="1207008"/>
           </a:xfrm>
           <a:prstGeom prst="line">
             <a:avLst/>
@@ -6890,14 +6009,637 @@
       </p:cxnSp>
       <p:sp>
         <p:nvSpPr>
+          <p:cNvPr id="27" name="Rectangle 26"/>
+          <p:cNvSpPr/>
+          <p:nvPr/>
+        </p:nvSpPr>
+        <p:spPr>
+          <a:xfrm>
+            <a:off x="5126844" y="1956816"/>
+            <a:ext cx="1237630" cy="164592"/>
+          </a:xfrm>
+          <a:prstGeom prst="rect">
+            <a:avLst/>
+          </a:prstGeom>
+          <a:solidFill>
+            <a:srgbClr val="D7D8D6"/>
+          </a:solidFill>
+          <a:ln>
+            <a:noFill/>
+          </a:ln>
+          <a:effectLst/>
+        </p:spPr>
+        <p:style>
+          <a:lnRef idx="1">
+            <a:schemeClr val="accent1"/>
+          </a:lnRef>
+          <a:fillRef idx="3">
+            <a:schemeClr val="accent1"/>
+          </a:fillRef>
+          <a:effectRef idx="2">
+            <a:schemeClr val="accent1"/>
+          </a:effectRef>
+          <a:fontRef idx="minor">
+            <a:schemeClr val="lt1"/>
+          </a:fontRef>
+        </p:style>
+        <p:txBody>
+          <a:bodyPr rtlCol="0" anchor="ctr"/>
+          <a:lstStyle/>
+          <a:p/>
+        </p:txBody>
+      </p:sp>
+      <p:sp>
+        <p:nvSpPr>
+          <p:cNvPr id="28" name="Rectangle 27"/>
+          <p:cNvSpPr/>
+          <p:nvPr/>
+        </p:nvSpPr>
+        <p:spPr>
+          <a:xfrm>
+            <a:off x="6092762" y="1956816"/>
+            <a:ext cx="271712" cy="164592"/>
+          </a:xfrm>
+          <a:prstGeom prst="rect">
+            <a:avLst/>
+          </a:prstGeom>
+          <a:solidFill>
+            <a:srgbClr val="F4B4BB"/>
+          </a:solidFill>
+          <a:ln>
+            <a:noFill/>
+          </a:ln>
+          <a:effectLst/>
+        </p:spPr>
+        <p:style>
+          <a:lnRef idx="1">
+            <a:schemeClr val="accent1"/>
+          </a:lnRef>
+          <a:fillRef idx="3">
+            <a:schemeClr val="accent1"/>
+          </a:fillRef>
+          <a:effectRef idx="2">
+            <a:schemeClr val="accent1"/>
+          </a:effectRef>
+          <a:fontRef idx="minor">
+            <a:schemeClr val="lt1"/>
+          </a:fontRef>
+        </p:style>
+        <p:txBody>
+          <a:bodyPr rtlCol="0" anchor="ctr"/>
+          <a:lstStyle/>
+          <a:p/>
+        </p:txBody>
+      </p:sp>
+      <p:sp>
+        <p:nvSpPr>
+          <p:cNvPr id="29" name="Rectangle 28"/>
+          <p:cNvSpPr/>
+          <p:nvPr/>
+        </p:nvSpPr>
+        <p:spPr>
+          <a:xfrm>
+            <a:off x="5639545" y="1924812"/>
+            <a:ext cx="20116" cy="228600"/>
+          </a:xfrm>
+          <a:prstGeom prst="rect">
+            <a:avLst/>
+          </a:prstGeom>
+          <a:solidFill>
+            <a:srgbClr val="44546A"/>
+          </a:solidFill>
+          <a:ln>
+            <a:noFill/>
+          </a:ln>
+          <a:effectLst/>
+        </p:spPr>
+        <p:style>
+          <a:lnRef idx="1">
+            <a:schemeClr val="accent1"/>
+          </a:lnRef>
+          <a:fillRef idx="3">
+            <a:schemeClr val="accent1"/>
+          </a:fillRef>
+          <a:effectRef idx="2">
+            <a:schemeClr val="accent1"/>
+          </a:effectRef>
+          <a:fontRef idx="minor">
+            <a:schemeClr val="lt1"/>
+          </a:fontRef>
+        </p:style>
+        <p:txBody>
+          <a:bodyPr rtlCol="0" anchor="ctr"/>
+          <a:lstStyle/>
+          <a:p/>
+        </p:txBody>
+      </p:sp>
+      <p:sp>
+        <p:nvSpPr>
+          <p:cNvPr id="30" name="Rectangle 29"/>
+          <p:cNvSpPr/>
+          <p:nvPr/>
+        </p:nvSpPr>
+        <p:spPr>
+          <a:xfrm>
+            <a:off x="6068987" y="1892807"/>
+            <a:ext cx="47548" cy="292608"/>
+          </a:xfrm>
+          <a:prstGeom prst="rect">
+            <a:avLst/>
+          </a:prstGeom>
+          <a:solidFill>
+            <a:srgbClr val="DB0011"/>
+          </a:solidFill>
+          <a:ln>
+            <a:noFill/>
+          </a:ln>
+          <a:effectLst/>
+        </p:spPr>
+        <p:style>
+          <a:lnRef idx="1">
+            <a:schemeClr val="accent1"/>
+          </a:lnRef>
+          <a:fillRef idx="3">
+            <a:schemeClr val="accent1"/>
+          </a:fillRef>
+          <a:effectRef idx="2">
+            <a:schemeClr val="accent1"/>
+          </a:effectRef>
+          <a:fontRef idx="minor">
+            <a:schemeClr val="lt1"/>
+          </a:fontRef>
+        </p:style>
+        <p:txBody>
+          <a:bodyPr rtlCol="0" anchor="ctr"/>
+          <a:lstStyle/>
+          <a:p/>
+        </p:txBody>
+      </p:sp>
+      <p:sp>
+        <p:nvSpPr>
+          <p:cNvPr id="31" name="TextBox 30"/>
+          <p:cNvSpPr txBox="1"/>
+          <p:nvPr/>
+        </p:nvSpPr>
+        <p:spPr>
+          <a:xfrm>
+            <a:off x="5578090" y="1709928"/>
+            <a:ext cx="822960" cy="182880"/>
+          </a:xfrm>
+          <a:prstGeom prst="rect">
+            <a:avLst/>
+          </a:prstGeom>
+          <a:noFill/>
+        </p:spPr>
+        <p:txBody>
+          <a:bodyPr wrap="none" lIns="0" rIns="0" tIns="0" bIns="0" anchor="t">
+            <a:spAutoFit/>
+          </a:bodyPr>
+          <a:lstStyle/>
+          <a:p>
+            <a:pPr algn="r">
+              <a:lnSpc>
+                <a:spcPct val="100000"/>
+              </a:lnSpc>
+              <a:spcAft>
+                <a:spcPts val="0"/>
+              </a:spcAft>
+            </a:pPr>
+            <a:r>
+              <a:rPr sz="850" b="1" i="0">
+                <a:solidFill>
+                  <a:srgbClr val="DB0011"/>
+                </a:solidFill>
+                <a:latin typeface="Arial"/>
+              </a:rPr>
+              <a:t>+35.5bp</a:t>
+            </a:r>
+          </a:p>
+        </p:txBody>
+      </p:sp>
+      <p:sp>
+        <p:nvSpPr>
+          <p:cNvPr id="32" name="TextBox 31"/>
+          <p:cNvSpPr txBox="1"/>
+          <p:nvPr/>
+        </p:nvSpPr>
+        <p:spPr>
+          <a:xfrm>
+            <a:off x="4133087" y="1933955"/>
+            <a:ext cx="896112" cy="210312"/>
+          </a:xfrm>
+          <a:prstGeom prst="rect">
+            <a:avLst/>
+          </a:prstGeom>
+          <a:noFill/>
+        </p:spPr>
+        <p:txBody>
+          <a:bodyPr wrap="none" lIns="0" rIns="0" tIns="0" bIns="0" anchor="t">
+            <a:spAutoFit/>
+          </a:bodyPr>
+          <a:lstStyle/>
+          <a:p>
+            <a:pPr algn="l">
+              <a:lnSpc>
+                <a:spcPct val="100000"/>
+              </a:lnSpc>
+              <a:spcAft>
+                <a:spcPts val="0"/>
+              </a:spcAft>
+            </a:pPr>
+            <a:r>
+              <a:rPr sz="1000" b="1" i="0">
+                <a:solidFill>
+                  <a:srgbClr val="DB0011"/>
+                </a:solidFill>
+                <a:latin typeface="Arial"/>
+              </a:rPr>
+              <a:t>JGB 2s10s</a:t>
+            </a:r>
+          </a:p>
+        </p:txBody>
+      </p:sp>
+      <p:sp>
+        <p:nvSpPr>
+          <p:cNvPr id="33" name="TextBox 32"/>
+          <p:cNvSpPr txBox="1"/>
+          <p:nvPr/>
+        </p:nvSpPr>
+        <p:spPr>
+          <a:xfrm>
+            <a:off x="7168896" y="1933955"/>
+            <a:ext cx="987552" cy="210312"/>
+          </a:xfrm>
+          <a:prstGeom prst="rect">
+            <a:avLst/>
+          </a:prstGeom>
+          <a:noFill/>
+        </p:spPr>
+        <p:txBody>
+          <a:bodyPr wrap="none" lIns="0" rIns="0" tIns="0" bIns="0" anchor="t">
+            <a:spAutoFit/>
+          </a:bodyPr>
+          <a:lstStyle/>
+          <a:p>
+            <a:pPr algn="r">
+              <a:lnSpc>
+                <a:spcPct val="100000"/>
+              </a:lnSpc>
+              <a:spcAft>
+                <a:spcPts val="0"/>
+              </a:spcAft>
+            </a:pPr>
+            <a:r>
+              <a:rPr sz="1000" b="1" i="0">
+                <a:solidFill>
+                  <a:srgbClr val="DB0011"/>
+                </a:solidFill>
+                <a:latin typeface="Arial"/>
+              </a:rPr>
+              <a:t>129bp · 93rd</a:t>
+            </a:r>
+          </a:p>
+        </p:txBody>
+      </p:sp>
+      <p:sp>
+        <p:nvSpPr>
+          <p:cNvPr id="34" name="Rectangle 33"/>
+          <p:cNvSpPr/>
+          <p:nvPr/>
+        </p:nvSpPr>
+        <p:spPr>
+          <a:xfrm>
+            <a:off x="5425345" y="2560320"/>
+            <a:ext cx="1665481" cy="164592"/>
+          </a:xfrm>
+          <a:prstGeom prst="rect">
+            <a:avLst/>
+          </a:prstGeom>
+          <a:solidFill>
+            <a:srgbClr val="D7D8D6"/>
+          </a:solidFill>
+          <a:ln>
+            <a:noFill/>
+          </a:ln>
+          <a:effectLst/>
+        </p:spPr>
+        <p:style>
+          <a:lnRef idx="1">
+            <a:schemeClr val="accent1"/>
+          </a:lnRef>
+          <a:fillRef idx="3">
+            <a:schemeClr val="accent1"/>
+          </a:fillRef>
+          <a:effectRef idx="2">
+            <a:schemeClr val="accent1"/>
+          </a:effectRef>
+          <a:fontRef idx="minor">
+            <a:schemeClr val="lt1"/>
+          </a:fontRef>
+        </p:style>
+        <p:txBody>
+          <a:bodyPr rtlCol="0" anchor="ctr"/>
+          <a:lstStyle/>
+          <a:p/>
+        </p:txBody>
+      </p:sp>
+      <p:sp>
+        <p:nvSpPr>
+          <p:cNvPr id="35" name="Rectangle 34"/>
+          <p:cNvSpPr/>
+          <p:nvPr/>
+        </p:nvSpPr>
+        <p:spPr>
+          <a:xfrm>
+            <a:off x="6996684" y="2560320"/>
+            <a:ext cx="94142" cy="164592"/>
+          </a:xfrm>
+          <a:prstGeom prst="rect">
+            <a:avLst/>
+          </a:prstGeom>
+          <a:solidFill>
+            <a:srgbClr val="F4B4BB"/>
+          </a:solidFill>
+          <a:ln>
+            <a:noFill/>
+          </a:ln>
+          <a:effectLst/>
+        </p:spPr>
+        <p:style>
+          <a:lnRef idx="1">
+            <a:schemeClr val="accent1"/>
+          </a:lnRef>
+          <a:fillRef idx="3">
+            <a:schemeClr val="accent1"/>
+          </a:fillRef>
+          <a:effectRef idx="2">
+            <a:schemeClr val="accent1"/>
+          </a:effectRef>
+          <a:fontRef idx="minor">
+            <a:schemeClr val="lt1"/>
+          </a:fontRef>
+        </p:style>
+        <p:txBody>
+          <a:bodyPr rtlCol="0" anchor="ctr"/>
+          <a:lstStyle/>
+          <a:p/>
+        </p:txBody>
+      </p:sp>
+      <p:sp>
+        <p:nvSpPr>
+          <p:cNvPr id="36" name="Rectangle 35"/>
+          <p:cNvSpPr/>
+          <p:nvPr/>
+        </p:nvSpPr>
+        <p:spPr>
+          <a:xfrm>
+            <a:off x="6300073" y="2528316"/>
+            <a:ext cx="20116" cy="228600"/>
+          </a:xfrm>
+          <a:prstGeom prst="rect">
+            <a:avLst/>
+          </a:prstGeom>
+          <a:solidFill>
+            <a:srgbClr val="44546A"/>
+          </a:solidFill>
+          <a:ln>
+            <a:noFill/>
+          </a:ln>
+          <a:effectLst/>
+        </p:spPr>
+        <p:style>
+          <a:lnRef idx="1">
+            <a:schemeClr val="accent1"/>
+          </a:lnRef>
+          <a:fillRef idx="3">
+            <a:schemeClr val="accent1"/>
+          </a:fillRef>
+          <a:effectRef idx="2">
+            <a:schemeClr val="accent1"/>
+          </a:effectRef>
+          <a:fontRef idx="minor">
+            <a:schemeClr val="lt1"/>
+          </a:fontRef>
+        </p:style>
+        <p:txBody>
+          <a:bodyPr rtlCol="0" anchor="ctr"/>
+          <a:lstStyle/>
+          <a:p/>
+        </p:txBody>
+      </p:sp>
+      <p:sp>
+        <p:nvSpPr>
+          <p:cNvPr id="37" name="Rectangle 36"/>
+          <p:cNvSpPr/>
+          <p:nvPr/>
+        </p:nvSpPr>
+        <p:spPr>
+          <a:xfrm>
+            <a:off x="6972909" y="2496312"/>
+            <a:ext cx="47548" cy="292608"/>
+          </a:xfrm>
+          <a:prstGeom prst="rect">
+            <a:avLst/>
+          </a:prstGeom>
+          <a:solidFill>
+            <a:srgbClr val="DB0011"/>
+          </a:solidFill>
+          <a:ln>
+            <a:noFill/>
+          </a:ln>
+          <a:effectLst/>
+        </p:spPr>
+        <p:style>
+          <a:lnRef idx="1">
+            <a:schemeClr val="accent1"/>
+          </a:lnRef>
+          <a:fillRef idx="3">
+            <a:schemeClr val="accent1"/>
+          </a:fillRef>
+          <a:effectRef idx="2">
+            <a:schemeClr val="accent1"/>
+          </a:effectRef>
+          <a:fontRef idx="minor">
+            <a:schemeClr val="lt1"/>
+          </a:fontRef>
+        </p:style>
+        <p:txBody>
+          <a:bodyPr rtlCol="0" anchor="ctr"/>
+          <a:lstStyle/>
+          <a:p/>
+        </p:txBody>
+      </p:sp>
+      <p:sp>
+        <p:nvSpPr>
+          <p:cNvPr id="38" name="TextBox 37"/>
+          <p:cNvSpPr txBox="1"/>
+          <p:nvPr/>
+        </p:nvSpPr>
+        <p:spPr>
+          <a:xfrm>
+            <a:off x="6304442" y="2313432"/>
+            <a:ext cx="822960" cy="182880"/>
+          </a:xfrm>
+          <a:prstGeom prst="rect">
+            <a:avLst/>
+          </a:prstGeom>
+          <a:noFill/>
+        </p:spPr>
+        <p:txBody>
+          <a:bodyPr wrap="none" lIns="0" rIns="0" tIns="0" bIns="0" anchor="t">
+            <a:spAutoFit/>
+          </a:bodyPr>
+          <a:lstStyle/>
+          <a:p>
+            <a:pPr algn="r">
+              <a:lnSpc>
+                <a:spcPct val="100000"/>
+              </a:lnSpc>
+              <a:spcAft>
+                <a:spcPts val="0"/>
+              </a:spcAft>
+            </a:pPr>
+            <a:r>
+              <a:rPr sz="850" b="1" i="0">
+                <a:solidFill>
+                  <a:srgbClr val="DB0011"/>
+                </a:solidFill>
+                <a:latin typeface="Arial"/>
+              </a:rPr>
+              <a:t>+12.3bp</a:t>
+            </a:r>
+          </a:p>
+        </p:txBody>
+      </p:sp>
+      <p:sp>
+        <p:nvSpPr>
+          <p:cNvPr id="39" name="TextBox 38"/>
+          <p:cNvSpPr txBox="1"/>
+          <p:nvPr/>
+        </p:nvSpPr>
+        <p:spPr>
+          <a:xfrm>
+            <a:off x="4133087" y="2537460"/>
+            <a:ext cx="896112" cy="210312"/>
+          </a:xfrm>
+          <a:prstGeom prst="rect">
+            <a:avLst/>
+          </a:prstGeom>
+          <a:noFill/>
+        </p:spPr>
+        <p:txBody>
+          <a:bodyPr wrap="none" lIns="0" rIns="0" tIns="0" bIns="0" anchor="t">
+            <a:spAutoFit/>
+          </a:bodyPr>
+          <a:lstStyle/>
+          <a:p>
+            <a:pPr algn="l">
+              <a:lnSpc>
+                <a:spcPct val="100000"/>
+              </a:lnSpc>
+              <a:spcAft>
+                <a:spcPts val="0"/>
+              </a:spcAft>
+            </a:pPr>
+            <a:r>
+              <a:rPr sz="1000" b="1" i="0">
+                <a:solidFill>
+                  <a:srgbClr val="767576"/>
+                </a:solidFill>
+                <a:latin typeface="Arial"/>
+              </a:rPr>
+              <a:t>JGB 2s30s</a:t>
+            </a:r>
+          </a:p>
+        </p:txBody>
+      </p:sp>
+      <p:sp>
+        <p:nvSpPr>
           <p:cNvPr id="40" name="TextBox 39"/>
           <p:cNvSpPr txBox="1"/>
           <p:nvPr/>
         </p:nvSpPr>
         <p:spPr>
           <a:xfrm>
-            <a:off x="4133087" y="4480560"/>
-            <a:ext cx="1984248" cy="219456"/>
+            <a:off x="7168896" y="2537460"/>
+            <a:ext cx="987552" cy="210312"/>
+          </a:xfrm>
+          <a:prstGeom prst="rect">
+            <a:avLst/>
+          </a:prstGeom>
+          <a:noFill/>
+        </p:spPr>
+        <p:txBody>
+          <a:bodyPr wrap="none" lIns="0" rIns="0" tIns="0" bIns="0" anchor="t">
+            <a:spAutoFit/>
+          </a:bodyPr>
+          <a:lstStyle/>
+          <a:p>
+            <a:pPr algn="r">
+              <a:lnSpc>
+                <a:spcPct val="100000"/>
+              </a:lnSpc>
+              <a:spcAft>
+                <a:spcPts val="0"/>
+              </a:spcAft>
+            </a:pPr>
+            <a:r>
+              <a:rPr sz="1000" b="0" i="0">
+                <a:solidFill>
+                  <a:srgbClr val="767576"/>
+                </a:solidFill>
+                <a:latin typeface="Arial"/>
+              </a:rPr>
+              <a:t>248bp · 99th</a:t>
+            </a:r>
+          </a:p>
+        </p:txBody>
+      </p:sp>
+      <p:cxnSp>
+        <p:nvCxnSpPr>
+          <p:cNvPr id="41" name="Connector 40"/>
+          <p:cNvCxnSpPr/>
+          <p:nvPr/>
+        </p:nvCxnSpPr>
+        <p:spPr>
+          <a:xfrm>
+            <a:off x="5102352" y="2944368"/>
+            <a:ext cx="2066544" cy="0"/>
+          </a:xfrm>
+          <a:prstGeom prst="line">
+            <a:avLst/>
+          </a:prstGeom>
+          <a:ln w="9525">
+            <a:solidFill>
+              <a:srgbClr val="000000"/>
+            </a:solidFill>
+          </a:ln>
+        </p:spPr>
+        <p:style>
+          <a:lnRef idx="2">
+            <a:schemeClr val="accent1"/>
+          </a:lnRef>
+          <a:fillRef idx="0">
+            <a:schemeClr val="accent1"/>
+          </a:fillRef>
+          <a:effectRef idx="1">
+            <a:schemeClr val="accent1"/>
+          </a:effectRef>
+          <a:fontRef idx="minor">
+            <a:schemeClr val="tx1"/>
+          </a:fontRef>
+        </p:style>
+      </p:cxnSp>
+      <p:sp>
+        <p:nvSpPr>
+          <p:cNvPr id="42" name="TextBox 41"/>
+          <p:cNvSpPr txBox="1"/>
+          <p:nvPr/>
+        </p:nvSpPr>
+        <p:spPr>
+          <a:xfrm>
+            <a:off x="4782312" y="2980944"/>
+            <a:ext cx="640080" cy="182880"/>
           </a:xfrm>
           <a:prstGeom prst="rect">
             <a:avLst/>
@@ -6919,27 +6661,27 @@
               </a:spcAft>
             </a:pPr>
             <a:r>
-              <a:rPr sz="1150" b="1" i="0">
+              <a:rPr sz="850" b="0" i="0">
                 <a:solidFill>
-                  <a:srgbClr val="DB0011"/>
+                  <a:srgbClr val="767576"/>
                 </a:solidFill>
                 <a:latin typeface="Arial"/>
               </a:rPr>
-              <a:t>93rd vs 99th</a:t>
-            </a:r>
-          </a:p>
-        </p:txBody>
-      </p:sp>
-      <p:sp>
-        <p:nvSpPr>
-          <p:cNvPr id="41" name="TextBox 40"/>
+              <a:t>0</a:t>
+            </a:r>
+          </a:p>
+        </p:txBody>
+      </p:sp>
+      <p:sp>
+        <p:nvSpPr>
+          <p:cNvPr id="43" name="TextBox 42"/>
           <p:cNvSpPr txBox="1"/>
           <p:nvPr/>
         </p:nvSpPr>
         <p:spPr>
           <a:xfrm>
-            <a:off x="4133087" y="4681728"/>
-            <a:ext cx="1984248" cy="182880"/>
+            <a:off x="5471160" y="2980944"/>
+            <a:ext cx="640080" cy="182880"/>
           </a:xfrm>
           <a:prstGeom prst="rect">
             <a:avLst/>
@@ -6961,27 +6703,27 @@
               </a:spcAft>
             </a:pPr>
             <a:r>
-              <a:rPr sz="800" b="0" i="0">
+              <a:rPr sz="850" b="0" i="0">
                 <a:solidFill>
                   <a:srgbClr val="767576"/>
                 </a:solidFill>
                 <a:latin typeface="Arial"/>
               </a:rPr>
-              <a:t>percentile since 2000, vs 2s30s</a:t>
-            </a:r>
-          </a:p>
-        </p:txBody>
-      </p:sp>
-      <p:sp>
-        <p:nvSpPr>
-          <p:cNvPr id="42" name="TextBox 41"/>
+              <a:t>+90</a:t>
+            </a:r>
+          </a:p>
+        </p:txBody>
+      </p:sp>
+      <p:sp>
+        <p:nvSpPr>
+          <p:cNvPr id="44" name="TextBox 43"/>
           <p:cNvSpPr txBox="1"/>
           <p:nvPr/>
         </p:nvSpPr>
         <p:spPr>
           <a:xfrm>
-            <a:off x="6208776" y="4480560"/>
-            <a:ext cx="1984248" cy="219456"/>
+            <a:off x="6160008" y="2980944"/>
+            <a:ext cx="640080" cy="182880"/>
           </a:xfrm>
           <a:prstGeom prst="rect">
             <a:avLst/>
@@ -7003,27 +6745,27 @@
               </a:spcAft>
             </a:pPr>
             <a:r>
-              <a:rPr sz="1150" b="1" i="0">
+              <a:rPr sz="850" b="0" i="0">
                 <a:solidFill>
-                  <a:srgbClr val="DB0011"/>
+                  <a:srgbClr val="767576"/>
                 </a:solidFill>
                 <a:latin typeface="Arial"/>
               </a:rPr>
-              <a:t>−5.8bp</a:t>
-            </a:r>
-          </a:p>
-        </p:txBody>
-      </p:sp>
-      <p:sp>
-        <p:nvSpPr>
-          <p:cNvPr id="43" name="TextBox 42"/>
+              <a:t>+180</a:t>
+            </a:r>
+          </a:p>
+        </p:txBody>
+      </p:sp>
+      <p:sp>
+        <p:nvSpPr>
+          <p:cNvPr id="45" name="TextBox 44"/>
           <p:cNvSpPr txBox="1"/>
           <p:nvPr/>
         </p:nvSpPr>
         <p:spPr>
           <a:xfrm>
-            <a:off x="6208776" y="4681728"/>
-            <a:ext cx="1984248" cy="182880"/>
+            <a:off x="6848856" y="2980944"/>
+            <a:ext cx="640080" cy="182880"/>
           </a:xfrm>
           <a:prstGeom prst="rect">
             <a:avLst/>
@@ -7045,6 +6787,1112 @@
               </a:spcAft>
             </a:pPr>
             <a:r>
+              <a:rPr sz="850" b="0" i="0">
+                <a:solidFill>
+                  <a:srgbClr val="767576"/>
+                </a:solidFill>
+                <a:latin typeface="Arial"/>
+              </a:rPr>
+              <a:t>+270</a:t>
+            </a:r>
+          </a:p>
+        </p:txBody>
+      </p:sp>
+      <p:sp>
+        <p:nvSpPr>
+          <p:cNvPr id="46" name="Rectangle 45"/>
+          <p:cNvSpPr/>
+          <p:nvPr/>
+        </p:nvSpPr>
+        <p:spPr>
+          <a:xfrm>
+            <a:off x="4133087" y="3200400"/>
+            <a:ext cx="47548" cy="146304"/>
+          </a:xfrm>
+          <a:prstGeom prst="rect">
+            <a:avLst/>
+          </a:prstGeom>
+          <a:solidFill>
+            <a:srgbClr val="DB0011"/>
+          </a:solidFill>
+          <a:ln>
+            <a:noFill/>
+          </a:ln>
+          <a:effectLst/>
+        </p:spPr>
+        <p:style>
+          <a:lnRef idx="1">
+            <a:schemeClr val="accent1"/>
+          </a:lnRef>
+          <a:fillRef idx="3">
+            <a:schemeClr val="accent1"/>
+          </a:fillRef>
+          <a:effectRef idx="2">
+            <a:schemeClr val="accent1"/>
+          </a:effectRef>
+          <a:fontRef idx="minor">
+            <a:schemeClr val="lt1"/>
+          </a:fontRef>
+        </p:style>
+        <p:txBody>
+          <a:bodyPr rtlCol="0" anchor="ctr"/>
+          <a:lstStyle/>
+          <a:p/>
+        </p:txBody>
+      </p:sp>
+      <p:sp>
+        <p:nvSpPr>
+          <p:cNvPr id="47" name="TextBox 46"/>
+          <p:cNvSpPr txBox="1"/>
+          <p:nvPr/>
+        </p:nvSpPr>
+        <p:spPr>
+          <a:xfrm>
+            <a:off x="4235500" y="3182112"/>
+            <a:ext cx="1872691" cy="182880"/>
+          </a:xfrm>
+          <a:prstGeom prst="rect">
+            <a:avLst/>
+          </a:prstGeom>
+          <a:noFill/>
+        </p:spPr>
+        <p:txBody>
+          <a:bodyPr wrap="none" lIns="0" rIns="0" tIns="0" bIns="0" anchor="t">
+            <a:spAutoFit/>
+          </a:bodyPr>
+          <a:lstStyle/>
+          <a:p>
+            <a:pPr algn="l">
+              <a:lnSpc>
+                <a:spcPct val="100000"/>
+              </a:lnSpc>
+              <a:spcAft>
+                <a:spcPts val="0"/>
+              </a:spcAft>
+            </a:pPr>
+            <a:r>
+              <a:rPr sz="800" b="0" i="0">
+                <a:solidFill>
+                  <a:srgbClr val="767576"/>
+                </a:solidFill>
+                <a:latin typeface="Arial"/>
+              </a:rPr>
+              <a:t>Today</a:t>
+            </a:r>
+          </a:p>
+        </p:txBody>
+      </p:sp>
+      <p:sp>
+        <p:nvSpPr>
+          <p:cNvPr id="48" name="Rectangle 47"/>
+          <p:cNvSpPr/>
+          <p:nvPr/>
+        </p:nvSpPr>
+        <p:spPr>
+          <a:xfrm>
+            <a:off x="6163056" y="3223260"/>
+            <a:ext cx="182880" cy="100584"/>
+          </a:xfrm>
+          <a:prstGeom prst="rect">
+            <a:avLst/>
+          </a:prstGeom>
+          <a:solidFill>
+            <a:srgbClr val="F4B4BB"/>
+          </a:solidFill>
+          <a:ln>
+            <a:noFill/>
+          </a:ln>
+          <a:effectLst/>
+        </p:spPr>
+        <p:style>
+          <a:lnRef idx="1">
+            <a:schemeClr val="accent1"/>
+          </a:lnRef>
+          <a:fillRef idx="3">
+            <a:schemeClr val="accent1"/>
+          </a:fillRef>
+          <a:effectRef idx="2">
+            <a:schemeClr val="accent1"/>
+          </a:effectRef>
+          <a:fontRef idx="minor">
+            <a:schemeClr val="lt1"/>
+          </a:fontRef>
+        </p:style>
+        <p:txBody>
+          <a:bodyPr rtlCol="0" anchor="ctr"/>
+          <a:lstStyle/>
+          <a:p/>
+        </p:txBody>
+      </p:sp>
+      <p:sp>
+        <p:nvSpPr>
+          <p:cNvPr id="49" name="TextBox 48"/>
+          <p:cNvSpPr txBox="1"/>
+          <p:nvPr/>
+        </p:nvSpPr>
+        <p:spPr>
+          <a:xfrm>
+            <a:off x="6400800" y="3182112"/>
+            <a:ext cx="1737360" cy="182880"/>
+          </a:xfrm>
+          <a:prstGeom prst="rect">
+            <a:avLst/>
+          </a:prstGeom>
+          <a:noFill/>
+        </p:spPr>
+        <p:txBody>
+          <a:bodyPr wrap="none" lIns="0" rIns="0" tIns="0" bIns="0" anchor="t">
+            <a:spAutoFit/>
+          </a:bodyPr>
+          <a:lstStyle/>
+          <a:p>
+            <a:pPr algn="l">
+              <a:lnSpc>
+                <a:spcPct val="100000"/>
+              </a:lnSpc>
+              <a:spcAft>
+                <a:spcPts val="0"/>
+              </a:spcAft>
+            </a:pPr>
+            <a:r>
+              <a:rPr sz="800" b="0" i="0">
+                <a:solidFill>
+                  <a:srgbClr val="767576"/>
+                </a:solidFill>
+                <a:latin typeface="Arial"/>
+              </a:rPr>
+              <a:t>Room to the high</a:t>
+            </a:r>
+          </a:p>
+        </p:txBody>
+      </p:sp>
+      <p:sp>
+        <p:nvSpPr>
+          <p:cNvPr id="50" name="Rectangle 49"/>
+          <p:cNvSpPr/>
+          <p:nvPr/>
+        </p:nvSpPr>
+        <p:spPr>
+          <a:xfrm>
+            <a:off x="4133087" y="3383280"/>
+            <a:ext cx="20116" cy="146304"/>
+          </a:xfrm>
+          <a:prstGeom prst="rect">
+            <a:avLst/>
+          </a:prstGeom>
+          <a:solidFill>
+            <a:srgbClr val="44546A"/>
+          </a:solidFill>
+          <a:ln>
+            <a:noFill/>
+          </a:ln>
+          <a:effectLst/>
+        </p:spPr>
+        <p:style>
+          <a:lnRef idx="1">
+            <a:schemeClr val="accent1"/>
+          </a:lnRef>
+          <a:fillRef idx="3">
+            <a:schemeClr val="accent1"/>
+          </a:fillRef>
+          <a:effectRef idx="2">
+            <a:schemeClr val="accent1"/>
+          </a:effectRef>
+          <a:fontRef idx="minor">
+            <a:schemeClr val="lt1"/>
+          </a:fontRef>
+        </p:style>
+        <p:txBody>
+          <a:bodyPr rtlCol="0" anchor="ctr"/>
+          <a:lstStyle/>
+          <a:p/>
+        </p:txBody>
+      </p:sp>
+      <p:sp>
+        <p:nvSpPr>
+          <p:cNvPr id="51" name="TextBox 50"/>
+          <p:cNvSpPr txBox="1"/>
+          <p:nvPr/>
+        </p:nvSpPr>
+        <p:spPr>
+          <a:xfrm>
+            <a:off x="4208068" y="3364992"/>
+            <a:ext cx="1900123" cy="182880"/>
+          </a:xfrm>
+          <a:prstGeom prst="rect">
+            <a:avLst/>
+          </a:prstGeom>
+          <a:noFill/>
+        </p:spPr>
+        <p:txBody>
+          <a:bodyPr wrap="none" lIns="0" rIns="0" tIns="0" bIns="0" anchor="t">
+            <a:spAutoFit/>
+          </a:bodyPr>
+          <a:lstStyle/>
+          <a:p>
+            <a:pPr algn="l">
+              <a:lnSpc>
+                <a:spcPct val="100000"/>
+              </a:lnSpc>
+              <a:spcAft>
+                <a:spcPts val="0"/>
+              </a:spcAft>
+            </a:pPr>
+            <a:r>
+              <a:rPr sz="800" b="0" i="0">
+                <a:solidFill>
+                  <a:srgbClr val="767576"/>
+                </a:solidFill>
+                <a:latin typeface="Arial"/>
+              </a:rPr>
+              <a:t>Mean</a:t>
+            </a:r>
+          </a:p>
+        </p:txBody>
+      </p:sp>
+      <p:sp>
+        <p:nvSpPr>
+          <p:cNvPr id="52" name="Rectangle 51"/>
+          <p:cNvSpPr/>
+          <p:nvPr/>
+        </p:nvSpPr>
+        <p:spPr>
+          <a:xfrm>
+            <a:off x="6163056" y="3406140"/>
+            <a:ext cx="182880" cy="100584"/>
+          </a:xfrm>
+          <a:prstGeom prst="rect">
+            <a:avLst/>
+          </a:prstGeom>
+          <a:solidFill>
+            <a:srgbClr val="D7D8D6"/>
+          </a:solidFill>
+          <a:ln>
+            <a:noFill/>
+          </a:ln>
+          <a:effectLst/>
+        </p:spPr>
+        <p:style>
+          <a:lnRef idx="1">
+            <a:schemeClr val="accent1"/>
+          </a:lnRef>
+          <a:fillRef idx="3">
+            <a:schemeClr val="accent1"/>
+          </a:fillRef>
+          <a:effectRef idx="2">
+            <a:schemeClr val="accent1"/>
+          </a:effectRef>
+          <a:fontRef idx="minor">
+            <a:schemeClr val="lt1"/>
+          </a:fontRef>
+        </p:style>
+        <p:txBody>
+          <a:bodyPr rtlCol="0" anchor="ctr"/>
+          <a:lstStyle/>
+          <a:p/>
+        </p:txBody>
+      </p:sp>
+      <p:sp>
+        <p:nvSpPr>
+          <p:cNvPr id="53" name="TextBox 52"/>
+          <p:cNvSpPr txBox="1"/>
+          <p:nvPr/>
+        </p:nvSpPr>
+        <p:spPr>
+          <a:xfrm>
+            <a:off x="6400800" y="3364992"/>
+            <a:ext cx="1737360" cy="182880"/>
+          </a:xfrm>
+          <a:prstGeom prst="rect">
+            <a:avLst/>
+          </a:prstGeom>
+          <a:noFill/>
+        </p:spPr>
+        <p:txBody>
+          <a:bodyPr wrap="none" lIns="0" rIns="0" tIns="0" bIns="0" anchor="t">
+            <a:spAutoFit/>
+          </a:bodyPr>
+          <a:lstStyle/>
+          <a:p>
+            <a:pPr algn="l">
+              <a:lnSpc>
+                <a:spcPct val="100000"/>
+              </a:lnSpc>
+              <a:spcAft>
+                <a:spcPts val="0"/>
+              </a:spcAft>
+            </a:pPr>
+            <a:r>
+              <a:rPr sz="800" b="0" i="0">
+                <a:solidFill>
+                  <a:srgbClr val="767576"/>
+                </a:solidFill>
+                <a:latin typeface="Arial"/>
+              </a:rPr>
+              <a:t>Range since 2000</a:t>
+            </a:r>
+          </a:p>
+        </p:txBody>
+      </p:sp>
+      <p:sp>
+        <p:nvSpPr>
+          <p:cNvPr id="54" name="TextBox 53"/>
+          <p:cNvSpPr txBox="1"/>
+          <p:nvPr/>
+        </p:nvSpPr>
+        <p:spPr>
+          <a:xfrm>
+            <a:off x="6236207" y="3584448"/>
+            <a:ext cx="914400" cy="164592"/>
+          </a:xfrm>
+          <a:prstGeom prst="rect">
+            <a:avLst/>
+          </a:prstGeom>
+          <a:noFill/>
+        </p:spPr>
+        <p:txBody>
+          <a:bodyPr wrap="none" lIns="0" rIns="0" tIns="0" bIns="0" anchor="t">
+            <a:spAutoFit/>
+          </a:bodyPr>
+          <a:lstStyle/>
+          <a:p>
+            <a:pPr algn="r">
+              <a:lnSpc>
+                <a:spcPct val="100000"/>
+              </a:lnSpc>
+              <a:spcAft>
+                <a:spcPts val="0"/>
+              </a:spcAft>
+            </a:pPr>
+            <a:r>
+              <a:rPr sz="850" b="1" i="0">
+                <a:solidFill>
+                  <a:srgbClr val="DB0011"/>
+                </a:solidFill>
+                <a:latin typeface="Arial"/>
+              </a:rPr>
+              <a:t>2s10s</a:t>
+            </a:r>
+          </a:p>
+        </p:txBody>
+      </p:sp>
+      <p:sp>
+        <p:nvSpPr>
+          <p:cNvPr id="55" name="TextBox 54"/>
+          <p:cNvSpPr txBox="1"/>
+          <p:nvPr/>
+        </p:nvSpPr>
+        <p:spPr>
+          <a:xfrm>
+            <a:off x="7150607" y="3584448"/>
+            <a:ext cx="914400" cy="164592"/>
+          </a:xfrm>
+          <a:prstGeom prst="rect">
+            <a:avLst/>
+          </a:prstGeom>
+          <a:noFill/>
+        </p:spPr>
+        <p:txBody>
+          <a:bodyPr wrap="none" lIns="0" rIns="0" tIns="0" bIns="0" anchor="t">
+            <a:spAutoFit/>
+          </a:bodyPr>
+          <a:lstStyle/>
+          <a:p>
+            <a:pPr algn="r">
+              <a:lnSpc>
+                <a:spcPct val="100000"/>
+              </a:lnSpc>
+              <a:spcAft>
+                <a:spcPts val="0"/>
+              </a:spcAft>
+            </a:pPr>
+            <a:r>
+              <a:rPr sz="850" b="1" i="0">
+                <a:solidFill>
+                  <a:srgbClr val="767576"/>
+                </a:solidFill>
+                <a:latin typeface="Arial"/>
+              </a:rPr>
+              <a:t>2s30s</a:t>
+            </a:r>
+          </a:p>
+        </p:txBody>
+      </p:sp>
+      <p:cxnSp>
+        <p:nvCxnSpPr>
+          <p:cNvPr id="56" name="Connector 55"/>
+          <p:cNvCxnSpPr/>
+          <p:nvPr/>
+        </p:nvCxnSpPr>
+        <p:spPr>
+          <a:xfrm>
+            <a:off x="4133087" y="3767328"/>
+            <a:ext cx="3931921" cy="0"/>
+          </a:xfrm>
+          <a:prstGeom prst="line">
+            <a:avLst/>
+          </a:prstGeom>
+          <a:ln w="9525">
+            <a:solidFill>
+              <a:srgbClr val="000000"/>
+            </a:solidFill>
+          </a:ln>
+        </p:spPr>
+        <p:style>
+          <a:lnRef idx="2">
+            <a:schemeClr val="accent1"/>
+          </a:lnRef>
+          <a:fillRef idx="0">
+            <a:schemeClr val="accent1"/>
+          </a:fillRef>
+          <a:effectRef idx="1">
+            <a:schemeClr val="accent1"/>
+          </a:effectRef>
+          <a:fontRef idx="minor">
+            <a:schemeClr val="tx1"/>
+          </a:fontRef>
+        </p:style>
+      </p:cxnSp>
+      <p:sp>
+        <p:nvSpPr>
+          <p:cNvPr id="57" name="TextBox 56"/>
+          <p:cNvSpPr txBox="1"/>
+          <p:nvPr/>
+        </p:nvSpPr>
+        <p:spPr>
+          <a:xfrm>
+            <a:off x="4133087" y="3822191"/>
+            <a:ext cx="2029967" cy="164592"/>
+          </a:xfrm>
+          <a:prstGeom prst="rect">
+            <a:avLst/>
+          </a:prstGeom>
+          <a:noFill/>
+        </p:spPr>
+        <p:txBody>
+          <a:bodyPr wrap="none" lIns="0" rIns="0" tIns="0" bIns="0" anchor="t">
+            <a:spAutoFit/>
+          </a:bodyPr>
+          <a:lstStyle/>
+          <a:p>
+            <a:pPr algn="l">
+              <a:lnSpc>
+                <a:spcPct val="100000"/>
+              </a:lnSpc>
+              <a:spcAft>
+                <a:spcPts val="0"/>
+              </a:spcAft>
+            </a:pPr>
+            <a:r>
+              <a:rPr sz="800" b="0" i="0">
+                <a:solidFill>
+                  <a:srgbClr val="000000"/>
+                </a:solidFill>
+                <a:latin typeface="Arial"/>
+              </a:rPr>
+              <a:t>Headroom to the high since 2000</a:t>
+            </a:r>
+          </a:p>
+        </p:txBody>
+      </p:sp>
+      <p:sp>
+        <p:nvSpPr>
+          <p:cNvPr id="58" name="TextBox 57"/>
+          <p:cNvSpPr txBox="1"/>
+          <p:nvPr/>
+        </p:nvSpPr>
+        <p:spPr>
+          <a:xfrm>
+            <a:off x="6236207" y="3822191"/>
+            <a:ext cx="914400" cy="164592"/>
+          </a:xfrm>
+          <a:prstGeom prst="rect">
+            <a:avLst/>
+          </a:prstGeom>
+          <a:noFill/>
+        </p:spPr>
+        <p:txBody>
+          <a:bodyPr wrap="none" lIns="0" rIns="0" tIns="0" bIns="0" anchor="t">
+            <a:spAutoFit/>
+          </a:bodyPr>
+          <a:lstStyle/>
+          <a:p>
+            <a:pPr algn="r">
+              <a:lnSpc>
+                <a:spcPct val="100000"/>
+              </a:lnSpc>
+              <a:spcAft>
+                <a:spcPts val="0"/>
+              </a:spcAft>
+            </a:pPr>
+            <a:r>
+              <a:rPr sz="850" b="1" i="0">
+                <a:solidFill>
+                  <a:srgbClr val="DB0011"/>
+                </a:solidFill>
+                <a:latin typeface="Arial"/>
+              </a:rPr>
+              <a:t>+35.5bp</a:t>
+            </a:r>
+          </a:p>
+        </p:txBody>
+      </p:sp>
+      <p:sp>
+        <p:nvSpPr>
+          <p:cNvPr id="59" name="TextBox 58"/>
+          <p:cNvSpPr txBox="1"/>
+          <p:nvPr/>
+        </p:nvSpPr>
+        <p:spPr>
+          <a:xfrm>
+            <a:off x="7150607" y="3822191"/>
+            <a:ext cx="914400" cy="164592"/>
+          </a:xfrm>
+          <a:prstGeom prst="rect">
+            <a:avLst/>
+          </a:prstGeom>
+          <a:noFill/>
+        </p:spPr>
+        <p:txBody>
+          <a:bodyPr wrap="none" lIns="0" rIns="0" tIns="0" bIns="0" anchor="t">
+            <a:spAutoFit/>
+          </a:bodyPr>
+          <a:lstStyle/>
+          <a:p>
+            <a:pPr algn="r">
+              <a:lnSpc>
+                <a:spcPct val="100000"/>
+              </a:lnSpc>
+              <a:spcAft>
+                <a:spcPts val="0"/>
+              </a:spcAft>
+            </a:pPr>
+            <a:r>
+              <a:rPr sz="850" b="0" i="0">
+                <a:solidFill>
+                  <a:srgbClr val="767576"/>
+                </a:solidFill>
+                <a:latin typeface="Arial"/>
+              </a:rPr>
+              <a:t>+12.3bp</a:t>
+            </a:r>
+          </a:p>
+        </p:txBody>
+      </p:sp>
+      <p:cxnSp>
+        <p:nvCxnSpPr>
+          <p:cNvPr id="60" name="Connector 59"/>
+          <p:cNvCxnSpPr/>
+          <p:nvPr/>
+        </p:nvCxnSpPr>
+        <p:spPr>
+          <a:xfrm>
+            <a:off x="4133087" y="3968496"/>
+            <a:ext cx="3931921" cy="0"/>
+          </a:xfrm>
+          <a:prstGeom prst="line">
+            <a:avLst/>
+          </a:prstGeom>
+          <a:ln w="6350">
+            <a:solidFill>
+              <a:srgbClr val="D0CECE"/>
+            </a:solidFill>
+          </a:ln>
+        </p:spPr>
+        <p:style>
+          <a:lnRef idx="2">
+            <a:schemeClr val="accent1"/>
+          </a:lnRef>
+          <a:fillRef idx="0">
+            <a:schemeClr val="accent1"/>
+          </a:fillRef>
+          <a:effectRef idx="1">
+            <a:schemeClr val="accent1"/>
+          </a:effectRef>
+          <a:fontRef idx="minor">
+            <a:schemeClr val="tx1"/>
+          </a:fontRef>
+        </p:style>
+      </p:cxnSp>
+      <p:sp>
+        <p:nvSpPr>
+          <p:cNvPr id="61" name="TextBox 60"/>
+          <p:cNvSpPr txBox="1"/>
+          <p:nvPr/>
+        </p:nvSpPr>
+        <p:spPr>
+          <a:xfrm>
+            <a:off x="4133087" y="4005072"/>
+            <a:ext cx="2029967" cy="164592"/>
+          </a:xfrm>
+          <a:prstGeom prst="rect">
+            <a:avLst/>
+          </a:prstGeom>
+          <a:noFill/>
+        </p:spPr>
+        <p:txBody>
+          <a:bodyPr wrap="none" lIns="0" rIns="0" tIns="0" bIns="0" anchor="t">
+            <a:spAutoFit/>
+          </a:bodyPr>
+          <a:lstStyle/>
+          <a:p>
+            <a:pPr algn="l">
+              <a:lnSpc>
+                <a:spcPct val="100000"/>
+              </a:lnSpc>
+              <a:spcAft>
+                <a:spcPts val="0"/>
+              </a:spcAft>
+            </a:pPr>
+            <a:r>
+              <a:rPr sz="800" b="0" i="0">
+                <a:solidFill>
+                  <a:srgbClr val="000000"/>
+                </a:solidFill>
+                <a:latin typeface="Arial"/>
+              </a:rPr>
+              <a:t>Round trip, share of headroom</a:t>
+            </a:r>
+          </a:p>
+        </p:txBody>
+      </p:sp>
+      <p:sp>
+        <p:nvSpPr>
+          <p:cNvPr id="62" name="TextBox 61"/>
+          <p:cNvSpPr txBox="1"/>
+          <p:nvPr/>
+        </p:nvSpPr>
+        <p:spPr>
+          <a:xfrm>
+            <a:off x="6236207" y="4005072"/>
+            <a:ext cx="914400" cy="164592"/>
+          </a:xfrm>
+          <a:prstGeom prst="rect">
+            <a:avLst/>
+          </a:prstGeom>
+          <a:noFill/>
+        </p:spPr>
+        <p:txBody>
+          <a:bodyPr wrap="none" lIns="0" rIns="0" tIns="0" bIns="0" anchor="t">
+            <a:spAutoFit/>
+          </a:bodyPr>
+          <a:lstStyle/>
+          <a:p>
+            <a:pPr algn="r">
+              <a:lnSpc>
+                <a:spcPct val="100000"/>
+              </a:lnSpc>
+              <a:spcAft>
+                <a:spcPts val="0"/>
+              </a:spcAft>
+            </a:pPr>
+            <a:r>
+              <a:rPr sz="850" b="1" i="0">
+                <a:solidFill>
+                  <a:srgbClr val="DB0011"/>
+                </a:solidFill>
+                <a:latin typeface="Arial"/>
+              </a:rPr>
+              <a:t>11%</a:t>
+            </a:r>
+          </a:p>
+        </p:txBody>
+      </p:sp>
+      <p:sp>
+        <p:nvSpPr>
+          <p:cNvPr id="63" name="TextBox 62"/>
+          <p:cNvSpPr txBox="1"/>
+          <p:nvPr/>
+        </p:nvSpPr>
+        <p:spPr>
+          <a:xfrm>
+            <a:off x="7150607" y="4005072"/>
+            <a:ext cx="914400" cy="164592"/>
+          </a:xfrm>
+          <a:prstGeom prst="rect">
+            <a:avLst/>
+          </a:prstGeom>
+          <a:noFill/>
+        </p:spPr>
+        <p:txBody>
+          <a:bodyPr wrap="none" lIns="0" rIns="0" tIns="0" bIns="0" anchor="t">
+            <a:spAutoFit/>
+          </a:bodyPr>
+          <a:lstStyle/>
+          <a:p>
+            <a:pPr algn="r">
+              <a:lnSpc>
+                <a:spcPct val="100000"/>
+              </a:lnSpc>
+              <a:spcAft>
+                <a:spcPts val="0"/>
+              </a:spcAft>
+            </a:pPr>
+            <a:r>
+              <a:rPr sz="850" b="0" i="0">
+                <a:solidFill>
+                  <a:srgbClr val="767576"/>
+                </a:solidFill>
+                <a:latin typeface="Arial"/>
+              </a:rPr>
+              <a:t>33%</a:t>
+            </a:r>
+          </a:p>
+        </p:txBody>
+      </p:sp>
+      <p:cxnSp>
+        <p:nvCxnSpPr>
+          <p:cNvPr id="64" name="Connector 63"/>
+          <p:cNvCxnSpPr/>
+          <p:nvPr/>
+        </p:nvCxnSpPr>
+        <p:spPr>
+          <a:xfrm>
+            <a:off x="4133087" y="4151376"/>
+            <a:ext cx="3931921" cy="0"/>
+          </a:xfrm>
+          <a:prstGeom prst="line">
+            <a:avLst/>
+          </a:prstGeom>
+          <a:ln w="6350">
+            <a:solidFill>
+              <a:srgbClr val="D0CECE"/>
+            </a:solidFill>
+          </a:ln>
+        </p:spPr>
+        <p:style>
+          <a:lnRef idx="2">
+            <a:schemeClr val="accent1"/>
+          </a:lnRef>
+          <a:fillRef idx="0">
+            <a:schemeClr val="accent1"/>
+          </a:fillRef>
+          <a:effectRef idx="1">
+            <a:schemeClr val="accent1"/>
+          </a:effectRef>
+          <a:fontRef idx="minor">
+            <a:schemeClr val="tx1"/>
+          </a:fontRef>
+        </p:style>
+      </p:cxnSp>
+      <p:sp>
+        <p:nvSpPr>
+          <p:cNvPr id="65" name="TextBox 64"/>
+          <p:cNvSpPr txBox="1"/>
+          <p:nvPr/>
+        </p:nvSpPr>
+        <p:spPr>
+          <a:xfrm>
+            <a:off x="4133087" y="4187952"/>
+            <a:ext cx="2029967" cy="164592"/>
+          </a:xfrm>
+          <a:prstGeom prst="rect">
+            <a:avLst/>
+          </a:prstGeom>
+          <a:noFill/>
+        </p:spPr>
+        <p:txBody>
+          <a:bodyPr wrap="none" lIns="0" rIns="0" tIns="0" bIns="0" anchor="t">
+            <a:spAutoFit/>
+          </a:bodyPr>
+          <a:lstStyle/>
+          <a:p>
+            <a:pPr algn="l">
+              <a:lnSpc>
+                <a:spcPct val="100000"/>
+              </a:lnSpc>
+              <a:spcAft>
+                <a:spcPts val="0"/>
+              </a:spcAft>
+            </a:pPr>
+            <a:r>
+              <a:rPr sz="800" b="0" i="0">
+                <a:solidFill>
+                  <a:srgbClr val="000000"/>
+                </a:solidFill>
+                <a:latin typeface="Arial"/>
+              </a:rPr>
+              <a:t>Risk : reward, net of costs</a:t>
+            </a:r>
+          </a:p>
+        </p:txBody>
+      </p:sp>
+      <p:sp>
+        <p:nvSpPr>
+          <p:cNvPr id="66" name="TextBox 65"/>
+          <p:cNvSpPr txBox="1"/>
+          <p:nvPr/>
+        </p:nvSpPr>
+        <p:spPr>
+          <a:xfrm>
+            <a:off x="6236207" y="4187952"/>
+            <a:ext cx="914400" cy="164592"/>
+          </a:xfrm>
+          <a:prstGeom prst="rect">
+            <a:avLst/>
+          </a:prstGeom>
+          <a:noFill/>
+        </p:spPr>
+        <p:txBody>
+          <a:bodyPr wrap="none" lIns="0" rIns="0" tIns="0" bIns="0" anchor="t">
+            <a:spAutoFit/>
+          </a:bodyPr>
+          <a:lstStyle/>
+          <a:p>
+            <a:pPr algn="r">
+              <a:lnSpc>
+                <a:spcPct val="100000"/>
+              </a:lnSpc>
+              <a:spcAft>
+                <a:spcPts val="0"/>
+              </a:spcAft>
+            </a:pPr>
+            <a:r>
+              <a:rPr sz="850" b="1" i="0">
+                <a:solidFill>
+                  <a:srgbClr val="DB0011"/>
+                </a:solidFill>
+                <a:latin typeface="Arial"/>
+              </a:rPr>
+              <a:t>2.1 : 1</a:t>
+            </a:r>
+          </a:p>
+        </p:txBody>
+      </p:sp>
+      <p:sp>
+        <p:nvSpPr>
+          <p:cNvPr id="67" name="TextBox 66"/>
+          <p:cNvSpPr txBox="1"/>
+          <p:nvPr/>
+        </p:nvSpPr>
+        <p:spPr>
+          <a:xfrm>
+            <a:off x="7150607" y="4187952"/>
+            <a:ext cx="914400" cy="164592"/>
+          </a:xfrm>
+          <a:prstGeom prst="rect">
+            <a:avLst/>
+          </a:prstGeom>
+          <a:noFill/>
+        </p:spPr>
+        <p:txBody>
+          <a:bodyPr wrap="none" lIns="0" rIns="0" tIns="0" bIns="0" anchor="t">
+            <a:spAutoFit/>
+          </a:bodyPr>
+          <a:lstStyle/>
+          <a:p>
+            <a:pPr algn="r">
+              <a:lnSpc>
+                <a:spcPct val="100000"/>
+              </a:lnSpc>
+              <a:spcAft>
+                <a:spcPts val="0"/>
+              </a:spcAft>
+            </a:pPr>
+            <a:r>
+              <a:rPr sz="850" b="0" i="0">
+                <a:solidFill>
+                  <a:srgbClr val="767576"/>
+                </a:solidFill>
+                <a:latin typeface="Arial"/>
+              </a:rPr>
+              <a:t>1.1 : 1</a:t>
+            </a:r>
+          </a:p>
+        </p:txBody>
+      </p:sp>
+      <p:cxnSp>
+        <p:nvCxnSpPr>
+          <p:cNvPr id="68" name="Connector 67"/>
+          <p:cNvCxnSpPr/>
+          <p:nvPr/>
+        </p:nvCxnSpPr>
+        <p:spPr>
+          <a:xfrm>
+            <a:off x="4133087" y="4334256"/>
+            <a:ext cx="3931921" cy="0"/>
+          </a:xfrm>
+          <a:prstGeom prst="line">
+            <a:avLst/>
+          </a:prstGeom>
+          <a:ln w="6350">
+            <a:solidFill>
+              <a:srgbClr val="D0CECE"/>
+            </a:solidFill>
+          </a:ln>
+        </p:spPr>
+        <p:style>
+          <a:lnRef idx="2">
+            <a:schemeClr val="accent1"/>
+          </a:lnRef>
+          <a:fillRef idx="0">
+            <a:schemeClr val="accent1"/>
+          </a:fillRef>
+          <a:effectRef idx="1">
+            <a:schemeClr val="accent1"/>
+          </a:effectRef>
+          <a:fontRef idx="minor">
+            <a:schemeClr val="tx1"/>
+          </a:fontRef>
+        </p:style>
+      </p:cxnSp>
+      <p:sp>
+        <p:nvSpPr>
+          <p:cNvPr id="69" name="TextBox 68"/>
+          <p:cNvSpPr txBox="1"/>
+          <p:nvPr/>
+        </p:nvSpPr>
+        <p:spPr>
+          <a:xfrm>
+            <a:off x="4133087" y="4480560"/>
+            <a:ext cx="1984248" cy="219456"/>
+          </a:xfrm>
+          <a:prstGeom prst="rect">
+            <a:avLst/>
+          </a:prstGeom>
+          <a:noFill/>
+        </p:spPr>
+        <p:txBody>
+          <a:bodyPr wrap="none" lIns="0" rIns="0" tIns="0" bIns="0" anchor="t">
+            <a:spAutoFit/>
+          </a:bodyPr>
+          <a:lstStyle/>
+          <a:p>
+            <a:pPr algn="ctr">
+              <a:lnSpc>
+                <a:spcPct val="100000"/>
+              </a:lnSpc>
+              <a:spcAft>
+                <a:spcPts val="0"/>
+              </a:spcAft>
+            </a:pPr>
+            <a:r>
+              <a:rPr sz="1150" b="1" i="0">
+                <a:solidFill>
+                  <a:srgbClr val="DB0011"/>
+                </a:solidFill>
+                <a:latin typeface="Arial"/>
+              </a:rPr>
+              <a:t>93rd vs 99th</a:t>
+            </a:r>
+          </a:p>
+        </p:txBody>
+      </p:sp>
+      <p:sp>
+        <p:nvSpPr>
+          <p:cNvPr id="70" name="TextBox 69"/>
+          <p:cNvSpPr txBox="1"/>
+          <p:nvPr/>
+        </p:nvSpPr>
+        <p:spPr>
+          <a:xfrm>
+            <a:off x="4133087" y="4681728"/>
+            <a:ext cx="1984248" cy="182880"/>
+          </a:xfrm>
+          <a:prstGeom prst="rect">
+            <a:avLst/>
+          </a:prstGeom>
+          <a:noFill/>
+        </p:spPr>
+        <p:txBody>
+          <a:bodyPr wrap="none" lIns="0" rIns="0" tIns="0" bIns="0" anchor="t">
+            <a:spAutoFit/>
+          </a:bodyPr>
+          <a:lstStyle/>
+          <a:p>
+            <a:pPr algn="ctr">
+              <a:lnSpc>
+                <a:spcPct val="100000"/>
+              </a:lnSpc>
+              <a:spcAft>
+                <a:spcPts val="0"/>
+              </a:spcAft>
+            </a:pPr>
+            <a:r>
+              <a:rPr sz="800" b="0" i="0">
+                <a:solidFill>
+                  <a:srgbClr val="767576"/>
+                </a:solidFill>
+                <a:latin typeface="Arial"/>
+              </a:rPr>
+              <a:t>percentile since 2000, vs 2s30s</a:t>
+            </a:r>
+          </a:p>
+        </p:txBody>
+      </p:sp>
+      <p:sp>
+        <p:nvSpPr>
+          <p:cNvPr id="71" name="TextBox 70"/>
+          <p:cNvSpPr txBox="1"/>
+          <p:nvPr/>
+        </p:nvSpPr>
+        <p:spPr>
+          <a:xfrm>
+            <a:off x="6208776" y="4480560"/>
+            <a:ext cx="1984248" cy="219456"/>
+          </a:xfrm>
+          <a:prstGeom prst="rect">
+            <a:avLst/>
+          </a:prstGeom>
+          <a:noFill/>
+        </p:spPr>
+        <p:txBody>
+          <a:bodyPr wrap="none" lIns="0" rIns="0" tIns="0" bIns="0" anchor="t">
+            <a:spAutoFit/>
+          </a:bodyPr>
+          <a:lstStyle/>
+          <a:p>
+            <a:pPr algn="ctr">
+              <a:lnSpc>
+                <a:spcPct val="100000"/>
+              </a:lnSpc>
+              <a:spcAft>
+                <a:spcPts val="0"/>
+              </a:spcAft>
+            </a:pPr>
+            <a:r>
+              <a:rPr sz="1150" b="1" i="0">
+                <a:solidFill>
+                  <a:srgbClr val="DB0011"/>
+                </a:solidFill>
+                <a:latin typeface="Arial"/>
+              </a:rPr>
+              <a:t>−5.8bp</a:t>
+            </a:r>
+          </a:p>
+        </p:txBody>
+      </p:sp>
+      <p:sp>
+        <p:nvSpPr>
+          <p:cNvPr id="72" name="TextBox 71"/>
+          <p:cNvSpPr txBox="1"/>
+          <p:nvPr/>
+        </p:nvSpPr>
+        <p:spPr>
+          <a:xfrm>
+            <a:off x="6208776" y="4681728"/>
+            <a:ext cx="1984248" cy="182880"/>
+          </a:xfrm>
+          <a:prstGeom prst="rect">
+            <a:avLst/>
+          </a:prstGeom>
+          <a:noFill/>
+        </p:spPr>
+        <p:txBody>
+          <a:bodyPr wrap="none" lIns="0" rIns="0" tIns="0" bIns="0" anchor="t">
+            <a:spAutoFit/>
+          </a:bodyPr>
+          <a:lstStyle/>
+          <a:p>
+            <a:pPr algn="ctr">
+              <a:lnSpc>
+                <a:spcPct val="100000"/>
+              </a:lnSpc>
+              <a:spcAft>
+                <a:spcPts val="0"/>
+              </a:spcAft>
+            </a:pPr>
+            <a:r>
               <a:rPr sz="800" b="0" i="0">
                 <a:solidFill>
                   <a:srgbClr val="767576"/>
@@ -7058,7 +7906,7 @@
       </p:sp>
       <p:sp>
         <p:nvSpPr>
-          <p:cNvPr id="44" name="TextBox 43"/>
+          <p:cNvPr id="73" name="TextBox 72"/>
           <p:cNvSpPr txBox="1"/>
           <p:nvPr/>
         </p:nvSpPr>
@@ -7100,7 +7948,7 @@
       </p:sp>
       <p:sp>
         <p:nvSpPr>
-          <p:cNvPr id="45" name="TextBox 44"/>
+          <p:cNvPr id="74" name="TextBox 73"/>
           <p:cNvSpPr txBox="1"/>
           <p:nvPr/>
         </p:nvSpPr>
@@ -7142,7 +7990,7 @@
       </p:sp>
       <p:graphicFrame>
         <p:nvGraphicFramePr>
-          <p:cNvPr id="46" name="Chart 45"/>
+          <p:cNvPr id="75" name="Chart 74"/>
           <p:cNvGraphicFramePr>
             <a:graphicFrameLocks noGrp="1"/>
           </p:cNvGraphicFramePr>
@@ -7154,13 +8002,13 @@
         </p:xfrm>
         <a:graphic>
           <a:graphicData uri="http://schemas.openxmlformats.org/drawingml/2006/chart">
-            <c:chart xmlns:c="http://schemas.openxmlformats.org/drawingml/2006/chart" r:id="rId4"/>
+            <c:chart xmlns:c="http://schemas.openxmlformats.org/drawingml/2006/chart" r:id="rId3"/>
           </a:graphicData>
         </a:graphic>
       </p:graphicFrame>
       <p:sp>
         <p:nvSpPr>
-          <p:cNvPr id="47" name="TextBox 46"/>
+          <p:cNvPr id="76" name="TextBox 75"/>
           <p:cNvSpPr txBox="1"/>
           <p:nvPr/>
         </p:nvSpPr>
@@ -7202,7 +8050,7 @@
       </p:sp>
       <p:sp>
         <p:nvSpPr>
-          <p:cNvPr id="48" name="TextBox 47"/>
+          <p:cNvPr id="77" name="TextBox 76"/>
           <p:cNvSpPr txBox="1"/>
           <p:nvPr/>
         </p:nvSpPr>
@@ -7244,7 +8092,7 @@
       </p:sp>
       <p:sp>
         <p:nvSpPr>
-          <p:cNvPr id="49" name="TextBox 48"/>
+          <p:cNvPr id="78" name="TextBox 77"/>
           <p:cNvSpPr txBox="1"/>
           <p:nvPr/>
         </p:nvSpPr>
@@ -7286,7 +8134,7 @@
       </p:sp>
       <p:sp>
         <p:nvSpPr>
-          <p:cNvPr id="50" name="TextBox 49"/>
+          <p:cNvPr id="79" name="TextBox 78"/>
           <p:cNvSpPr txBox="1"/>
           <p:nvPr/>
         </p:nvSpPr>
@@ -7328,7 +8176,7 @@
       </p:sp>
       <p:sp>
         <p:nvSpPr>
-          <p:cNvPr id="51" name="TextBox 50"/>
+          <p:cNvPr id="80" name="TextBox 79"/>
           <p:cNvSpPr txBox="1"/>
           <p:nvPr/>
         </p:nvSpPr>
@@ -7370,7 +8218,7 @@
       </p:sp>
       <p:graphicFrame>
         <p:nvGraphicFramePr>
-          <p:cNvPr id="52" name="Table 51"/>
+          <p:cNvPr id="81" name="Table 80"/>
           <p:cNvGraphicFramePr>
             <a:graphicFrameLocks noGrp="1"/>
           </p:cNvGraphicFramePr>
@@ -7872,7 +8720,7 @@
       </p:graphicFrame>
       <p:sp>
         <p:nvSpPr>
-          <p:cNvPr id="53" name="TextBox 52"/>
+          <p:cNvPr id="82" name="TextBox 81"/>
           <p:cNvSpPr txBox="1"/>
           <p:nvPr/>
         </p:nvSpPr>
@@ -7914,7 +8762,7 @@
       </p:sp>
       <p:sp>
         <p:nvSpPr>
-          <p:cNvPr id="54" name="TextBox 53"/>
+          <p:cNvPr id="83" name="TextBox 82"/>
           <p:cNvSpPr txBox="1"/>
           <p:nvPr/>
         </p:nvSpPr>

</xml_diff>

<commit_message>
Rebase the tenor comparison onto basis points of runway
</commit_message>
<xml_diff>
--- a/JGB_2s10s_Steepener.pptx
+++ b/JGB_2s10s_Steepener.pptx
@@ -5820,7 +5820,7 @@
                 </a:solidFill>
                 <a:latin typeface="Arial"/>
               </a:rPr>
-              <a:t>Exhibit 5. 2s10s has 35bp of room to its high. 2s30s has 12bp, and the round trip takes a third of it</a:t>
+              <a:t>Exhibit 5. 2s10s has 35bp of room to its high. The same 4bp round trip eats a third of what 2s30s has left</a:t>
             </a:r>
           </a:p>
         </p:txBody>
@@ -5862,7 +5862,7 @@
                 </a:solidFill>
                 <a:latin typeface="Arial"/>
               </a:rPr>
-              <a:t>Slope vs its own range since 2000, bp</a:t>
+              <a:t>Room from today to the high since 2000, bp of further steepening</a:t>
             </a:r>
           </a:p>
         </p:txBody>
@@ -5875,8 +5875,8 @@
         </p:nvCxnSpPr>
         <p:spPr>
           <a:xfrm>
-            <a:off x="5102352" y="1737360"/>
-            <a:ext cx="0" cy="1207008"/>
+            <a:off x="5065775" y="1773936"/>
+            <a:ext cx="0" cy="1353312"/>
           </a:xfrm>
           <a:prstGeom prst="line">
             <a:avLst/>
@@ -5910,8 +5910,8 @@
         </p:nvCxnSpPr>
         <p:spPr>
           <a:xfrm>
-            <a:off x="5791200" y="1737360"/>
-            <a:ext cx="0" cy="1207008"/>
+            <a:off x="5591555" y="1773936"/>
+            <a:ext cx="0" cy="1353312"/>
           </a:xfrm>
           <a:prstGeom prst="line">
             <a:avLst/>
@@ -5945,8 +5945,8 @@
         </p:nvCxnSpPr>
         <p:spPr>
           <a:xfrm>
-            <a:off x="6480048" y="1737360"/>
-            <a:ext cx="0" cy="1207008"/>
+            <a:off x="6117336" y="1773936"/>
+            <a:ext cx="0" cy="1353312"/>
           </a:xfrm>
           <a:prstGeom prst="line">
             <a:avLst/>
@@ -5980,8 +5980,8 @@
         </p:nvCxnSpPr>
         <p:spPr>
           <a:xfrm>
-            <a:off x="7168896" y="1737360"/>
-            <a:ext cx="0" cy="1207008"/>
+            <a:off x="6643115" y="1773936"/>
+            <a:ext cx="0" cy="1353312"/>
           </a:xfrm>
           <a:prstGeom prst="line">
             <a:avLst/>
@@ -6007,611 +6007,23 @@
           </a:fontRef>
         </p:style>
       </p:cxnSp>
-      <p:sp>
-        <p:nvSpPr>
-          <p:cNvPr id="27" name="Rectangle 26"/>
-          <p:cNvSpPr/>
-          <p:nvPr/>
-        </p:nvSpPr>
-        <p:spPr>
-          <a:xfrm>
-            <a:off x="5126844" y="1956816"/>
-            <a:ext cx="1237630" cy="164592"/>
-          </a:xfrm>
-          <a:prstGeom prst="rect">
-            <a:avLst/>
-          </a:prstGeom>
-          <a:solidFill>
-            <a:srgbClr val="D7D8D6"/>
-          </a:solidFill>
-          <a:ln>
-            <a:noFill/>
-          </a:ln>
-          <a:effectLst/>
-        </p:spPr>
-        <p:style>
-          <a:lnRef idx="1">
-            <a:schemeClr val="accent1"/>
-          </a:lnRef>
-          <a:fillRef idx="3">
-            <a:schemeClr val="accent1"/>
-          </a:fillRef>
-          <a:effectRef idx="2">
-            <a:schemeClr val="accent1"/>
-          </a:effectRef>
-          <a:fontRef idx="minor">
-            <a:schemeClr val="lt1"/>
-          </a:fontRef>
-        </p:style>
-        <p:txBody>
-          <a:bodyPr rtlCol="0" anchor="ctr"/>
-          <a:lstStyle/>
-          <a:p/>
-        </p:txBody>
-      </p:sp>
-      <p:sp>
-        <p:nvSpPr>
-          <p:cNvPr id="28" name="Rectangle 27"/>
-          <p:cNvSpPr/>
-          <p:nvPr/>
-        </p:nvSpPr>
-        <p:spPr>
-          <a:xfrm>
-            <a:off x="6092762" y="1956816"/>
-            <a:ext cx="271712" cy="164592"/>
-          </a:xfrm>
-          <a:prstGeom prst="rect">
-            <a:avLst/>
-          </a:prstGeom>
-          <a:solidFill>
-            <a:srgbClr val="F4B4BB"/>
-          </a:solidFill>
-          <a:ln>
-            <a:noFill/>
-          </a:ln>
-          <a:effectLst/>
-        </p:spPr>
-        <p:style>
-          <a:lnRef idx="1">
-            <a:schemeClr val="accent1"/>
-          </a:lnRef>
-          <a:fillRef idx="3">
-            <a:schemeClr val="accent1"/>
-          </a:fillRef>
-          <a:effectRef idx="2">
-            <a:schemeClr val="accent1"/>
-          </a:effectRef>
-          <a:fontRef idx="minor">
-            <a:schemeClr val="lt1"/>
-          </a:fontRef>
-        </p:style>
-        <p:txBody>
-          <a:bodyPr rtlCol="0" anchor="ctr"/>
-          <a:lstStyle/>
-          <a:p/>
-        </p:txBody>
-      </p:sp>
-      <p:sp>
-        <p:nvSpPr>
-          <p:cNvPr id="29" name="Rectangle 28"/>
-          <p:cNvSpPr/>
-          <p:nvPr/>
-        </p:nvSpPr>
-        <p:spPr>
-          <a:xfrm>
-            <a:off x="5639545" y="1924812"/>
-            <a:ext cx="20116" cy="228600"/>
-          </a:xfrm>
-          <a:prstGeom prst="rect">
-            <a:avLst/>
-          </a:prstGeom>
-          <a:solidFill>
-            <a:srgbClr val="44546A"/>
-          </a:solidFill>
-          <a:ln>
-            <a:noFill/>
-          </a:ln>
-          <a:effectLst/>
-        </p:spPr>
-        <p:style>
-          <a:lnRef idx="1">
-            <a:schemeClr val="accent1"/>
-          </a:lnRef>
-          <a:fillRef idx="3">
-            <a:schemeClr val="accent1"/>
-          </a:fillRef>
-          <a:effectRef idx="2">
-            <a:schemeClr val="accent1"/>
-          </a:effectRef>
-          <a:fontRef idx="minor">
-            <a:schemeClr val="lt1"/>
-          </a:fontRef>
-        </p:style>
-        <p:txBody>
-          <a:bodyPr rtlCol="0" anchor="ctr"/>
-          <a:lstStyle/>
-          <a:p/>
-        </p:txBody>
-      </p:sp>
-      <p:sp>
-        <p:nvSpPr>
-          <p:cNvPr id="30" name="Rectangle 29"/>
-          <p:cNvSpPr/>
-          <p:nvPr/>
-        </p:nvSpPr>
-        <p:spPr>
-          <a:xfrm>
-            <a:off x="6068987" y="1892807"/>
-            <a:ext cx="47548" cy="292608"/>
-          </a:xfrm>
-          <a:prstGeom prst="rect">
-            <a:avLst/>
-          </a:prstGeom>
-          <a:solidFill>
-            <a:srgbClr val="DB0011"/>
-          </a:solidFill>
-          <a:ln>
-            <a:noFill/>
-          </a:ln>
-          <a:effectLst/>
-        </p:spPr>
-        <p:style>
-          <a:lnRef idx="1">
-            <a:schemeClr val="accent1"/>
-          </a:lnRef>
-          <a:fillRef idx="3">
-            <a:schemeClr val="accent1"/>
-          </a:fillRef>
-          <a:effectRef idx="2">
-            <a:schemeClr val="accent1"/>
-          </a:effectRef>
-          <a:fontRef idx="minor">
-            <a:schemeClr val="lt1"/>
-          </a:fontRef>
-        </p:style>
-        <p:txBody>
-          <a:bodyPr rtlCol="0" anchor="ctr"/>
-          <a:lstStyle/>
-          <a:p/>
-        </p:txBody>
-      </p:sp>
-      <p:sp>
-        <p:nvSpPr>
-          <p:cNvPr id="31" name="TextBox 30"/>
-          <p:cNvSpPr txBox="1"/>
-          <p:nvPr/>
-        </p:nvSpPr>
-        <p:spPr>
-          <a:xfrm>
-            <a:off x="5578090" y="1709928"/>
-            <a:ext cx="822960" cy="182880"/>
-          </a:xfrm>
-          <a:prstGeom prst="rect">
-            <a:avLst/>
-          </a:prstGeom>
-          <a:noFill/>
-        </p:spPr>
-        <p:txBody>
-          <a:bodyPr wrap="none" lIns="0" rIns="0" tIns="0" bIns="0" anchor="t">
-            <a:spAutoFit/>
-          </a:bodyPr>
-          <a:lstStyle/>
-          <a:p>
-            <a:pPr algn="r">
-              <a:lnSpc>
-                <a:spcPct val="100000"/>
-              </a:lnSpc>
-              <a:spcAft>
-                <a:spcPts val="0"/>
-              </a:spcAft>
-            </a:pPr>
-            <a:r>
-              <a:rPr sz="850" b="1" i="0">
-                <a:solidFill>
-                  <a:srgbClr val="DB0011"/>
-                </a:solidFill>
-                <a:latin typeface="Arial"/>
-              </a:rPr>
-              <a:t>+35.5bp</a:t>
-            </a:r>
-          </a:p>
-        </p:txBody>
-      </p:sp>
-      <p:sp>
-        <p:nvSpPr>
-          <p:cNvPr id="32" name="TextBox 31"/>
-          <p:cNvSpPr txBox="1"/>
-          <p:nvPr/>
-        </p:nvSpPr>
-        <p:spPr>
-          <a:xfrm>
-            <a:off x="4133087" y="1933955"/>
-            <a:ext cx="896112" cy="210312"/>
-          </a:xfrm>
-          <a:prstGeom prst="rect">
-            <a:avLst/>
-          </a:prstGeom>
-          <a:noFill/>
-        </p:spPr>
-        <p:txBody>
-          <a:bodyPr wrap="none" lIns="0" rIns="0" tIns="0" bIns="0" anchor="t">
-            <a:spAutoFit/>
-          </a:bodyPr>
-          <a:lstStyle/>
-          <a:p>
-            <a:pPr algn="l">
-              <a:lnSpc>
-                <a:spcPct val="100000"/>
-              </a:lnSpc>
-              <a:spcAft>
-                <a:spcPts val="0"/>
-              </a:spcAft>
-            </a:pPr>
-            <a:r>
-              <a:rPr sz="1000" b="1" i="0">
-                <a:solidFill>
-                  <a:srgbClr val="DB0011"/>
-                </a:solidFill>
-                <a:latin typeface="Arial"/>
-              </a:rPr>
-              <a:t>JGB 2s10s</a:t>
-            </a:r>
-          </a:p>
-        </p:txBody>
-      </p:sp>
-      <p:sp>
-        <p:nvSpPr>
-          <p:cNvPr id="33" name="TextBox 32"/>
-          <p:cNvSpPr txBox="1"/>
-          <p:nvPr/>
-        </p:nvSpPr>
-        <p:spPr>
-          <a:xfrm>
-            <a:off x="7168896" y="1933955"/>
-            <a:ext cx="987552" cy="210312"/>
-          </a:xfrm>
-          <a:prstGeom prst="rect">
-            <a:avLst/>
-          </a:prstGeom>
-          <a:noFill/>
-        </p:spPr>
-        <p:txBody>
-          <a:bodyPr wrap="none" lIns="0" rIns="0" tIns="0" bIns="0" anchor="t">
-            <a:spAutoFit/>
-          </a:bodyPr>
-          <a:lstStyle/>
-          <a:p>
-            <a:pPr algn="r">
-              <a:lnSpc>
-                <a:spcPct val="100000"/>
-              </a:lnSpc>
-              <a:spcAft>
-                <a:spcPts val="0"/>
-              </a:spcAft>
-            </a:pPr>
-            <a:r>
-              <a:rPr sz="1000" b="1" i="0">
-                <a:solidFill>
-                  <a:srgbClr val="DB0011"/>
-                </a:solidFill>
-                <a:latin typeface="Arial"/>
-              </a:rPr>
-              <a:t>129bp · 93rd</a:t>
-            </a:r>
-          </a:p>
-        </p:txBody>
-      </p:sp>
-      <p:sp>
-        <p:nvSpPr>
-          <p:cNvPr id="34" name="Rectangle 33"/>
-          <p:cNvSpPr/>
-          <p:nvPr/>
-        </p:nvSpPr>
-        <p:spPr>
-          <a:xfrm>
-            <a:off x="5425345" y="2560320"/>
-            <a:ext cx="1665481" cy="164592"/>
-          </a:xfrm>
-          <a:prstGeom prst="rect">
-            <a:avLst/>
-          </a:prstGeom>
-          <a:solidFill>
-            <a:srgbClr val="D7D8D6"/>
-          </a:solidFill>
-          <a:ln>
-            <a:noFill/>
-          </a:ln>
-          <a:effectLst/>
-        </p:spPr>
-        <p:style>
-          <a:lnRef idx="1">
-            <a:schemeClr val="accent1"/>
-          </a:lnRef>
-          <a:fillRef idx="3">
-            <a:schemeClr val="accent1"/>
-          </a:fillRef>
-          <a:effectRef idx="2">
-            <a:schemeClr val="accent1"/>
-          </a:effectRef>
-          <a:fontRef idx="minor">
-            <a:schemeClr val="lt1"/>
-          </a:fontRef>
-        </p:style>
-        <p:txBody>
-          <a:bodyPr rtlCol="0" anchor="ctr"/>
-          <a:lstStyle/>
-          <a:p/>
-        </p:txBody>
-      </p:sp>
-      <p:sp>
-        <p:nvSpPr>
-          <p:cNvPr id="35" name="Rectangle 34"/>
-          <p:cNvSpPr/>
-          <p:nvPr/>
-        </p:nvSpPr>
-        <p:spPr>
-          <a:xfrm>
-            <a:off x="6996684" y="2560320"/>
-            <a:ext cx="94142" cy="164592"/>
-          </a:xfrm>
-          <a:prstGeom prst="rect">
-            <a:avLst/>
-          </a:prstGeom>
-          <a:solidFill>
-            <a:srgbClr val="F4B4BB"/>
-          </a:solidFill>
-          <a:ln>
-            <a:noFill/>
-          </a:ln>
-          <a:effectLst/>
-        </p:spPr>
-        <p:style>
-          <a:lnRef idx="1">
-            <a:schemeClr val="accent1"/>
-          </a:lnRef>
-          <a:fillRef idx="3">
-            <a:schemeClr val="accent1"/>
-          </a:fillRef>
-          <a:effectRef idx="2">
-            <a:schemeClr val="accent1"/>
-          </a:effectRef>
-          <a:fontRef idx="minor">
-            <a:schemeClr val="lt1"/>
-          </a:fontRef>
-        </p:style>
-        <p:txBody>
-          <a:bodyPr rtlCol="0" anchor="ctr"/>
-          <a:lstStyle/>
-          <a:p/>
-        </p:txBody>
-      </p:sp>
-      <p:sp>
-        <p:nvSpPr>
-          <p:cNvPr id="36" name="Rectangle 35"/>
-          <p:cNvSpPr/>
-          <p:nvPr/>
-        </p:nvSpPr>
-        <p:spPr>
-          <a:xfrm>
-            <a:off x="6300073" y="2528316"/>
-            <a:ext cx="20116" cy="228600"/>
-          </a:xfrm>
-          <a:prstGeom prst="rect">
-            <a:avLst/>
-          </a:prstGeom>
-          <a:solidFill>
-            <a:srgbClr val="44546A"/>
-          </a:solidFill>
-          <a:ln>
-            <a:noFill/>
-          </a:ln>
-          <a:effectLst/>
-        </p:spPr>
-        <p:style>
-          <a:lnRef idx="1">
-            <a:schemeClr val="accent1"/>
-          </a:lnRef>
-          <a:fillRef idx="3">
-            <a:schemeClr val="accent1"/>
-          </a:fillRef>
-          <a:effectRef idx="2">
-            <a:schemeClr val="accent1"/>
-          </a:effectRef>
-          <a:fontRef idx="minor">
-            <a:schemeClr val="lt1"/>
-          </a:fontRef>
-        </p:style>
-        <p:txBody>
-          <a:bodyPr rtlCol="0" anchor="ctr"/>
-          <a:lstStyle/>
-          <a:p/>
-        </p:txBody>
-      </p:sp>
-      <p:sp>
-        <p:nvSpPr>
-          <p:cNvPr id="37" name="Rectangle 36"/>
-          <p:cNvSpPr/>
-          <p:nvPr/>
-        </p:nvSpPr>
-        <p:spPr>
-          <a:xfrm>
-            <a:off x="6972909" y="2496312"/>
-            <a:ext cx="47548" cy="292608"/>
-          </a:xfrm>
-          <a:prstGeom prst="rect">
-            <a:avLst/>
-          </a:prstGeom>
-          <a:solidFill>
-            <a:srgbClr val="DB0011"/>
-          </a:solidFill>
-          <a:ln>
-            <a:noFill/>
-          </a:ln>
-          <a:effectLst/>
-        </p:spPr>
-        <p:style>
-          <a:lnRef idx="1">
-            <a:schemeClr val="accent1"/>
-          </a:lnRef>
-          <a:fillRef idx="3">
-            <a:schemeClr val="accent1"/>
-          </a:fillRef>
-          <a:effectRef idx="2">
-            <a:schemeClr val="accent1"/>
-          </a:effectRef>
-          <a:fontRef idx="minor">
-            <a:schemeClr val="lt1"/>
-          </a:fontRef>
-        </p:style>
-        <p:txBody>
-          <a:bodyPr rtlCol="0" anchor="ctr"/>
-          <a:lstStyle/>
-          <a:p/>
-        </p:txBody>
-      </p:sp>
-      <p:sp>
-        <p:nvSpPr>
-          <p:cNvPr id="38" name="TextBox 37"/>
-          <p:cNvSpPr txBox="1"/>
-          <p:nvPr/>
-        </p:nvSpPr>
-        <p:spPr>
-          <a:xfrm>
-            <a:off x="6304442" y="2313432"/>
-            <a:ext cx="822960" cy="182880"/>
-          </a:xfrm>
-          <a:prstGeom prst="rect">
-            <a:avLst/>
-          </a:prstGeom>
-          <a:noFill/>
-        </p:spPr>
-        <p:txBody>
-          <a:bodyPr wrap="none" lIns="0" rIns="0" tIns="0" bIns="0" anchor="t">
-            <a:spAutoFit/>
-          </a:bodyPr>
-          <a:lstStyle/>
-          <a:p>
-            <a:pPr algn="r">
-              <a:lnSpc>
-                <a:spcPct val="100000"/>
-              </a:lnSpc>
-              <a:spcAft>
-                <a:spcPts val="0"/>
-              </a:spcAft>
-            </a:pPr>
-            <a:r>
-              <a:rPr sz="850" b="1" i="0">
-                <a:solidFill>
-                  <a:srgbClr val="DB0011"/>
-                </a:solidFill>
-                <a:latin typeface="Arial"/>
-              </a:rPr>
-              <a:t>+12.3bp</a:t>
-            </a:r>
-          </a:p>
-        </p:txBody>
-      </p:sp>
-      <p:sp>
-        <p:nvSpPr>
-          <p:cNvPr id="39" name="TextBox 38"/>
-          <p:cNvSpPr txBox="1"/>
-          <p:nvPr/>
-        </p:nvSpPr>
-        <p:spPr>
-          <a:xfrm>
-            <a:off x="4133087" y="2537460"/>
-            <a:ext cx="896112" cy="210312"/>
-          </a:xfrm>
-          <a:prstGeom prst="rect">
-            <a:avLst/>
-          </a:prstGeom>
-          <a:noFill/>
-        </p:spPr>
-        <p:txBody>
-          <a:bodyPr wrap="none" lIns="0" rIns="0" tIns="0" bIns="0" anchor="t">
-            <a:spAutoFit/>
-          </a:bodyPr>
-          <a:lstStyle/>
-          <a:p>
-            <a:pPr algn="l">
-              <a:lnSpc>
-                <a:spcPct val="100000"/>
-              </a:lnSpc>
-              <a:spcAft>
-                <a:spcPts val="0"/>
-              </a:spcAft>
-            </a:pPr>
-            <a:r>
-              <a:rPr sz="1000" b="1" i="0">
-                <a:solidFill>
-                  <a:srgbClr val="767576"/>
-                </a:solidFill>
-                <a:latin typeface="Arial"/>
-              </a:rPr>
-              <a:t>JGB 2s30s</a:t>
-            </a:r>
-          </a:p>
-        </p:txBody>
-      </p:sp>
-      <p:sp>
-        <p:nvSpPr>
-          <p:cNvPr id="40" name="TextBox 39"/>
-          <p:cNvSpPr txBox="1"/>
-          <p:nvPr/>
-        </p:nvSpPr>
-        <p:spPr>
-          <a:xfrm>
-            <a:off x="7168896" y="2537460"/>
-            <a:ext cx="987552" cy="210312"/>
-          </a:xfrm>
-          <a:prstGeom prst="rect">
-            <a:avLst/>
-          </a:prstGeom>
-          <a:noFill/>
-        </p:spPr>
-        <p:txBody>
-          <a:bodyPr wrap="none" lIns="0" rIns="0" tIns="0" bIns="0" anchor="t">
-            <a:spAutoFit/>
-          </a:bodyPr>
-          <a:lstStyle/>
-          <a:p>
-            <a:pPr algn="r">
-              <a:lnSpc>
-                <a:spcPct val="100000"/>
-              </a:lnSpc>
-              <a:spcAft>
-                <a:spcPts val="0"/>
-              </a:spcAft>
-            </a:pPr>
-            <a:r>
-              <a:rPr sz="1000" b="0" i="0">
-                <a:solidFill>
-                  <a:srgbClr val="767576"/>
-                </a:solidFill>
-                <a:latin typeface="Arial"/>
-              </a:rPr>
-              <a:t>248bp · 99th</a:t>
-            </a:r>
-          </a:p>
-        </p:txBody>
-      </p:sp>
       <p:cxnSp>
         <p:nvCxnSpPr>
-          <p:cNvPr id="41" name="Connector 40"/>
+          <p:cNvPr id="27" name="Connector 26"/>
           <p:cNvCxnSpPr/>
           <p:nvPr/>
         </p:nvCxnSpPr>
         <p:spPr>
           <a:xfrm>
-            <a:off x="5102352" y="2944368"/>
-            <a:ext cx="2066544" cy="0"/>
+            <a:off x="7168896" y="1773936"/>
+            <a:ext cx="0" cy="1353312"/>
           </a:xfrm>
           <a:prstGeom prst="line">
             <a:avLst/>
           </a:prstGeom>
-          <a:ln w="9525">
+          <a:ln w="6350">
             <a:solidFill>
-              <a:srgbClr val="000000"/>
+              <a:srgbClr val="D0CECE"/>
             </a:solidFill>
           </a:ln>
         </p:spPr>
@@ -6632,188 +6044,20 @@
       </p:cxnSp>
       <p:sp>
         <p:nvSpPr>
-          <p:cNvPr id="42" name="TextBox 41"/>
-          <p:cNvSpPr txBox="1"/>
-          <p:nvPr/>
-        </p:nvSpPr>
-        <p:spPr>
-          <a:xfrm>
-            <a:off x="4782312" y="2980944"/>
-            <a:ext cx="640080" cy="182880"/>
-          </a:xfrm>
-          <a:prstGeom prst="rect">
-            <a:avLst/>
-          </a:prstGeom>
-          <a:noFill/>
-        </p:spPr>
-        <p:txBody>
-          <a:bodyPr wrap="none" lIns="0" rIns="0" tIns="0" bIns="0" anchor="t">
-            <a:spAutoFit/>
-          </a:bodyPr>
-          <a:lstStyle/>
-          <a:p>
-            <a:pPr algn="ctr">
-              <a:lnSpc>
-                <a:spcPct val="100000"/>
-              </a:lnSpc>
-              <a:spcAft>
-                <a:spcPts val="0"/>
-              </a:spcAft>
-            </a:pPr>
-            <a:r>
-              <a:rPr sz="850" b="0" i="0">
-                <a:solidFill>
-                  <a:srgbClr val="767576"/>
-                </a:solidFill>
-                <a:latin typeface="Arial"/>
-              </a:rPr>
-              <a:t>0</a:t>
-            </a:r>
-          </a:p>
-        </p:txBody>
-      </p:sp>
-      <p:sp>
-        <p:nvSpPr>
-          <p:cNvPr id="43" name="TextBox 42"/>
-          <p:cNvSpPr txBox="1"/>
-          <p:nvPr/>
-        </p:nvSpPr>
-        <p:spPr>
-          <a:xfrm>
-            <a:off x="5471160" y="2980944"/>
-            <a:ext cx="640080" cy="182880"/>
-          </a:xfrm>
-          <a:prstGeom prst="rect">
-            <a:avLst/>
-          </a:prstGeom>
-          <a:noFill/>
-        </p:spPr>
-        <p:txBody>
-          <a:bodyPr wrap="none" lIns="0" rIns="0" tIns="0" bIns="0" anchor="t">
-            <a:spAutoFit/>
-          </a:bodyPr>
-          <a:lstStyle/>
-          <a:p>
-            <a:pPr algn="ctr">
-              <a:lnSpc>
-                <a:spcPct val="100000"/>
-              </a:lnSpc>
-              <a:spcAft>
-                <a:spcPts val="0"/>
-              </a:spcAft>
-            </a:pPr>
-            <a:r>
-              <a:rPr sz="850" b="0" i="0">
-                <a:solidFill>
-                  <a:srgbClr val="767576"/>
-                </a:solidFill>
-                <a:latin typeface="Arial"/>
-              </a:rPr>
-              <a:t>+90</a:t>
-            </a:r>
-          </a:p>
-        </p:txBody>
-      </p:sp>
-      <p:sp>
-        <p:nvSpPr>
-          <p:cNvPr id="44" name="TextBox 43"/>
-          <p:cNvSpPr txBox="1"/>
-          <p:nvPr/>
-        </p:nvSpPr>
-        <p:spPr>
-          <a:xfrm>
-            <a:off x="6160008" y="2980944"/>
-            <a:ext cx="640080" cy="182880"/>
-          </a:xfrm>
-          <a:prstGeom prst="rect">
-            <a:avLst/>
-          </a:prstGeom>
-          <a:noFill/>
-        </p:spPr>
-        <p:txBody>
-          <a:bodyPr wrap="none" lIns="0" rIns="0" tIns="0" bIns="0" anchor="t">
-            <a:spAutoFit/>
-          </a:bodyPr>
-          <a:lstStyle/>
-          <a:p>
-            <a:pPr algn="ctr">
-              <a:lnSpc>
-                <a:spcPct val="100000"/>
-              </a:lnSpc>
-              <a:spcAft>
-                <a:spcPts val="0"/>
-              </a:spcAft>
-            </a:pPr>
-            <a:r>
-              <a:rPr sz="850" b="0" i="0">
-                <a:solidFill>
-                  <a:srgbClr val="767576"/>
-                </a:solidFill>
-                <a:latin typeface="Arial"/>
-              </a:rPr>
-              <a:t>+180</a:t>
-            </a:r>
-          </a:p>
-        </p:txBody>
-      </p:sp>
-      <p:sp>
-        <p:nvSpPr>
-          <p:cNvPr id="45" name="TextBox 44"/>
-          <p:cNvSpPr txBox="1"/>
-          <p:nvPr/>
-        </p:nvSpPr>
-        <p:spPr>
-          <a:xfrm>
-            <a:off x="6848856" y="2980944"/>
-            <a:ext cx="640080" cy="182880"/>
-          </a:xfrm>
-          <a:prstGeom prst="rect">
-            <a:avLst/>
-          </a:prstGeom>
-          <a:noFill/>
-        </p:spPr>
-        <p:txBody>
-          <a:bodyPr wrap="none" lIns="0" rIns="0" tIns="0" bIns="0" anchor="t">
-            <a:spAutoFit/>
-          </a:bodyPr>
-          <a:lstStyle/>
-          <a:p>
-            <a:pPr algn="ctr">
-              <a:lnSpc>
-                <a:spcPct val="100000"/>
-              </a:lnSpc>
-              <a:spcAft>
-                <a:spcPts val="0"/>
-              </a:spcAft>
-            </a:pPr>
-            <a:r>
-              <a:rPr sz="850" b="0" i="0">
-                <a:solidFill>
-                  <a:srgbClr val="767576"/>
-                </a:solidFill>
-                <a:latin typeface="Arial"/>
-              </a:rPr>
-              <a:t>+270</a:t>
-            </a:r>
-          </a:p>
-        </p:txBody>
-      </p:sp>
-      <p:sp>
-        <p:nvSpPr>
-          <p:cNvPr id="46" name="Rectangle 45"/>
+          <p:cNvPr id="28" name="Rectangle 27"/>
           <p:cNvSpPr/>
           <p:nvPr/>
         </p:nvSpPr>
         <p:spPr>
           <a:xfrm>
-            <a:off x="4133087" y="3200400"/>
-            <a:ext cx="47548" cy="146304"/>
+            <a:off x="5065775" y="2011680"/>
+            <a:ext cx="1866518" cy="201168"/>
           </a:xfrm>
           <a:prstGeom prst="rect">
             <a:avLst/>
           </a:prstGeom>
           <a:solidFill>
-            <a:srgbClr val="DB0011"/>
+            <a:srgbClr val="F4B4BB"/>
           </a:solidFill>
           <a:ln>
             <a:noFill/>
@@ -6842,62 +6086,20 @@
       </p:sp>
       <p:sp>
         <p:nvSpPr>
-          <p:cNvPr id="47" name="TextBox 46"/>
-          <p:cNvSpPr txBox="1"/>
-          <p:nvPr/>
-        </p:nvSpPr>
-        <p:spPr>
-          <a:xfrm>
-            <a:off x="4235500" y="3182112"/>
-            <a:ext cx="1872691" cy="182880"/>
-          </a:xfrm>
-          <a:prstGeom prst="rect">
-            <a:avLst/>
-          </a:prstGeom>
-          <a:noFill/>
-        </p:spPr>
-        <p:txBody>
-          <a:bodyPr wrap="none" lIns="0" rIns="0" tIns="0" bIns="0" anchor="t">
-            <a:spAutoFit/>
-          </a:bodyPr>
-          <a:lstStyle/>
-          <a:p>
-            <a:pPr algn="l">
-              <a:lnSpc>
-                <a:spcPct val="100000"/>
-              </a:lnSpc>
-              <a:spcAft>
-                <a:spcPts val="0"/>
-              </a:spcAft>
-            </a:pPr>
-            <a:r>
-              <a:rPr sz="800" b="0" i="0">
-                <a:solidFill>
-                  <a:srgbClr val="767576"/>
-                </a:solidFill>
-                <a:latin typeface="Arial"/>
-              </a:rPr>
-              <a:t>Today</a:t>
-            </a:r>
-          </a:p>
-        </p:txBody>
-      </p:sp>
-      <p:sp>
-        <p:nvSpPr>
-          <p:cNvPr id="48" name="Rectangle 47"/>
+          <p:cNvPr id="29" name="Rectangle 28"/>
           <p:cNvSpPr/>
           <p:nvPr/>
         </p:nvSpPr>
         <p:spPr>
           <a:xfrm>
-            <a:off x="6163056" y="3223260"/>
-            <a:ext cx="182880" cy="100584"/>
+            <a:off x="5065775" y="2011680"/>
+            <a:ext cx="210312" cy="201168"/>
           </a:xfrm>
           <a:prstGeom prst="rect">
             <a:avLst/>
           </a:prstGeom>
           <a:solidFill>
-            <a:srgbClr val="F4B4BB"/>
+            <a:srgbClr val="6E747A"/>
           </a:solidFill>
           <a:ln>
             <a:noFill/>
@@ -6926,62 +6128,20 @@
       </p:sp>
       <p:sp>
         <p:nvSpPr>
-          <p:cNvPr id="49" name="TextBox 48"/>
-          <p:cNvSpPr txBox="1"/>
-          <p:nvPr/>
-        </p:nvSpPr>
-        <p:spPr>
-          <a:xfrm>
-            <a:off x="6400800" y="3182112"/>
-            <a:ext cx="1737360" cy="182880"/>
-          </a:xfrm>
-          <a:prstGeom prst="rect">
-            <a:avLst/>
-          </a:prstGeom>
-          <a:noFill/>
-        </p:spPr>
-        <p:txBody>
-          <a:bodyPr wrap="none" lIns="0" rIns="0" tIns="0" bIns="0" anchor="t">
-            <a:spAutoFit/>
-          </a:bodyPr>
-          <a:lstStyle/>
-          <a:p>
-            <a:pPr algn="l">
-              <a:lnSpc>
-                <a:spcPct val="100000"/>
-              </a:lnSpc>
-              <a:spcAft>
-                <a:spcPts val="0"/>
-              </a:spcAft>
-            </a:pPr>
-            <a:r>
-              <a:rPr sz="800" b="0" i="0">
-                <a:solidFill>
-                  <a:srgbClr val="767576"/>
-                </a:solidFill>
-                <a:latin typeface="Arial"/>
-              </a:rPr>
-              <a:t>Room to the high</a:t>
-            </a:r>
-          </a:p>
-        </p:txBody>
-      </p:sp>
-      <p:sp>
-        <p:nvSpPr>
-          <p:cNvPr id="50" name="Rectangle 49"/>
+          <p:cNvPr id="30" name="Rectangle 29"/>
           <p:cNvSpPr/>
           <p:nvPr/>
         </p:nvSpPr>
         <p:spPr>
           <a:xfrm>
-            <a:off x="4133087" y="3383280"/>
-            <a:ext cx="20116" cy="146304"/>
+            <a:off x="6663690" y="1956816"/>
+            <a:ext cx="21945" cy="310896"/>
           </a:xfrm>
           <a:prstGeom prst="rect">
             <a:avLst/>
           </a:prstGeom>
           <a:solidFill>
-            <a:srgbClr val="44546A"/>
+            <a:srgbClr val="000000"/>
           </a:solidFill>
           <a:ln>
             <a:noFill/>
@@ -7010,14 +6170,56 @@
       </p:sp>
       <p:sp>
         <p:nvSpPr>
-          <p:cNvPr id="51" name="TextBox 50"/>
+          <p:cNvPr id="31" name="TextBox 30"/>
           <p:cNvSpPr txBox="1"/>
           <p:nvPr/>
         </p:nvSpPr>
         <p:spPr>
           <a:xfrm>
-            <a:off x="4208068" y="3364992"/>
-            <a:ext cx="1900123" cy="182880"/>
+            <a:off x="6217462" y="1732788"/>
+            <a:ext cx="914400" cy="173736"/>
+          </a:xfrm>
+          <a:prstGeom prst="rect">
+            <a:avLst/>
+          </a:prstGeom>
+          <a:noFill/>
+        </p:spPr>
+        <p:txBody>
+          <a:bodyPr wrap="none" lIns="0" rIns="0" tIns="0" bIns="0" anchor="t">
+            <a:spAutoFit/>
+          </a:bodyPr>
+          <a:lstStyle/>
+          <a:p>
+            <a:pPr algn="ctr">
+              <a:lnSpc>
+                <a:spcPct val="100000"/>
+              </a:lnSpc>
+              <a:spcAft>
+                <a:spcPts val="0"/>
+              </a:spcAft>
+            </a:pPr>
+            <a:r>
+              <a:rPr sz="700" b="1" i="0">
+                <a:solidFill>
+                  <a:srgbClr val="000000"/>
+                </a:solidFill>
+                <a:latin typeface="Arial"/>
+              </a:rPr>
+              <a:t>target 160</a:t>
+            </a:r>
+          </a:p>
+        </p:txBody>
+      </p:sp>
+      <p:sp>
+        <p:nvSpPr>
+          <p:cNvPr id="32" name="TextBox 31"/>
+          <p:cNvSpPr txBox="1"/>
+          <p:nvPr/>
+        </p:nvSpPr>
+        <p:spPr>
+          <a:xfrm>
+            <a:off x="6978014" y="2016252"/>
+            <a:ext cx="868680" cy="182880"/>
           </a:xfrm>
           <a:prstGeom prst="rect">
             <a:avLst/>
@@ -7039,33 +6241,117 @@
               </a:spcAft>
             </a:pPr>
             <a:r>
-              <a:rPr sz="800" b="0" i="0">
+              <a:rPr sz="750" b="0" i="0">
                 <a:solidFill>
                   <a:srgbClr val="767576"/>
                 </a:solidFill>
                 <a:latin typeface="Arial"/>
               </a:rPr>
-              <a:t>Mean</a:t>
-            </a:r>
-          </a:p>
-        </p:txBody>
-      </p:sp>
-      <p:sp>
-        <p:nvSpPr>
-          <p:cNvPr id="52" name="Rectangle 51"/>
+              <a:t>165 high</a:t>
+            </a:r>
+          </a:p>
+        </p:txBody>
+      </p:sp>
+      <p:sp>
+        <p:nvSpPr>
+          <p:cNvPr id="33" name="TextBox 32"/>
+          <p:cNvSpPr txBox="1"/>
+          <p:nvPr/>
+        </p:nvSpPr>
+        <p:spPr>
+          <a:xfrm>
+            <a:off x="4133087" y="2007107"/>
+            <a:ext cx="877824" cy="210312"/>
+          </a:xfrm>
+          <a:prstGeom prst="rect">
+            <a:avLst/>
+          </a:prstGeom>
+          <a:noFill/>
+        </p:spPr>
+        <p:txBody>
+          <a:bodyPr wrap="none" lIns="0" rIns="0" tIns="0" bIns="0" anchor="t">
+            <a:spAutoFit/>
+          </a:bodyPr>
+          <a:lstStyle/>
+          <a:p>
+            <a:pPr algn="l">
+              <a:lnSpc>
+                <a:spcPct val="100000"/>
+              </a:lnSpc>
+              <a:spcAft>
+                <a:spcPts val="0"/>
+              </a:spcAft>
+            </a:pPr>
+            <a:r>
+              <a:rPr sz="1000" b="1" i="0">
+                <a:solidFill>
+                  <a:srgbClr val="DB0011"/>
+                </a:solidFill>
+                <a:latin typeface="Arial"/>
+              </a:rPr>
+              <a:t>JGB 2s10s</a:t>
+            </a:r>
+          </a:p>
+        </p:txBody>
+      </p:sp>
+      <p:sp>
+        <p:nvSpPr>
+          <p:cNvPr id="34" name="TextBox 33"/>
+          <p:cNvSpPr txBox="1"/>
+          <p:nvPr/>
+        </p:nvSpPr>
+        <p:spPr>
+          <a:xfrm>
+            <a:off x="7168896" y="2007107"/>
+            <a:ext cx="987552" cy="210312"/>
+          </a:xfrm>
+          <a:prstGeom prst="rect">
+            <a:avLst/>
+          </a:prstGeom>
+          <a:noFill/>
+        </p:spPr>
+        <p:txBody>
+          <a:bodyPr wrap="none" lIns="0" rIns="0" tIns="0" bIns="0" anchor="t">
+            <a:spAutoFit/>
+          </a:bodyPr>
+          <a:lstStyle/>
+          <a:p>
+            <a:pPr algn="r">
+              <a:lnSpc>
+                <a:spcPct val="100000"/>
+              </a:lnSpc>
+              <a:spcAft>
+                <a:spcPts val="0"/>
+              </a:spcAft>
+            </a:pPr>
+            <a:r>
+              <a:rPr sz="1000" b="1" i="0">
+                <a:solidFill>
+                  <a:srgbClr val="DB0011"/>
+                </a:solidFill>
+                <a:latin typeface="Arial"/>
+              </a:rPr>
+              <a:t>129bp · 93rd</a:t>
+            </a:r>
+          </a:p>
+        </p:txBody>
+      </p:sp>
+      <p:sp>
+        <p:nvSpPr>
+          <p:cNvPr id="35" name="Rectangle 34"/>
           <p:cNvSpPr/>
           <p:nvPr/>
         </p:nvSpPr>
         <p:spPr>
           <a:xfrm>
-            <a:off x="6163056" y="3406140"/>
-            <a:ext cx="182880" cy="100584"/>
+            <a:off x="5065775" y="2688336"/>
+            <a:ext cx="646709" cy="201168"/>
           </a:xfrm>
           <a:prstGeom prst="rect">
             <a:avLst/>
           </a:prstGeom>
           <a:solidFill>
-            <a:srgbClr val="D7D8D6"/>
+            <a:srgbClr val="F4B4BB"/>
           </a:solidFill>
           <a:ln>
             <a:noFill/>
@@ -7094,14 +6380,140 @@
       </p:sp>
       <p:sp>
         <p:nvSpPr>
-          <p:cNvPr id="53" name="TextBox 52"/>
+          <p:cNvPr id="36" name="Rectangle 35"/>
+          <p:cNvSpPr/>
+          <p:nvPr/>
+        </p:nvSpPr>
+        <p:spPr>
+          <a:xfrm>
+            <a:off x="5065775" y="2688336"/>
+            <a:ext cx="210312" cy="201168"/>
+          </a:xfrm>
+          <a:prstGeom prst="rect">
+            <a:avLst/>
+          </a:prstGeom>
+          <a:solidFill>
+            <a:srgbClr val="6E747A"/>
+          </a:solidFill>
+          <a:ln>
+            <a:noFill/>
+          </a:ln>
+          <a:effectLst/>
+        </p:spPr>
+        <p:style>
+          <a:lnRef idx="1">
+            <a:schemeClr val="accent1"/>
+          </a:lnRef>
+          <a:fillRef idx="3">
+            <a:schemeClr val="accent1"/>
+          </a:fillRef>
+          <a:effectRef idx="2">
+            <a:schemeClr val="accent1"/>
+          </a:effectRef>
+          <a:fontRef idx="minor">
+            <a:schemeClr val="lt1"/>
+          </a:fontRef>
+        </p:style>
+        <p:txBody>
+          <a:bodyPr rtlCol="0" anchor="ctr"/>
+          <a:lstStyle/>
+          <a:p/>
+        </p:txBody>
+      </p:sp>
+      <p:sp>
+        <p:nvSpPr>
+          <p:cNvPr id="37" name="Rectangle 36"/>
+          <p:cNvSpPr/>
+          <p:nvPr/>
+        </p:nvSpPr>
+        <p:spPr>
+          <a:xfrm>
+            <a:off x="5606872" y="2633472"/>
+            <a:ext cx="21945" cy="310896"/>
+          </a:xfrm>
+          <a:prstGeom prst="rect">
+            <a:avLst/>
+          </a:prstGeom>
+          <a:solidFill>
+            <a:srgbClr val="000000"/>
+          </a:solidFill>
+          <a:ln>
+            <a:noFill/>
+          </a:ln>
+          <a:effectLst/>
+        </p:spPr>
+        <p:style>
+          <a:lnRef idx="1">
+            <a:schemeClr val="accent1"/>
+          </a:lnRef>
+          <a:fillRef idx="3">
+            <a:schemeClr val="accent1"/>
+          </a:fillRef>
+          <a:effectRef idx="2">
+            <a:schemeClr val="accent1"/>
+          </a:effectRef>
+          <a:fontRef idx="minor">
+            <a:schemeClr val="lt1"/>
+          </a:fontRef>
+        </p:style>
+        <p:txBody>
+          <a:bodyPr rtlCol="0" anchor="ctr"/>
+          <a:lstStyle/>
+          <a:p/>
+        </p:txBody>
+      </p:sp>
+      <p:sp>
+        <p:nvSpPr>
+          <p:cNvPr id="38" name="TextBox 37"/>
           <p:cNvSpPr txBox="1"/>
           <p:nvPr/>
         </p:nvSpPr>
         <p:spPr>
           <a:xfrm>
-            <a:off x="6400800" y="3364992"/>
-            <a:ext cx="1737360" cy="182880"/>
+            <a:off x="5160644" y="2409444"/>
+            <a:ext cx="914400" cy="173736"/>
+          </a:xfrm>
+          <a:prstGeom prst="rect">
+            <a:avLst/>
+          </a:prstGeom>
+          <a:noFill/>
+        </p:spPr>
+        <p:txBody>
+          <a:bodyPr wrap="none" lIns="0" rIns="0" tIns="0" bIns="0" anchor="t">
+            <a:spAutoFit/>
+          </a:bodyPr>
+          <a:lstStyle/>
+          <a:p>
+            <a:pPr algn="ctr">
+              <a:lnSpc>
+                <a:spcPct val="100000"/>
+              </a:lnSpc>
+              <a:spcAft>
+                <a:spcPts val="0"/>
+              </a:spcAft>
+            </a:pPr>
+            <a:r>
+              <a:rPr sz="700" b="1" i="0">
+                <a:solidFill>
+                  <a:srgbClr val="000000"/>
+                </a:solidFill>
+                <a:latin typeface="Arial"/>
+              </a:rPr>
+              <a:t>target 258</a:t>
+            </a:r>
+          </a:p>
+        </p:txBody>
+      </p:sp>
+      <p:sp>
+        <p:nvSpPr>
+          <p:cNvPr id="39" name="TextBox 38"/>
+          <p:cNvSpPr txBox="1"/>
+          <p:nvPr/>
+        </p:nvSpPr>
+        <p:spPr>
+          <a:xfrm>
+            <a:off x="5758205" y="2692908"/>
+            <a:ext cx="868680" cy="182880"/>
           </a:xfrm>
           <a:prstGeom prst="rect">
             <a:avLst/>
@@ -7123,27 +6535,69 @@
               </a:spcAft>
             </a:pPr>
             <a:r>
-              <a:rPr sz="800" b="0" i="0">
+              <a:rPr sz="750" b="0" i="0">
                 <a:solidFill>
                   <a:srgbClr val="767576"/>
                 </a:solidFill>
                 <a:latin typeface="Arial"/>
               </a:rPr>
-              <a:t>Range since 2000</a:t>
-            </a:r>
-          </a:p>
-        </p:txBody>
-      </p:sp>
-      <p:sp>
-        <p:nvSpPr>
-          <p:cNvPr id="54" name="TextBox 53"/>
+              <a:t>260 high</a:t>
+            </a:r>
+          </a:p>
+        </p:txBody>
+      </p:sp>
+      <p:sp>
+        <p:nvSpPr>
+          <p:cNvPr id="40" name="TextBox 39"/>
           <p:cNvSpPr txBox="1"/>
           <p:nvPr/>
         </p:nvSpPr>
         <p:spPr>
           <a:xfrm>
-            <a:off x="6236207" y="3584448"/>
-            <a:ext cx="914400" cy="164592"/>
+            <a:off x="4133087" y="2683763"/>
+            <a:ext cx="877824" cy="210312"/>
+          </a:xfrm>
+          <a:prstGeom prst="rect">
+            <a:avLst/>
+          </a:prstGeom>
+          <a:noFill/>
+        </p:spPr>
+        <p:txBody>
+          <a:bodyPr wrap="none" lIns="0" rIns="0" tIns="0" bIns="0" anchor="t">
+            <a:spAutoFit/>
+          </a:bodyPr>
+          <a:lstStyle/>
+          <a:p>
+            <a:pPr algn="l">
+              <a:lnSpc>
+                <a:spcPct val="100000"/>
+              </a:lnSpc>
+              <a:spcAft>
+                <a:spcPts val="0"/>
+              </a:spcAft>
+            </a:pPr>
+            <a:r>
+              <a:rPr sz="1000" b="1" i="0">
+                <a:solidFill>
+                  <a:srgbClr val="767576"/>
+                </a:solidFill>
+                <a:latin typeface="Arial"/>
+              </a:rPr>
+              <a:t>JGB 2s30s</a:t>
+            </a:r>
+          </a:p>
+        </p:txBody>
+      </p:sp>
+      <p:sp>
+        <p:nvSpPr>
+          <p:cNvPr id="41" name="TextBox 40"/>
+          <p:cNvSpPr txBox="1"/>
+          <p:nvPr/>
+        </p:nvSpPr>
+        <p:spPr>
+          <a:xfrm>
+            <a:off x="7168896" y="2683763"/>
+            <a:ext cx="987552" cy="210312"/>
           </a:xfrm>
           <a:prstGeom prst="rect">
             <a:avLst/>
@@ -7165,69 +6619,27 @@
               </a:spcAft>
             </a:pPr>
             <a:r>
-              <a:rPr sz="850" b="1" i="0">
-                <a:solidFill>
-                  <a:srgbClr val="DB0011"/>
-                </a:solidFill>
-                <a:latin typeface="Arial"/>
-              </a:rPr>
-              <a:t>2s10s</a:t>
-            </a:r>
-          </a:p>
-        </p:txBody>
-      </p:sp>
-      <p:sp>
-        <p:nvSpPr>
-          <p:cNvPr id="55" name="TextBox 54"/>
-          <p:cNvSpPr txBox="1"/>
-          <p:nvPr/>
-        </p:nvSpPr>
-        <p:spPr>
-          <a:xfrm>
-            <a:off x="7150607" y="3584448"/>
-            <a:ext cx="914400" cy="164592"/>
-          </a:xfrm>
-          <a:prstGeom prst="rect">
-            <a:avLst/>
-          </a:prstGeom>
-          <a:noFill/>
-        </p:spPr>
-        <p:txBody>
-          <a:bodyPr wrap="none" lIns="0" rIns="0" tIns="0" bIns="0" anchor="t">
-            <a:spAutoFit/>
-          </a:bodyPr>
-          <a:lstStyle/>
-          <a:p>
-            <a:pPr algn="r">
-              <a:lnSpc>
-                <a:spcPct val="100000"/>
-              </a:lnSpc>
-              <a:spcAft>
-                <a:spcPts val="0"/>
-              </a:spcAft>
-            </a:pPr>
-            <a:r>
-              <a:rPr sz="850" b="1" i="0">
+              <a:rPr sz="1000" b="0" i="0">
                 <a:solidFill>
                   <a:srgbClr val="767576"/>
                 </a:solidFill>
                 <a:latin typeface="Arial"/>
               </a:rPr>
-              <a:t>2s30s</a:t>
+              <a:t>248bp · 99th</a:t>
             </a:r>
           </a:p>
         </p:txBody>
       </p:sp>
       <p:cxnSp>
         <p:nvCxnSpPr>
-          <p:cNvPr id="56" name="Connector 55"/>
+          <p:cNvPr id="42" name="Connector 41"/>
           <p:cNvCxnSpPr/>
           <p:nvPr/>
         </p:nvCxnSpPr>
         <p:spPr>
           <a:xfrm>
-            <a:off x="4133087" y="3767328"/>
-            <a:ext cx="3931921" cy="0"/>
+            <a:off x="5065775" y="3127248"/>
+            <a:ext cx="2103121" cy="0"/>
           </a:xfrm>
           <a:prstGeom prst="line">
             <a:avLst/>
@@ -7255,14 +6667,266 @@
       </p:cxnSp>
       <p:sp>
         <p:nvSpPr>
-          <p:cNvPr id="57" name="TextBox 56"/>
+          <p:cNvPr id="43" name="TextBox 42"/>
           <p:cNvSpPr txBox="1"/>
           <p:nvPr/>
         </p:nvSpPr>
         <p:spPr>
           <a:xfrm>
-            <a:off x="4133087" y="3822191"/>
-            <a:ext cx="2029967" cy="164592"/>
+            <a:off x="4791455" y="3163824"/>
+            <a:ext cx="548640" cy="164592"/>
+          </a:xfrm>
+          <a:prstGeom prst="rect">
+            <a:avLst/>
+          </a:prstGeom>
+          <a:noFill/>
+        </p:spPr>
+        <p:txBody>
+          <a:bodyPr wrap="none" lIns="0" rIns="0" tIns="0" bIns="0" anchor="t">
+            <a:spAutoFit/>
+          </a:bodyPr>
+          <a:lstStyle/>
+          <a:p>
+            <a:pPr algn="ctr">
+              <a:lnSpc>
+                <a:spcPct val="100000"/>
+              </a:lnSpc>
+              <a:spcAft>
+                <a:spcPts val="0"/>
+              </a:spcAft>
+            </a:pPr>
+            <a:r>
+              <a:rPr sz="800" b="0" i="0">
+                <a:solidFill>
+                  <a:srgbClr val="767576"/>
+                </a:solidFill>
+                <a:latin typeface="Arial"/>
+              </a:rPr>
+              <a:t>0</a:t>
+            </a:r>
+          </a:p>
+        </p:txBody>
+      </p:sp>
+      <p:sp>
+        <p:nvSpPr>
+          <p:cNvPr id="44" name="TextBox 43"/>
+          <p:cNvSpPr txBox="1"/>
+          <p:nvPr/>
+        </p:nvSpPr>
+        <p:spPr>
+          <a:xfrm>
+            <a:off x="5317236" y="3163824"/>
+            <a:ext cx="548640" cy="164592"/>
+          </a:xfrm>
+          <a:prstGeom prst="rect">
+            <a:avLst/>
+          </a:prstGeom>
+          <a:noFill/>
+        </p:spPr>
+        <p:txBody>
+          <a:bodyPr wrap="none" lIns="0" rIns="0" tIns="0" bIns="0" anchor="t">
+            <a:spAutoFit/>
+          </a:bodyPr>
+          <a:lstStyle/>
+          <a:p>
+            <a:pPr algn="ctr">
+              <a:lnSpc>
+                <a:spcPct val="100000"/>
+              </a:lnSpc>
+              <a:spcAft>
+                <a:spcPts val="0"/>
+              </a:spcAft>
+            </a:pPr>
+            <a:r>
+              <a:rPr sz="800" b="0" i="0">
+                <a:solidFill>
+                  <a:srgbClr val="767576"/>
+                </a:solidFill>
+                <a:latin typeface="Arial"/>
+              </a:rPr>
+              <a:t>+10</a:t>
+            </a:r>
+          </a:p>
+        </p:txBody>
+      </p:sp>
+      <p:sp>
+        <p:nvSpPr>
+          <p:cNvPr id="45" name="TextBox 44"/>
+          <p:cNvSpPr txBox="1"/>
+          <p:nvPr/>
+        </p:nvSpPr>
+        <p:spPr>
+          <a:xfrm>
+            <a:off x="5843016" y="3163824"/>
+            <a:ext cx="548640" cy="164592"/>
+          </a:xfrm>
+          <a:prstGeom prst="rect">
+            <a:avLst/>
+          </a:prstGeom>
+          <a:noFill/>
+        </p:spPr>
+        <p:txBody>
+          <a:bodyPr wrap="none" lIns="0" rIns="0" tIns="0" bIns="0" anchor="t">
+            <a:spAutoFit/>
+          </a:bodyPr>
+          <a:lstStyle/>
+          <a:p>
+            <a:pPr algn="ctr">
+              <a:lnSpc>
+                <a:spcPct val="100000"/>
+              </a:lnSpc>
+              <a:spcAft>
+                <a:spcPts val="0"/>
+              </a:spcAft>
+            </a:pPr>
+            <a:r>
+              <a:rPr sz="800" b="0" i="0">
+                <a:solidFill>
+                  <a:srgbClr val="767576"/>
+                </a:solidFill>
+                <a:latin typeface="Arial"/>
+              </a:rPr>
+              <a:t>+20</a:t>
+            </a:r>
+          </a:p>
+        </p:txBody>
+      </p:sp>
+      <p:sp>
+        <p:nvSpPr>
+          <p:cNvPr id="46" name="TextBox 45"/>
+          <p:cNvSpPr txBox="1"/>
+          <p:nvPr/>
+        </p:nvSpPr>
+        <p:spPr>
+          <a:xfrm>
+            <a:off x="6368795" y="3163824"/>
+            <a:ext cx="548640" cy="164592"/>
+          </a:xfrm>
+          <a:prstGeom prst="rect">
+            <a:avLst/>
+          </a:prstGeom>
+          <a:noFill/>
+        </p:spPr>
+        <p:txBody>
+          <a:bodyPr wrap="none" lIns="0" rIns="0" tIns="0" bIns="0" anchor="t">
+            <a:spAutoFit/>
+          </a:bodyPr>
+          <a:lstStyle/>
+          <a:p>
+            <a:pPr algn="ctr">
+              <a:lnSpc>
+                <a:spcPct val="100000"/>
+              </a:lnSpc>
+              <a:spcAft>
+                <a:spcPts val="0"/>
+              </a:spcAft>
+            </a:pPr>
+            <a:r>
+              <a:rPr sz="800" b="0" i="0">
+                <a:solidFill>
+                  <a:srgbClr val="767576"/>
+                </a:solidFill>
+                <a:latin typeface="Arial"/>
+              </a:rPr>
+              <a:t>+30</a:t>
+            </a:r>
+          </a:p>
+        </p:txBody>
+      </p:sp>
+      <p:sp>
+        <p:nvSpPr>
+          <p:cNvPr id="47" name="TextBox 46"/>
+          <p:cNvSpPr txBox="1"/>
+          <p:nvPr/>
+        </p:nvSpPr>
+        <p:spPr>
+          <a:xfrm>
+            <a:off x="6894576" y="3163824"/>
+            <a:ext cx="548640" cy="164592"/>
+          </a:xfrm>
+          <a:prstGeom prst="rect">
+            <a:avLst/>
+          </a:prstGeom>
+          <a:noFill/>
+        </p:spPr>
+        <p:txBody>
+          <a:bodyPr wrap="none" lIns="0" rIns="0" tIns="0" bIns="0" anchor="t">
+            <a:spAutoFit/>
+          </a:bodyPr>
+          <a:lstStyle/>
+          <a:p>
+            <a:pPr algn="ctr">
+              <a:lnSpc>
+                <a:spcPct val="100000"/>
+              </a:lnSpc>
+              <a:spcAft>
+                <a:spcPts val="0"/>
+              </a:spcAft>
+            </a:pPr>
+            <a:r>
+              <a:rPr sz="800" b="0" i="0">
+                <a:solidFill>
+                  <a:srgbClr val="767576"/>
+                </a:solidFill>
+                <a:latin typeface="Arial"/>
+              </a:rPr>
+              <a:t>+40</a:t>
+            </a:r>
+          </a:p>
+        </p:txBody>
+      </p:sp>
+      <p:sp>
+        <p:nvSpPr>
+          <p:cNvPr id="48" name="Rectangle 47"/>
+          <p:cNvSpPr/>
+          <p:nvPr/>
+        </p:nvSpPr>
+        <p:spPr>
+          <a:xfrm>
+            <a:off x="4133087" y="3406140"/>
+            <a:ext cx="182880" cy="100584"/>
+          </a:xfrm>
+          <a:prstGeom prst="rect">
+            <a:avLst/>
+          </a:prstGeom>
+          <a:solidFill>
+            <a:srgbClr val="6E747A"/>
+          </a:solidFill>
+          <a:ln>
+            <a:noFill/>
+          </a:ln>
+          <a:effectLst/>
+        </p:spPr>
+        <p:style>
+          <a:lnRef idx="1">
+            <a:schemeClr val="accent1"/>
+          </a:lnRef>
+          <a:fillRef idx="3">
+            <a:schemeClr val="accent1"/>
+          </a:fillRef>
+          <a:effectRef idx="2">
+            <a:schemeClr val="accent1"/>
+          </a:effectRef>
+          <a:fontRef idx="minor">
+            <a:schemeClr val="lt1"/>
+          </a:fontRef>
+        </p:style>
+        <p:txBody>
+          <a:bodyPr rtlCol="0" anchor="ctr"/>
+          <a:lstStyle/>
+          <a:p/>
+        </p:txBody>
+      </p:sp>
+      <p:sp>
+        <p:nvSpPr>
+          <p:cNvPr id="49" name="TextBox 48"/>
+          <p:cNvSpPr txBox="1"/>
+          <p:nvPr/>
+        </p:nvSpPr>
+        <p:spPr>
+          <a:xfrm>
+            <a:off x="4370831" y="3364992"/>
+            <a:ext cx="1737360" cy="182880"/>
           </a:xfrm>
           <a:prstGeom prst="rect">
             <a:avLst/>
@@ -7286,24 +6950,108 @@
             <a:r>
               <a:rPr sz="800" b="0" i="0">
                 <a:solidFill>
-                  <a:srgbClr val="000000"/>
+                  <a:srgbClr val="767576"/>
                 </a:solidFill>
                 <a:latin typeface="Arial"/>
               </a:rPr>
-              <a:t>Headroom to the high since 2000</a:t>
-            </a:r>
-          </a:p>
-        </p:txBody>
-      </p:sp>
-      <p:sp>
-        <p:nvSpPr>
-          <p:cNvPr id="58" name="TextBox 57"/>
+              <a:t>4bp round trip</a:t>
+            </a:r>
+          </a:p>
+        </p:txBody>
+      </p:sp>
+      <p:sp>
+        <p:nvSpPr>
+          <p:cNvPr id="50" name="Rectangle 49"/>
+          <p:cNvSpPr/>
+          <p:nvPr/>
+        </p:nvSpPr>
+        <p:spPr>
+          <a:xfrm>
+            <a:off x="6163056" y="3406140"/>
+            <a:ext cx="182880" cy="100584"/>
+          </a:xfrm>
+          <a:prstGeom prst="rect">
+            <a:avLst/>
+          </a:prstGeom>
+          <a:solidFill>
+            <a:srgbClr val="F4B4BB"/>
+          </a:solidFill>
+          <a:ln>
+            <a:noFill/>
+          </a:ln>
+          <a:effectLst/>
+        </p:spPr>
+        <p:style>
+          <a:lnRef idx="1">
+            <a:schemeClr val="accent1"/>
+          </a:lnRef>
+          <a:fillRef idx="3">
+            <a:schemeClr val="accent1"/>
+          </a:fillRef>
+          <a:effectRef idx="2">
+            <a:schemeClr val="accent1"/>
+          </a:effectRef>
+          <a:fontRef idx="minor">
+            <a:schemeClr val="lt1"/>
+          </a:fontRef>
+        </p:style>
+        <p:txBody>
+          <a:bodyPr rtlCol="0" anchor="ctr"/>
+          <a:lstStyle/>
+          <a:p/>
+        </p:txBody>
+      </p:sp>
+      <p:sp>
+        <p:nvSpPr>
+          <p:cNvPr id="51" name="TextBox 50"/>
           <p:cNvSpPr txBox="1"/>
           <p:nvPr/>
         </p:nvSpPr>
         <p:spPr>
           <a:xfrm>
-            <a:off x="6236207" y="3822191"/>
+            <a:off x="6400800" y="3364992"/>
+            <a:ext cx="1737360" cy="182880"/>
+          </a:xfrm>
+          <a:prstGeom prst="rect">
+            <a:avLst/>
+          </a:prstGeom>
+          <a:noFill/>
+        </p:spPr>
+        <p:txBody>
+          <a:bodyPr wrap="none" lIns="0" rIns="0" tIns="0" bIns="0" anchor="t">
+            <a:spAutoFit/>
+          </a:bodyPr>
+          <a:lstStyle/>
+          <a:p>
+            <a:pPr algn="l">
+              <a:lnSpc>
+                <a:spcPct val="100000"/>
+              </a:lnSpc>
+              <a:spcAft>
+                <a:spcPts val="0"/>
+              </a:spcAft>
+            </a:pPr>
+            <a:r>
+              <a:rPr sz="800" b="0" i="0">
+                <a:solidFill>
+                  <a:srgbClr val="767576"/>
+                </a:solidFill>
+                <a:latin typeface="Arial"/>
+              </a:rPr>
+              <a:t>Room to the high since 2000</a:t>
+            </a:r>
+          </a:p>
+        </p:txBody>
+      </p:sp>
+      <p:sp>
+        <p:nvSpPr>
+          <p:cNvPr id="52" name="TextBox 51"/>
+          <p:cNvSpPr txBox="1"/>
+          <p:nvPr/>
+        </p:nvSpPr>
+        <p:spPr>
+          <a:xfrm>
+            <a:off x="6236207" y="3584448"/>
             <a:ext cx="914400" cy="164592"/>
           </a:xfrm>
           <a:prstGeom prst="rect">
@@ -7332,20 +7080,20 @@
                 </a:solidFill>
                 <a:latin typeface="Arial"/>
               </a:rPr>
-              <a:t>+35.5bp</a:t>
-            </a:r>
-          </a:p>
-        </p:txBody>
-      </p:sp>
-      <p:sp>
-        <p:nvSpPr>
-          <p:cNvPr id="59" name="TextBox 58"/>
+              <a:t>2s10s</a:t>
+            </a:r>
+          </a:p>
+        </p:txBody>
+      </p:sp>
+      <p:sp>
+        <p:nvSpPr>
+          <p:cNvPr id="53" name="TextBox 52"/>
           <p:cNvSpPr txBox="1"/>
           <p:nvPr/>
         </p:nvSpPr>
         <p:spPr>
           <a:xfrm>
-            <a:off x="7150607" y="3822191"/>
+            <a:off x="7150607" y="3584448"/>
             <a:ext cx="914400" cy="164592"/>
           </a:xfrm>
           <a:prstGeom prst="rect">
@@ -7368,34 +7116,34 @@
               </a:spcAft>
             </a:pPr>
             <a:r>
-              <a:rPr sz="850" b="0" i="0">
+              <a:rPr sz="850" b="1" i="0">
                 <a:solidFill>
                   <a:srgbClr val="767576"/>
                 </a:solidFill>
                 <a:latin typeface="Arial"/>
               </a:rPr>
-              <a:t>+12.3bp</a:t>
+              <a:t>2s30s</a:t>
             </a:r>
           </a:p>
         </p:txBody>
       </p:sp>
       <p:cxnSp>
         <p:nvCxnSpPr>
-          <p:cNvPr id="60" name="Connector 59"/>
+          <p:cNvPr id="54" name="Connector 53"/>
           <p:cNvCxnSpPr/>
           <p:nvPr/>
         </p:nvCxnSpPr>
         <p:spPr>
           <a:xfrm>
-            <a:off x="4133087" y="3968496"/>
+            <a:off x="4133087" y="3767328"/>
             <a:ext cx="3931921" cy="0"/>
           </a:xfrm>
           <a:prstGeom prst="line">
             <a:avLst/>
           </a:prstGeom>
-          <a:ln w="6350">
+          <a:ln w="9525">
             <a:solidFill>
-              <a:srgbClr val="D0CECE"/>
+              <a:srgbClr val="000000"/>
             </a:solidFill>
           </a:ln>
         </p:spPr>
@@ -7416,13 +7164,13 @@
       </p:cxnSp>
       <p:sp>
         <p:nvSpPr>
-          <p:cNvPr id="61" name="TextBox 60"/>
+          <p:cNvPr id="55" name="TextBox 54"/>
           <p:cNvSpPr txBox="1"/>
           <p:nvPr/>
         </p:nvSpPr>
         <p:spPr>
           <a:xfrm>
-            <a:off x="4133087" y="4005072"/>
+            <a:off x="4133087" y="3822191"/>
             <a:ext cx="2029967" cy="164592"/>
           </a:xfrm>
           <a:prstGeom prst="rect">
@@ -7451,20 +7199,20 @@
                 </a:solidFill>
                 <a:latin typeface="Arial"/>
               </a:rPr>
-              <a:t>Round trip, share of headroom</a:t>
-            </a:r>
-          </a:p>
-        </p:txBody>
-      </p:sp>
-      <p:sp>
-        <p:nvSpPr>
-          <p:cNvPr id="62" name="TextBox 61"/>
+              <a:t>Percentile since 2000</a:t>
+            </a:r>
+          </a:p>
+        </p:txBody>
+      </p:sp>
+      <p:sp>
+        <p:nvSpPr>
+          <p:cNvPr id="56" name="TextBox 55"/>
           <p:cNvSpPr txBox="1"/>
           <p:nvPr/>
         </p:nvSpPr>
         <p:spPr>
           <a:xfrm>
-            <a:off x="6236207" y="4005072"/>
+            <a:off x="6236207" y="3822191"/>
             <a:ext cx="914400" cy="164592"/>
           </a:xfrm>
           <a:prstGeom prst="rect">
@@ -7493,20 +7241,20 @@
                 </a:solidFill>
                 <a:latin typeface="Arial"/>
               </a:rPr>
-              <a:t>11%</a:t>
-            </a:r>
-          </a:p>
-        </p:txBody>
-      </p:sp>
-      <p:sp>
-        <p:nvSpPr>
-          <p:cNvPr id="63" name="TextBox 62"/>
+              <a:t>93rd</a:t>
+            </a:r>
+          </a:p>
+        </p:txBody>
+      </p:sp>
+      <p:sp>
+        <p:nvSpPr>
+          <p:cNvPr id="57" name="TextBox 56"/>
           <p:cNvSpPr txBox="1"/>
           <p:nvPr/>
         </p:nvSpPr>
         <p:spPr>
           <a:xfrm>
-            <a:off x="7150607" y="4005072"/>
+            <a:off x="7150607" y="3822191"/>
             <a:ext cx="914400" cy="164592"/>
           </a:xfrm>
           <a:prstGeom prst="rect">
@@ -7535,20 +7283,20 @@
                 </a:solidFill>
                 <a:latin typeface="Arial"/>
               </a:rPr>
-              <a:t>33%</a:t>
+              <a:t>99th</a:t>
             </a:r>
           </a:p>
         </p:txBody>
       </p:sp>
       <p:cxnSp>
         <p:nvCxnSpPr>
-          <p:cNvPr id="64" name="Connector 63"/>
+          <p:cNvPr id="58" name="Connector 57"/>
           <p:cNvCxnSpPr/>
           <p:nvPr/>
         </p:nvCxnSpPr>
         <p:spPr>
           <a:xfrm>
-            <a:off x="4133087" y="4151376"/>
+            <a:off x="4133087" y="3968496"/>
             <a:ext cx="3931921" cy="0"/>
           </a:xfrm>
           <a:prstGeom prst="line">
@@ -7577,13 +7325,13 @@
       </p:cxnSp>
       <p:sp>
         <p:nvSpPr>
-          <p:cNvPr id="65" name="TextBox 64"/>
+          <p:cNvPr id="59" name="TextBox 58"/>
           <p:cNvSpPr txBox="1"/>
           <p:nvPr/>
         </p:nvSpPr>
         <p:spPr>
           <a:xfrm>
-            <a:off x="4133087" y="4187952"/>
+            <a:off x="4133087" y="4005072"/>
             <a:ext cx="2029967" cy="164592"/>
           </a:xfrm>
           <a:prstGeom prst="rect">
@@ -7612,20 +7360,20 @@
                 </a:solidFill>
                 <a:latin typeface="Arial"/>
               </a:rPr>
-              <a:t>Risk : reward, net of costs</a:t>
-            </a:r>
-          </a:p>
-        </p:txBody>
-      </p:sp>
-      <p:sp>
-        <p:nvSpPr>
-          <p:cNvPr id="66" name="TextBox 65"/>
+              <a:t>Notional per ¥1bn back leg</a:t>
+            </a:r>
+          </a:p>
+        </p:txBody>
+      </p:sp>
+      <p:sp>
+        <p:nvSpPr>
+          <p:cNvPr id="60" name="TextBox 59"/>
           <p:cNvSpPr txBox="1"/>
           <p:nvPr/>
         </p:nvSpPr>
         <p:spPr>
           <a:xfrm>
-            <a:off x="6236207" y="4187952"/>
+            <a:off x="6236207" y="4005072"/>
             <a:ext cx="914400" cy="164592"/>
           </a:xfrm>
           <a:prstGeom prst="rect">
@@ -7654,20 +7402,20 @@
                 </a:solidFill>
                 <a:latin typeface="Arial"/>
               </a:rPr>
-              <a:t>2.1 : 1</a:t>
-            </a:r>
-          </a:p>
-        </p:txBody>
-      </p:sp>
-      <p:sp>
-        <p:nvSpPr>
-          <p:cNvPr id="67" name="TextBox 66"/>
+              <a:t>¥5.5bn</a:t>
+            </a:r>
+          </a:p>
+        </p:txBody>
+      </p:sp>
+      <p:sp>
+        <p:nvSpPr>
+          <p:cNvPr id="61" name="TextBox 60"/>
           <p:cNvSpPr txBox="1"/>
           <p:nvPr/>
         </p:nvSpPr>
         <p:spPr>
           <a:xfrm>
-            <a:off x="7150607" y="4187952"/>
+            <a:off x="7150607" y="4005072"/>
             <a:ext cx="914400" cy="164592"/>
           </a:xfrm>
           <a:prstGeom prst="rect">
@@ -7696,20 +7444,20 @@
                 </a:solidFill>
                 <a:latin typeface="Arial"/>
               </a:rPr>
-              <a:t>1.1 : 1</a:t>
+              <a:t>¥10.3bn</a:t>
             </a:r>
           </a:p>
         </p:txBody>
       </p:sp>
       <p:cxnSp>
         <p:nvCxnSpPr>
-          <p:cNvPr id="68" name="Connector 67"/>
+          <p:cNvPr id="62" name="Connector 61"/>
           <p:cNvCxnSpPr/>
           <p:nvPr/>
         </p:nvCxnSpPr>
         <p:spPr>
           <a:xfrm>
-            <a:off x="4133087" y="4334256"/>
+            <a:off x="4133087" y="4151376"/>
             <a:ext cx="3931921" cy="0"/>
           </a:xfrm>
           <a:prstGeom prst="line">
@@ -7738,7 +7486,168 @@
       </p:cxnSp>
       <p:sp>
         <p:nvSpPr>
-          <p:cNvPr id="69" name="TextBox 68"/>
+          <p:cNvPr id="63" name="TextBox 62"/>
+          <p:cNvSpPr txBox="1"/>
+          <p:nvPr/>
+        </p:nvSpPr>
+        <p:spPr>
+          <a:xfrm>
+            <a:off x="4133087" y="4187952"/>
+            <a:ext cx="2029967" cy="164592"/>
+          </a:xfrm>
+          <a:prstGeom prst="rect">
+            <a:avLst/>
+          </a:prstGeom>
+          <a:noFill/>
+        </p:spPr>
+        <p:txBody>
+          <a:bodyPr wrap="none" lIns="0" rIns="0" tIns="0" bIns="0" anchor="t">
+            <a:spAutoFit/>
+          </a:bodyPr>
+          <a:lstStyle/>
+          <a:p>
+            <a:pPr algn="l">
+              <a:lnSpc>
+                <a:spcPct val="100000"/>
+              </a:lnSpc>
+              <a:spcAft>
+                <a:spcPts val="0"/>
+              </a:spcAft>
+            </a:pPr>
+            <a:r>
+              <a:rPr sz="800" b="0" i="0">
+                <a:solidFill>
+                  <a:srgbClr val="000000"/>
+                </a:solidFill>
+                <a:latin typeface="Arial"/>
+              </a:rPr>
+              <a:t>Risk : reward, net of costs</a:t>
+            </a:r>
+          </a:p>
+        </p:txBody>
+      </p:sp>
+      <p:sp>
+        <p:nvSpPr>
+          <p:cNvPr id="64" name="TextBox 63"/>
+          <p:cNvSpPr txBox="1"/>
+          <p:nvPr/>
+        </p:nvSpPr>
+        <p:spPr>
+          <a:xfrm>
+            <a:off x="6236207" y="4187952"/>
+            <a:ext cx="914400" cy="164592"/>
+          </a:xfrm>
+          <a:prstGeom prst="rect">
+            <a:avLst/>
+          </a:prstGeom>
+          <a:noFill/>
+        </p:spPr>
+        <p:txBody>
+          <a:bodyPr wrap="none" lIns="0" rIns="0" tIns="0" bIns="0" anchor="t">
+            <a:spAutoFit/>
+          </a:bodyPr>
+          <a:lstStyle/>
+          <a:p>
+            <a:pPr algn="r">
+              <a:lnSpc>
+                <a:spcPct val="100000"/>
+              </a:lnSpc>
+              <a:spcAft>
+                <a:spcPts val="0"/>
+              </a:spcAft>
+            </a:pPr>
+            <a:r>
+              <a:rPr sz="850" b="1" i="0">
+                <a:solidFill>
+                  <a:srgbClr val="DB0011"/>
+                </a:solidFill>
+                <a:latin typeface="Arial"/>
+              </a:rPr>
+              <a:t>2.1 : 1</a:t>
+            </a:r>
+          </a:p>
+        </p:txBody>
+      </p:sp>
+      <p:sp>
+        <p:nvSpPr>
+          <p:cNvPr id="65" name="TextBox 64"/>
+          <p:cNvSpPr txBox="1"/>
+          <p:nvPr/>
+        </p:nvSpPr>
+        <p:spPr>
+          <a:xfrm>
+            <a:off x="7150607" y="4187952"/>
+            <a:ext cx="914400" cy="164592"/>
+          </a:xfrm>
+          <a:prstGeom prst="rect">
+            <a:avLst/>
+          </a:prstGeom>
+          <a:noFill/>
+        </p:spPr>
+        <p:txBody>
+          <a:bodyPr wrap="none" lIns="0" rIns="0" tIns="0" bIns="0" anchor="t">
+            <a:spAutoFit/>
+          </a:bodyPr>
+          <a:lstStyle/>
+          <a:p>
+            <a:pPr algn="r">
+              <a:lnSpc>
+                <a:spcPct val="100000"/>
+              </a:lnSpc>
+              <a:spcAft>
+                <a:spcPts val="0"/>
+              </a:spcAft>
+            </a:pPr>
+            <a:r>
+              <a:rPr sz="850" b="0" i="0">
+                <a:solidFill>
+                  <a:srgbClr val="767576"/>
+                </a:solidFill>
+                <a:latin typeface="Arial"/>
+              </a:rPr>
+              <a:t>1.1 : 1</a:t>
+            </a:r>
+          </a:p>
+        </p:txBody>
+      </p:sp>
+      <p:cxnSp>
+        <p:nvCxnSpPr>
+          <p:cNvPr id="66" name="Connector 65"/>
+          <p:cNvCxnSpPr/>
+          <p:nvPr/>
+        </p:nvCxnSpPr>
+        <p:spPr>
+          <a:xfrm>
+            <a:off x="4133087" y="4334256"/>
+            <a:ext cx="3931921" cy="0"/>
+          </a:xfrm>
+          <a:prstGeom prst="line">
+            <a:avLst/>
+          </a:prstGeom>
+          <a:ln w="6350">
+            <a:solidFill>
+              <a:srgbClr val="D0CECE"/>
+            </a:solidFill>
+          </a:ln>
+        </p:spPr>
+        <p:style>
+          <a:lnRef idx="2">
+            <a:schemeClr val="accent1"/>
+          </a:lnRef>
+          <a:fillRef idx="0">
+            <a:schemeClr val="accent1"/>
+          </a:fillRef>
+          <a:effectRef idx="1">
+            <a:schemeClr val="accent1"/>
+          </a:effectRef>
+          <a:fontRef idx="minor">
+            <a:schemeClr val="tx1"/>
+          </a:fontRef>
+        </p:style>
+      </p:cxnSp>
+      <p:sp>
+        <p:nvSpPr>
+          <p:cNvPr id="67" name="TextBox 66"/>
           <p:cNvSpPr txBox="1"/>
           <p:nvPr/>
         </p:nvSpPr>
@@ -7773,14 +7682,14 @@
                 </a:solidFill>
                 <a:latin typeface="Arial"/>
               </a:rPr>
-              <a:t>93rd vs 99th</a:t>
-            </a:r>
-          </a:p>
-        </p:txBody>
-      </p:sp>
-      <p:sp>
-        <p:nvSpPr>
-          <p:cNvPr id="70" name="TextBox 69"/>
+              <a:t>6.8%</a:t>
+            </a:r>
+          </a:p>
+        </p:txBody>
+      </p:sp>
+      <p:sp>
+        <p:nvSpPr>
+          <p:cNvPr id="68" name="TextBox 67"/>
           <p:cNvSpPr txBox="1"/>
           <p:nvPr/>
         </p:nvSpPr>
@@ -7815,14 +7724,14 @@
                 </a:solidFill>
                 <a:latin typeface="Arial"/>
               </a:rPr>
-              <a:t>percentile since 2000, vs 2s30s</a:t>
-            </a:r>
-          </a:p>
-        </p:txBody>
-      </p:sp>
-      <p:sp>
-        <p:nvSpPr>
-          <p:cNvPr id="71" name="TextBox 70"/>
+              <a:t>of weeks since 2000 closed steeper</a:t>
+            </a:r>
+          </a:p>
+        </p:txBody>
+      </p:sp>
+      <p:sp>
+        <p:nvSpPr>
+          <p:cNvPr id="69" name="TextBox 68"/>
           <p:cNvSpPr txBox="1"/>
           <p:nvPr/>
         </p:nvSpPr>
@@ -7864,7 +7773,7 @@
       </p:sp>
       <p:sp>
         <p:nvSpPr>
-          <p:cNvPr id="72" name="TextBox 71"/>
+          <p:cNvPr id="70" name="TextBox 69"/>
           <p:cNvSpPr txBox="1"/>
           <p:nvPr/>
         </p:nvSpPr>
@@ -7906,7 +7815,7 @@
       </p:sp>
       <p:sp>
         <p:nvSpPr>
-          <p:cNvPr id="73" name="TextBox 72"/>
+          <p:cNvPr id="71" name="TextBox 70"/>
           <p:cNvSpPr txBox="1"/>
           <p:nvPr/>
         </p:nvSpPr>
@@ -7948,7 +7857,7 @@
       </p:sp>
       <p:sp>
         <p:nvSpPr>
-          <p:cNvPr id="74" name="TextBox 73"/>
+          <p:cNvPr id="72" name="TextBox 71"/>
           <p:cNvSpPr txBox="1"/>
           <p:nvPr/>
         </p:nvSpPr>
@@ -7990,7 +7899,7 @@
       </p:sp>
       <p:graphicFrame>
         <p:nvGraphicFramePr>
-          <p:cNvPr id="75" name="Chart 74"/>
+          <p:cNvPr id="73" name="Chart 72"/>
           <p:cNvGraphicFramePr>
             <a:graphicFrameLocks noGrp="1"/>
           </p:cNvGraphicFramePr>
@@ -8008,7 +7917,7 @@
       </p:graphicFrame>
       <p:sp>
         <p:nvSpPr>
-          <p:cNvPr id="76" name="TextBox 75"/>
+          <p:cNvPr id="74" name="TextBox 73"/>
           <p:cNvSpPr txBox="1"/>
           <p:nvPr/>
         </p:nvSpPr>
@@ -8050,7 +7959,7 @@
       </p:sp>
       <p:sp>
         <p:nvSpPr>
-          <p:cNvPr id="77" name="TextBox 76"/>
+          <p:cNvPr id="75" name="TextBox 74"/>
           <p:cNvSpPr txBox="1"/>
           <p:nvPr/>
         </p:nvSpPr>
@@ -8092,7 +8001,7 @@
       </p:sp>
       <p:sp>
         <p:nvSpPr>
-          <p:cNvPr id="78" name="TextBox 77"/>
+          <p:cNvPr id="76" name="TextBox 75"/>
           <p:cNvSpPr txBox="1"/>
           <p:nvPr/>
         </p:nvSpPr>
@@ -8134,7 +8043,7 @@
       </p:sp>
       <p:sp>
         <p:nvSpPr>
-          <p:cNvPr id="79" name="TextBox 78"/>
+          <p:cNvPr id="77" name="TextBox 76"/>
           <p:cNvSpPr txBox="1"/>
           <p:nvPr/>
         </p:nvSpPr>
@@ -8176,7 +8085,7 @@
       </p:sp>
       <p:sp>
         <p:nvSpPr>
-          <p:cNvPr id="80" name="TextBox 79"/>
+          <p:cNvPr id="78" name="TextBox 77"/>
           <p:cNvSpPr txBox="1"/>
           <p:nvPr/>
         </p:nvSpPr>
@@ -8218,7 +8127,7 @@
       </p:sp>
       <p:graphicFrame>
         <p:nvGraphicFramePr>
-          <p:cNvPr id="81" name="Table 80"/>
+          <p:cNvPr id="79" name="Table 78"/>
           <p:cNvGraphicFramePr>
             <a:graphicFrameLocks noGrp="1"/>
           </p:cNvGraphicFramePr>
@@ -8720,7 +8629,7 @@
       </p:graphicFrame>
       <p:sp>
         <p:nvSpPr>
-          <p:cNvPr id="82" name="TextBox 81"/>
+          <p:cNvPr id="80" name="TextBox 79"/>
           <p:cNvSpPr txBox="1"/>
           <p:nvPr/>
         </p:nvSpPr>
@@ -8762,7 +8671,7 @@
       </p:sp>
       <p:sp>
         <p:nvSpPr>
-          <p:cNvPr id="83" name="TextBox 82"/>
+          <p:cNvPr id="81" name="TextBox 80"/>
           <p:cNvSpPr txBox="1"/>
           <p:nvPr/>
         </p:nvSpPr>

</xml_diff>

<commit_message>
Measure the tenor comparison against our own projected curve
</commit_message>
<xml_diff>
--- a/JGB_2s10s_Steepener.pptx
+++ b/JGB_2s10s_Steepener.pptx
@@ -5820,7 +5820,7 @@
                 </a:solidFill>
                 <a:latin typeface="Arial"/>
               </a:rPr>
-              <a:t>Exhibit 5. 2s10s has 35bp of room to its high. The same 4bp round trip eats a third of what 2s30s has left</a:t>
+              <a:t>Exhibit 5. The same curve pays 30bp on 2s10s and 21bp on 2s30s, and only 2s30s needs a new record to do it</a:t>
             </a:r>
           </a:p>
         </p:txBody>
@@ -5862,7 +5862,7 @@
                 </a:solidFill>
                 <a:latin typeface="Arial"/>
               </a:rPr>
-              <a:t>Room from today to the high since 2000, bp of further steepening</a:t>
+              <a:t>Move on our projected curve, bp of steepening from today</a:t>
             </a:r>
           </a:p>
         </p:txBody>
@@ -6051,7 +6051,7 @@
         <p:spPr>
           <a:xfrm>
             <a:off x="5065775" y="2011680"/>
-            <a:ext cx="1866518" cy="201168"/>
+            <a:ext cx="1577339" cy="201168"/>
           </a:xfrm>
           <a:prstGeom prst="rect">
             <a:avLst/>
@@ -6134,8 +6134,8 @@
         </p:nvSpPr>
         <p:spPr>
           <a:xfrm>
-            <a:off x="6663690" y="1956816"/>
-            <a:ext cx="21945" cy="310896"/>
+            <a:off x="6921322" y="1947672"/>
+            <a:ext cx="21945" cy="329184"/>
           </a:xfrm>
           <a:prstGeom prst="rect">
             <a:avLst/>
@@ -6176,8 +6176,8 @@
         </p:nvSpPr>
         <p:spPr>
           <a:xfrm>
-            <a:off x="6217462" y="1732788"/>
-            <a:ext cx="914400" cy="173736"/>
+            <a:off x="6400800" y="1723644"/>
+            <a:ext cx="768096" cy="173736"/>
           </a:xfrm>
           <a:prstGeom prst="rect">
             <a:avLst/>
@@ -6205,7 +6205,7 @@
                 </a:solidFill>
                 <a:latin typeface="Arial"/>
               </a:rPr>
-              <a:t>target 160</a:t>
+              <a:t>165 record</a:t>
             </a:r>
           </a:p>
         </p:txBody>
@@ -6218,8 +6218,8 @@
         </p:nvSpPr>
         <p:spPr>
           <a:xfrm>
-            <a:off x="6978014" y="2016252"/>
-            <a:ext cx="868680" cy="182880"/>
+            <a:off x="4133087" y="2007107"/>
+            <a:ext cx="877824" cy="210312"/>
           </a:xfrm>
           <a:prstGeom prst="rect">
             <a:avLst/>
@@ -6241,48 +6241,6 @@
               </a:spcAft>
             </a:pPr>
             <a:r>
-              <a:rPr sz="750" b="0" i="0">
-                <a:solidFill>
-                  <a:srgbClr val="767576"/>
-                </a:solidFill>
-                <a:latin typeface="Arial"/>
-              </a:rPr>
-              <a:t>165 high</a:t>
-            </a:r>
-          </a:p>
-        </p:txBody>
-      </p:sp>
-      <p:sp>
-        <p:nvSpPr>
-          <p:cNvPr id="33" name="TextBox 32"/>
-          <p:cNvSpPr txBox="1"/>
-          <p:nvPr/>
-        </p:nvSpPr>
-        <p:spPr>
-          <a:xfrm>
-            <a:off x="4133087" y="2007107"/>
-            <a:ext cx="877824" cy="210312"/>
-          </a:xfrm>
-          <a:prstGeom prst="rect">
-            <a:avLst/>
-          </a:prstGeom>
-          <a:noFill/>
-        </p:spPr>
-        <p:txBody>
-          <a:bodyPr wrap="none" lIns="0" rIns="0" tIns="0" bIns="0" anchor="t">
-            <a:spAutoFit/>
-          </a:bodyPr>
-          <a:lstStyle/>
-          <a:p>
-            <a:pPr algn="l">
-              <a:lnSpc>
-                <a:spcPct val="100000"/>
-              </a:lnSpc>
-              <a:spcAft>
-                <a:spcPts val="0"/>
-              </a:spcAft>
-            </a:pPr>
-            <a:r>
               <a:rPr sz="1000" b="1" i="0">
                 <a:solidFill>
                   <a:srgbClr val="DB0011"/>
@@ -6296,14 +6254,14 @@
       </p:sp>
       <p:sp>
         <p:nvSpPr>
-          <p:cNvPr id="34" name="TextBox 33"/>
+          <p:cNvPr id="33" name="TextBox 32"/>
           <p:cNvSpPr txBox="1"/>
           <p:nvPr/>
         </p:nvSpPr>
         <p:spPr>
           <a:xfrm>
-            <a:off x="7168896" y="2007107"/>
-            <a:ext cx="987552" cy="210312"/>
+            <a:off x="7168896" y="1929384"/>
+            <a:ext cx="987552" cy="201168"/>
           </a:xfrm>
           <a:prstGeom prst="rect">
             <a:avLst/>
@@ -6325,13 +6283,55 @@
               </a:spcAft>
             </a:pPr>
             <a:r>
-              <a:rPr sz="1000" b="1" i="0">
+              <a:rPr sz="1050" b="1" i="0">
                 <a:solidFill>
                   <a:srgbClr val="DB0011"/>
                 </a:solidFill>
                 <a:latin typeface="Arial"/>
               </a:rPr>
-              <a:t>129bp · 93rd</a:t>
+              <a:t>+30bp</a:t>
+            </a:r>
+          </a:p>
+        </p:txBody>
+      </p:sp>
+      <p:sp>
+        <p:nvSpPr>
+          <p:cNvPr id="34" name="TextBox 33"/>
+          <p:cNvSpPr txBox="1"/>
+          <p:nvPr/>
+        </p:nvSpPr>
+        <p:spPr>
+          <a:xfrm>
+            <a:off x="7168896" y="2139696"/>
+            <a:ext cx="987552" cy="164592"/>
+          </a:xfrm>
+          <a:prstGeom prst="rect">
+            <a:avLst/>
+          </a:prstGeom>
+          <a:noFill/>
+        </p:spPr>
+        <p:txBody>
+          <a:bodyPr wrap="none" lIns="0" rIns="0" tIns="0" bIns="0" anchor="t">
+            <a:spAutoFit/>
+          </a:bodyPr>
+          <a:lstStyle/>
+          <a:p>
+            <a:pPr algn="r">
+              <a:lnSpc>
+                <a:spcPct val="100000"/>
+              </a:lnSpc>
+              <a:spcAft>
+                <a:spcPts val="0"/>
+              </a:spcAft>
+            </a:pPr>
+            <a:r>
+              <a:rPr sz="750" b="0" i="0">
+                <a:solidFill>
+                  <a:srgbClr val="767576"/>
+                </a:solidFill>
+                <a:latin typeface="Arial"/>
+              </a:rPr>
+              <a:t>129 → 159bp</a:t>
             </a:r>
           </a:p>
         </p:txBody>
@@ -6386,17 +6386,19 @@
         </p:nvSpPr>
         <p:spPr>
           <a:xfrm>
-            <a:off x="5065775" y="2688336"/>
-            <a:ext cx="210312" cy="201168"/>
+            <a:off x="5712485" y="2688336"/>
+            <a:ext cx="457428" cy="201168"/>
           </a:xfrm>
           <a:prstGeom prst="rect">
             <a:avLst/>
           </a:prstGeom>
           <a:solidFill>
-            <a:srgbClr val="6E747A"/>
+            <a:srgbClr val="FFFFFF"/>
           </a:solidFill>
-          <a:ln>
-            <a:noFill/>
+          <a:ln w="9525">
+            <a:solidFill>
+              <a:srgbClr val="DB0011"/>
+            </a:solidFill>
           </a:ln>
           <a:effectLst/>
         </p:spPr>
@@ -6428,14 +6430,14 @@
         </p:nvSpPr>
         <p:spPr>
           <a:xfrm>
-            <a:off x="5606872" y="2633472"/>
-            <a:ext cx="21945" cy="310896"/>
+            <a:off x="5065775" y="2688336"/>
+            <a:ext cx="210312" cy="201168"/>
           </a:xfrm>
           <a:prstGeom prst="rect">
             <a:avLst/>
           </a:prstGeom>
           <a:solidFill>
-            <a:srgbClr val="000000"/>
+            <a:srgbClr val="6E747A"/>
           </a:solidFill>
           <a:ln>
             <a:noFill/>
@@ -6464,14 +6466,56 @@
       </p:sp>
       <p:sp>
         <p:nvSpPr>
-          <p:cNvPr id="38" name="TextBox 37"/>
+          <p:cNvPr id="38" name="Rectangle 37"/>
+          <p:cNvSpPr/>
+          <p:nvPr/>
+        </p:nvSpPr>
+        <p:spPr>
+          <a:xfrm>
+            <a:off x="5701512" y="2624327"/>
+            <a:ext cx="21945" cy="329184"/>
+          </a:xfrm>
+          <a:prstGeom prst="rect">
+            <a:avLst/>
+          </a:prstGeom>
+          <a:solidFill>
+            <a:srgbClr val="000000"/>
+          </a:solidFill>
+          <a:ln>
+            <a:noFill/>
+          </a:ln>
+          <a:effectLst/>
+        </p:spPr>
+        <p:style>
+          <a:lnRef idx="1">
+            <a:schemeClr val="accent1"/>
+          </a:lnRef>
+          <a:fillRef idx="3">
+            <a:schemeClr val="accent1"/>
+          </a:fillRef>
+          <a:effectRef idx="2">
+            <a:schemeClr val="accent1"/>
+          </a:effectRef>
+          <a:fontRef idx="minor">
+            <a:schemeClr val="lt1"/>
+          </a:fontRef>
+        </p:style>
+        <p:txBody>
+          <a:bodyPr rtlCol="0" anchor="ctr"/>
+          <a:lstStyle/>
+          <a:p/>
+        </p:txBody>
+      </p:sp>
+      <p:sp>
+        <p:nvSpPr>
+          <p:cNvPr id="39" name="TextBox 38"/>
           <p:cNvSpPr txBox="1"/>
           <p:nvPr/>
         </p:nvSpPr>
         <p:spPr>
           <a:xfrm>
-            <a:off x="5160644" y="2409444"/>
-            <a:ext cx="914400" cy="173736"/>
+            <a:off x="5328437" y="2400300"/>
+            <a:ext cx="768096" cy="173736"/>
           </a:xfrm>
           <a:prstGeom prst="rect">
             <a:avLst/>
@@ -6499,21 +6543,21 @@
                 </a:solidFill>
                 <a:latin typeface="Arial"/>
               </a:rPr>
-              <a:t>target 258</a:t>
-            </a:r>
-          </a:p>
-        </p:txBody>
-      </p:sp>
-      <p:sp>
-        <p:nvSpPr>
-          <p:cNvPr id="39" name="TextBox 38"/>
+              <a:t>260 record</a:t>
+            </a:r>
+          </a:p>
+        </p:txBody>
+      </p:sp>
+      <p:sp>
+        <p:nvSpPr>
+          <p:cNvPr id="40" name="TextBox 39"/>
           <p:cNvSpPr txBox="1"/>
           <p:nvPr/>
         </p:nvSpPr>
         <p:spPr>
           <a:xfrm>
-            <a:off x="5758205" y="2692908"/>
-            <a:ext cx="868680" cy="182880"/>
+            <a:off x="4133087" y="2683763"/>
+            <a:ext cx="877824" cy="210312"/>
           </a:xfrm>
           <a:prstGeom prst="rect">
             <a:avLst/>
@@ -6535,48 +6579,6 @@
               </a:spcAft>
             </a:pPr>
             <a:r>
-              <a:rPr sz="750" b="0" i="0">
-                <a:solidFill>
-                  <a:srgbClr val="767576"/>
-                </a:solidFill>
-                <a:latin typeface="Arial"/>
-              </a:rPr>
-              <a:t>260 high</a:t>
-            </a:r>
-          </a:p>
-        </p:txBody>
-      </p:sp>
-      <p:sp>
-        <p:nvSpPr>
-          <p:cNvPr id="40" name="TextBox 39"/>
-          <p:cNvSpPr txBox="1"/>
-          <p:nvPr/>
-        </p:nvSpPr>
-        <p:spPr>
-          <a:xfrm>
-            <a:off x="4133087" y="2683763"/>
-            <a:ext cx="877824" cy="210312"/>
-          </a:xfrm>
-          <a:prstGeom prst="rect">
-            <a:avLst/>
-          </a:prstGeom>
-          <a:noFill/>
-        </p:spPr>
-        <p:txBody>
-          <a:bodyPr wrap="none" lIns="0" rIns="0" tIns="0" bIns="0" anchor="t">
-            <a:spAutoFit/>
-          </a:bodyPr>
-          <a:lstStyle/>
-          <a:p>
-            <a:pPr algn="l">
-              <a:lnSpc>
-                <a:spcPct val="100000"/>
-              </a:lnSpc>
-              <a:spcAft>
-                <a:spcPts val="0"/>
-              </a:spcAft>
-            </a:pPr>
-            <a:r>
               <a:rPr sz="1000" b="1" i="0">
                 <a:solidFill>
                   <a:srgbClr val="767576"/>
@@ -6596,8 +6598,8 @@
         </p:nvSpPr>
         <p:spPr>
           <a:xfrm>
-            <a:off x="7168896" y="2683763"/>
-            <a:ext cx="987552" cy="210312"/>
+            <a:off x="7168896" y="2606039"/>
+            <a:ext cx="987552" cy="201168"/>
           </a:xfrm>
           <a:prstGeom prst="rect">
             <a:avLst/>
@@ -6619,20 +6621,62 @@
               </a:spcAft>
             </a:pPr>
             <a:r>
-              <a:rPr sz="1000" b="0" i="0">
+              <a:rPr sz="1050" b="0" i="0">
                 <a:solidFill>
                   <a:srgbClr val="767576"/>
                 </a:solidFill>
                 <a:latin typeface="Arial"/>
               </a:rPr>
-              <a:t>248bp · 99th</a:t>
+              <a:t>+21bp</a:t>
+            </a:r>
+          </a:p>
+        </p:txBody>
+      </p:sp>
+      <p:sp>
+        <p:nvSpPr>
+          <p:cNvPr id="42" name="TextBox 41"/>
+          <p:cNvSpPr txBox="1"/>
+          <p:nvPr/>
+        </p:nvSpPr>
+        <p:spPr>
+          <a:xfrm>
+            <a:off x="7168896" y="2816351"/>
+            <a:ext cx="987552" cy="164592"/>
+          </a:xfrm>
+          <a:prstGeom prst="rect">
+            <a:avLst/>
+          </a:prstGeom>
+          <a:noFill/>
+        </p:spPr>
+        <p:txBody>
+          <a:bodyPr wrap="none" lIns="0" rIns="0" tIns="0" bIns="0" anchor="t">
+            <a:spAutoFit/>
+          </a:bodyPr>
+          <a:lstStyle/>
+          <a:p>
+            <a:pPr algn="r">
+              <a:lnSpc>
+                <a:spcPct val="100000"/>
+              </a:lnSpc>
+              <a:spcAft>
+                <a:spcPts val="0"/>
+              </a:spcAft>
+            </a:pPr>
+            <a:r>
+              <a:rPr sz="750" b="0" i="0">
+                <a:solidFill>
+                  <a:srgbClr val="767576"/>
+                </a:solidFill>
+                <a:latin typeface="Arial"/>
+              </a:rPr>
+              <a:t>248 → 268bp</a:t>
             </a:r>
           </a:p>
         </p:txBody>
       </p:sp>
       <p:cxnSp>
         <p:nvCxnSpPr>
-          <p:cNvPr id="42" name="Connector 41"/>
+          <p:cNvPr id="43" name="Connector 42"/>
           <p:cNvCxnSpPr/>
           <p:nvPr/>
         </p:nvCxnSpPr>
@@ -6667,7 +6711,7 @@
       </p:cxnSp>
       <p:sp>
         <p:nvSpPr>
-          <p:cNvPr id="43" name="TextBox 42"/>
+          <p:cNvPr id="44" name="TextBox 43"/>
           <p:cNvSpPr txBox="1"/>
           <p:nvPr/>
         </p:nvSpPr>
@@ -6709,7 +6753,7 @@
       </p:sp>
       <p:sp>
         <p:nvSpPr>
-          <p:cNvPr id="44" name="TextBox 43"/>
+          <p:cNvPr id="45" name="TextBox 44"/>
           <p:cNvSpPr txBox="1"/>
           <p:nvPr/>
         </p:nvSpPr>
@@ -6751,7 +6795,7 @@
       </p:sp>
       <p:sp>
         <p:nvSpPr>
-          <p:cNvPr id="45" name="TextBox 44"/>
+          <p:cNvPr id="46" name="TextBox 45"/>
           <p:cNvSpPr txBox="1"/>
           <p:nvPr/>
         </p:nvSpPr>
@@ -6793,7 +6837,7 @@
       </p:sp>
       <p:sp>
         <p:nvSpPr>
-          <p:cNvPr id="46" name="TextBox 45"/>
+          <p:cNvPr id="47" name="TextBox 46"/>
           <p:cNvSpPr txBox="1"/>
           <p:nvPr/>
         </p:nvSpPr>
@@ -6835,7 +6879,7 @@
       </p:sp>
       <p:sp>
         <p:nvSpPr>
-          <p:cNvPr id="47" name="TextBox 46"/>
+          <p:cNvPr id="48" name="TextBox 47"/>
           <p:cNvSpPr txBox="1"/>
           <p:nvPr/>
         </p:nvSpPr>
@@ -6877,13 +6921,13 @@
       </p:sp>
       <p:sp>
         <p:nvSpPr>
-          <p:cNvPr id="48" name="Rectangle 47"/>
+          <p:cNvPr id="49" name="Rectangle 48"/>
           <p:cNvSpPr/>
           <p:nvPr/>
         </p:nvSpPr>
         <p:spPr>
           <a:xfrm>
-            <a:off x="4133087" y="3406140"/>
+            <a:off x="4133087" y="3387851"/>
             <a:ext cx="182880" cy="100584"/>
           </a:xfrm>
           <a:prstGeom prst="rect">
@@ -6919,13 +6963,13 @@
       </p:sp>
       <p:sp>
         <p:nvSpPr>
-          <p:cNvPr id="49" name="TextBox 48"/>
+          <p:cNvPr id="50" name="TextBox 49"/>
           <p:cNvSpPr txBox="1"/>
           <p:nvPr/>
         </p:nvSpPr>
         <p:spPr>
           <a:xfrm>
-            <a:off x="4370831" y="3364992"/>
+            <a:off x="4370831" y="3346703"/>
             <a:ext cx="1737360" cy="182880"/>
           </a:xfrm>
           <a:prstGeom prst="rect">
@@ -6961,13 +7005,13 @@
       </p:sp>
       <p:sp>
         <p:nvSpPr>
-          <p:cNvPr id="50" name="Rectangle 49"/>
+          <p:cNvPr id="51" name="Rectangle 50"/>
           <p:cNvSpPr/>
           <p:nvPr/>
         </p:nvSpPr>
         <p:spPr>
           <a:xfrm>
-            <a:off x="6163056" y="3406140"/>
+            <a:off x="6163056" y="3387851"/>
             <a:ext cx="182880" cy="100584"/>
           </a:xfrm>
           <a:prstGeom prst="rect">
@@ -7003,13 +7047,13 @@
       </p:sp>
       <p:sp>
         <p:nvSpPr>
-          <p:cNvPr id="51" name="TextBox 50"/>
+          <p:cNvPr id="52" name="TextBox 51"/>
           <p:cNvSpPr txBox="1"/>
           <p:nvPr/>
         </p:nvSpPr>
         <p:spPr>
           <a:xfrm>
-            <a:off x="6400800" y="3364992"/>
+            <a:off x="6400800" y="3346703"/>
             <a:ext cx="1737360" cy="182880"/>
           </a:xfrm>
           <a:prstGeom prst="rect">
@@ -7038,14 +7082,100 @@
                 </a:solidFill>
                 <a:latin typeface="Arial"/>
               </a:rPr>
-              <a:t>Room to the high since 2000</a:t>
-            </a:r>
-          </a:p>
-        </p:txBody>
-      </p:sp>
-      <p:sp>
-        <p:nvSpPr>
-          <p:cNvPr id="52" name="TextBox 51"/>
+              <a:t>Move on our path</a:t>
+            </a:r>
+          </a:p>
+        </p:txBody>
+      </p:sp>
+      <p:sp>
+        <p:nvSpPr>
+          <p:cNvPr id="53" name="Rectangle 52"/>
+          <p:cNvSpPr/>
+          <p:nvPr/>
+        </p:nvSpPr>
+        <p:spPr>
+          <a:xfrm>
+            <a:off x="4133087" y="3561587"/>
+            <a:ext cx="182880" cy="100584"/>
+          </a:xfrm>
+          <a:prstGeom prst="rect">
+            <a:avLst/>
+          </a:prstGeom>
+          <a:solidFill>
+            <a:srgbClr val="FFFFFF"/>
+          </a:solidFill>
+          <a:ln w="9525">
+            <a:solidFill>
+              <a:srgbClr val="DB0011"/>
+            </a:solidFill>
+          </a:ln>
+          <a:effectLst/>
+        </p:spPr>
+        <p:style>
+          <a:lnRef idx="1">
+            <a:schemeClr val="accent1"/>
+          </a:lnRef>
+          <a:fillRef idx="3">
+            <a:schemeClr val="accent1"/>
+          </a:fillRef>
+          <a:effectRef idx="2">
+            <a:schemeClr val="accent1"/>
+          </a:effectRef>
+          <a:fontRef idx="minor">
+            <a:schemeClr val="lt1"/>
+          </a:fontRef>
+        </p:style>
+        <p:txBody>
+          <a:bodyPr rtlCol="0" anchor="ctr"/>
+          <a:lstStyle/>
+          <a:p/>
+        </p:txBody>
+      </p:sp>
+      <p:sp>
+        <p:nvSpPr>
+          <p:cNvPr id="54" name="TextBox 53"/>
+          <p:cNvSpPr txBox="1"/>
+          <p:nvPr/>
+        </p:nvSpPr>
+        <p:spPr>
+          <a:xfrm>
+            <a:off x="4370831" y="3520439"/>
+            <a:ext cx="1737360" cy="182880"/>
+          </a:xfrm>
+          <a:prstGeom prst="rect">
+            <a:avLst/>
+          </a:prstGeom>
+          <a:noFill/>
+        </p:spPr>
+        <p:txBody>
+          <a:bodyPr wrap="none" lIns="0" rIns="0" tIns="0" bIns="0" anchor="t">
+            <a:spAutoFit/>
+          </a:bodyPr>
+          <a:lstStyle/>
+          <a:p>
+            <a:pPr algn="l">
+              <a:lnSpc>
+                <a:spcPct val="100000"/>
+              </a:lnSpc>
+              <a:spcAft>
+                <a:spcPts val="0"/>
+              </a:spcAft>
+            </a:pPr>
+            <a:r>
+              <a:rPr sz="800" b="0" i="0">
+                <a:solidFill>
+                  <a:srgbClr val="767576"/>
+                </a:solidFill>
+                <a:latin typeface="Arial"/>
+              </a:rPr>
+              <a:t>Beyond the record since 2000</a:t>
+            </a:r>
+          </a:p>
+        </p:txBody>
+      </p:sp>
+      <p:sp>
+        <p:nvSpPr>
+          <p:cNvPr id="55" name="TextBox 54"/>
           <p:cNvSpPr txBox="1"/>
           <p:nvPr/>
         </p:nvSpPr>
@@ -7087,7 +7217,7 @@
       </p:sp>
       <p:sp>
         <p:nvSpPr>
-          <p:cNvPr id="53" name="TextBox 52"/>
+          <p:cNvPr id="56" name="TextBox 55"/>
           <p:cNvSpPr txBox="1"/>
           <p:nvPr/>
         </p:nvSpPr>
@@ -7129,7 +7259,7 @@
       </p:sp>
       <p:cxnSp>
         <p:nvCxnSpPr>
-          <p:cNvPr id="54" name="Connector 53"/>
+          <p:cNvPr id="57" name="Connector 56"/>
           <p:cNvCxnSpPr/>
           <p:nvPr/>
         </p:nvCxnSpPr>
@@ -7164,7 +7294,7 @@
       </p:cxnSp>
       <p:sp>
         <p:nvSpPr>
-          <p:cNvPr id="55" name="TextBox 54"/>
+          <p:cNvPr id="58" name="TextBox 57"/>
           <p:cNvSpPr txBox="1"/>
           <p:nvPr/>
         </p:nvSpPr>
@@ -7206,7 +7336,7 @@
       </p:sp>
       <p:sp>
         <p:nvSpPr>
-          <p:cNvPr id="56" name="TextBox 55"/>
+          <p:cNvPr id="59" name="TextBox 58"/>
           <p:cNvSpPr txBox="1"/>
           <p:nvPr/>
         </p:nvSpPr>
@@ -7248,7 +7378,7 @@
       </p:sp>
       <p:sp>
         <p:nvSpPr>
-          <p:cNvPr id="57" name="TextBox 56"/>
+          <p:cNvPr id="60" name="TextBox 59"/>
           <p:cNvSpPr txBox="1"/>
           <p:nvPr/>
         </p:nvSpPr>
@@ -7290,7 +7420,7 @@
       </p:sp>
       <p:cxnSp>
         <p:nvCxnSpPr>
-          <p:cNvPr id="58" name="Connector 57"/>
+          <p:cNvPr id="61" name="Connector 60"/>
           <p:cNvCxnSpPr/>
           <p:nvPr/>
         </p:nvCxnSpPr>
@@ -7325,7 +7455,7 @@
       </p:cxnSp>
       <p:sp>
         <p:nvSpPr>
-          <p:cNvPr id="59" name="TextBox 58"/>
+          <p:cNvPr id="62" name="TextBox 61"/>
           <p:cNvSpPr txBox="1"/>
           <p:nvPr/>
         </p:nvSpPr>
@@ -7367,7 +7497,7 @@
       </p:sp>
       <p:sp>
         <p:nvSpPr>
-          <p:cNvPr id="60" name="TextBox 59"/>
+          <p:cNvPr id="63" name="TextBox 62"/>
           <p:cNvSpPr txBox="1"/>
           <p:nvPr/>
         </p:nvSpPr>
@@ -7409,7 +7539,7 @@
       </p:sp>
       <p:sp>
         <p:nvSpPr>
-          <p:cNvPr id="61" name="TextBox 60"/>
+          <p:cNvPr id="64" name="TextBox 63"/>
           <p:cNvSpPr txBox="1"/>
           <p:nvPr/>
         </p:nvSpPr>
@@ -7451,7 +7581,7 @@
       </p:sp>
       <p:cxnSp>
         <p:nvCxnSpPr>
-          <p:cNvPr id="62" name="Connector 61"/>
+          <p:cNvPr id="65" name="Connector 64"/>
           <p:cNvCxnSpPr/>
           <p:nvPr/>
         </p:nvCxnSpPr>
@@ -7486,7 +7616,7 @@
       </p:cxnSp>
       <p:sp>
         <p:nvSpPr>
-          <p:cNvPr id="63" name="TextBox 62"/>
+          <p:cNvPr id="66" name="TextBox 65"/>
           <p:cNvSpPr txBox="1"/>
           <p:nvPr/>
         </p:nvSpPr>
@@ -7528,7 +7658,7 @@
       </p:sp>
       <p:sp>
         <p:nvSpPr>
-          <p:cNvPr id="64" name="TextBox 63"/>
+          <p:cNvPr id="67" name="TextBox 66"/>
           <p:cNvSpPr txBox="1"/>
           <p:nvPr/>
         </p:nvSpPr>
@@ -7570,7 +7700,7 @@
       </p:sp>
       <p:sp>
         <p:nvSpPr>
-          <p:cNvPr id="65" name="TextBox 64"/>
+          <p:cNvPr id="68" name="TextBox 67"/>
           <p:cNvSpPr txBox="1"/>
           <p:nvPr/>
         </p:nvSpPr>
@@ -7612,7 +7742,7 @@
       </p:sp>
       <p:cxnSp>
         <p:nvCxnSpPr>
-          <p:cNvPr id="66" name="Connector 65"/>
+          <p:cNvPr id="69" name="Connector 68"/>
           <p:cNvCxnSpPr/>
           <p:nvPr/>
         </p:nvCxnSpPr>
@@ -7647,7 +7777,7 @@
       </p:cxnSp>
       <p:sp>
         <p:nvSpPr>
-          <p:cNvPr id="67" name="TextBox 66"/>
+          <p:cNvPr id="70" name="TextBox 69"/>
           <p:cNvSpPr txBox="1"/>
           <p:nvPr/>
         </p:nvSpPr>
@@ -7689,7 +7819,7 @@
       </p:sp>
       <p:sp>
         <p:nvSpPr>
-          <p:cNvPr id="68" name="TextBox 67"/>
+          <p:cNvPr id="71" name="TextBox 70"/>
           <p:cNvSpPr txBox="1"/>
           <p:nvPr/>
         </p:nvSpPr>
@@ -7731,7 +7861,7 @@
       </p:sp>
       <p:sp>
         <p:nvSpPr>
-          <p:cNvPr id="69" name="TextBox 68"/>
+          <p:cNvPr id="72" name="TextBox 71"/>
           <p:cNvSpPr txBox="1"/>
           <p:nvPr/>
         </p:nvSpPr>
@@ -7773,7 +7903,7 @@
       </p:sp>
       <p:sp>
         <p:nvSpPr>
-          <p:cNvPr id="70" name="TextBox 69"/>
+          <p:cNvPr id="73" name="TextBox 72"/>
           <p:cNvSpPr txBox="1"/>
           <p:nvPr/>
         </p:nvSpPr>
@@ -7815,7 +7945,7 @@
       </p:sp>
       <p:sp>
         <p:nvSpPr>
-          <p:cNvPr id="71" name="TextBox 70"/>
+          <p:cNvPr id="74" name="TextBox 73"/>
           <p:cNvSpPr txBox="1"/>
           <p:nvPr/>
         </p:nvSpPr>
@@ -7857,7 +7987,7 @@
       </p:sp>
       <p:sp>
         <p:nvSpPr>
-          <p:cNvPr id="72" name="TextBox 71"/>
+          <p:cNvPr id="75" name="TextBox 74"/>
           <p:cNvSpPr txBox="1"/>
           <p:nvPr/>
         </p:nvSpPr>
@@ -7899,7 +8029,7 @@
       </p:sp>
       <p:graphicFrame>
         <p:nvGraphicFramePr>
-          <p:cNvPr id="73" name="Chart 72"/>
+          <p:cNvPr id="76" name="Chart 75"/>
           <p:cNvGraphicFramePr>
             <a:graphicFrameLocks noGrp="1"/>
           </p:cNvGraphicFramePr>
@@ -7917,7 +8047,7 @@
       </p:graphicFrame>
       <p:sp>
         <p:nvSpPr>
-          <p:cNvPr id="74" name="TextBox 73"/>
+          <p:cNvPr id="77" name="TextBox 76"/>
           <p:cNvSpPr txBox="1"/>
           <p:nvPr/>
         </p:nvSpPr>
@@ -7959,7 +8089,7 @@
       </p:sp>
       <p:sp>
         <p:nvSpPr>
-          <p:cNvPr id="75" name="TextBox 74"/>
+          <p:cNvPr id="78" name="TextBox 77"/>
           <p:cNvSpPr txBox="1"/>
           <p:nvPr/>
         </p:nvSpPr>
@@ -8001,7 +8131,7 @@
       </p:sp>
       <p:sp>
         <p:nvSpPr>
-          <p:cNvPr id="76" name="TextBox 75"/>
+          <p:cNvPr id="79" name="TextBox 78"/>
           <p:cNvSpPr txBox="1"/>
           <p:nvPr/>
         </p:nvSpPr>
@@ -8043,7 +8173,7 @@
       </p:sp>
       <p:sp>
         <p:nvSpPr>
-          <p:cNvPr id="77" name="TextBox 76"/>
+          <p:cNvPr id="80" name="TextBox 79"/>
           <p:cNvSpPr txBox="1"/>
           <p:nvPr/>
         </p:nvSpPr>
@@ -8085,7 +8215,7 @@
       </p:sp>
       <p:sp>
         <p:nvSpPr>
-          <p:cNvPr id="78" name="TextBox 77"/>
+          <p:cNvPr id="81" name="TextBox 80"/>
           <p:cNvSpPr txBox="1"/>
           <p:nvPr/>
         </p:nvSpPr>
@@ -8127,7 +8257,7 @@
       </p:sp>
       <p:graphicFrame>
         <p:nvGraphicFramePr>
-          <p:cNvPr id="79" name="Table 78"/>
+          <p:cNvPr id="82" name="Table 81"/>
           <p:cNvGraphicFramePr>
             <a:graphicFrameLocks noGrp="1"/>
           </p:cNvGraphicFramePr>
@@ -8629,7 +8759,7 @@
       </p:graphicFrame>
       <p:sp>
         <p:nvSpPr>
-          <p:cNvPr id="80" name="TextBox 79"/>
+          <p:cNvPr id="83" name="TextBox 82"/>
           <p:cNvSpPr txBox="1"/>
           <p:nvPr/>
         </p:nvSpPr>
@@ -8671,7 +8801,7 @@
       </p:sp>
       <p:sp>
         <p:nvSpPr>
-          <p:cNvPr id="81" name="TextBox 80"/>
+          <p:cNvPr id="84" name="TextBox 83"/>
           <p:cNvSpPr txBox="1"/>
           <p:nvPr/>
         </p:nvSpPr>

</xml_diff>